<commit_message>
Rewrite film narration as synthesis and rebuild the five films
The narration check from narrated-deck-film found four of the five films repeating their slides'
wording: up to 39% of a slide's narration, and 23% on average for the tape-in film. Thirty-five
slide narrations are rewritten to say what each slide means instead. All five films now average
1.7-6.0% repeated wording, with no slide over 18%, and every line makes a point rather than
listing.

The films are re-voiced with Kokoro in the Holt profile, with per-slide speeds set from measured
pace, and recut on the same chapters. Overall pace is 148.7-153.6 words per minute. The decks'
speaker notes carry the new narration; the slides themselves are unchanged apart from per-build
IDs, and every deck check passes again.

Co-Authored-By: Claude Opus 5 <noreply@anthropic.com>
Claude-Session: https://claude.ai/code/session_01T6cQ2zmGzUx1Wop9BfR8h3
</commit_message>
<xml_diff>
--- a/public/downloads/dg32-2dom-datasheet.pptx
+++ b/public/downloads/dg32-2dom-datasheet.pptx
@@ -2,21 +2,21 @@
 <file path=ppt/presentation.xml><?xml version="1.0" encoding="utf-8"?>
 <p:presentation xmlns:p="http://schemas.openxmlformats.org/presentationml/2006/main">
   <p:sldMasterIdLst>
-    <p:sldMasterId xmlns:r="http://schemas.openxmlformats.org/officeDocument/2006/relationships" id="2147483648" r:id="Rd4ba064c5a6b41fc"/>
+    <p:sldMasterId xmlns:r="http://schemas.openxmlformats.org/officeDocument/2006/relationships" id="2147483648" r:id="Rdce16721685c4d7e"/>
   </p:sldMasterIdLst>
   <p:notesMasterIdLst>
-    <p:notesMasterId xmlns:r="http://schemas.openxmlformats.org/officeDocument/2006/relationships" r:id="R72d8ea62fb68470a"/>
+    <p:notesMasterId xmlns:r="http://schemas.openxmlformats.org/officeDocument/2006/relationships" r:id="R87c8343e77814a8e"/>
   </p:notesMasterIdLst>
   <p:sldIdLst>
-    <p:sldId xmlns:r="http://schemas.openxmlformats.org/officeDocument/2006/relationships" id="256" r:id="R66ae8254172344d6"/>
-    <p:sldId xmlns:r="http://schemas.openxmlformats.org/officeDocument/2006/relationships" id="257" r:id="R69e8d9db436d441f"/>
-    <p:sldId xmlns:r="http://schemas.openxmlformats.org/officeDocument/2006/relationships" id="258" r:id="Rd920f3edcac54a65"/>
-    <p:sldId xmlns:r="http://schemas.openxmlformats.org/officeDocument/2006/relationships" id="259" r:id="Rb5542e61d6ca4dd7"/>
-    <p:sldId xmlns:r="http://schemas.openxmlformats.org/officeDocument/2006/relationships" id="260" r:id="R45b442d05a2143d5"/>
-    <p:sldId xmlns:r="http://schemas.openxmlformats.org/officeDocument/2006/relationships" id="261" r:id="R973ecd57d3924f9d"/>
-    <p:sldId xmlns:r="http://schemas.openxmlformats.org/officeDocument/2006/relationships" id="262" r:id="R87f4ba92047b432a"/>
-    <p:sldId xmlns:r="http://schemas.openxmlformats.org/officeDocument/2006/relationships" id="263" r:id="R6224935d67654aa9"/>
-    <p:sldId xmlns:r="http://schemas.openxmlformats.org/officeDocument/2006/relationships" id="264" r:id="R6f3177094b564052"/>
+    <p:sldId xmlns:r="http://schemas.openxmlformats.org/officeDocument/2006/relationships" id="256" r:id="R3faff1aba45d4107"/>
+    <p:sldId xmlns:r="http://schemas.openxmlformats.org/officeDocument/2006/relationships" id="257" r:id="R583a03c8bf6d4076"/>
+    <p:sldId xmlns:r="http://schemas.openxmlformats.org/officeDocument/2006/relationships" id="258" r:id="Rc066512662fd452a"/>
+    <p:sldId xmlns:r="http://schemas.openxmlformats.org/officeDocument/2006/relationships" id="259" r:id="Rcd763b6825f94780"/>
+    <p:sldId xmlns:r="http://schemas.openxmlformats.org/officeDocument/2006/relationships" id="260" r:id="Rfa7cc57e5f7942ce"/>
+    <p:sldId xmlns:r="http://schemas.openxmlformats.org/officeDocument/2006/relationships" id="261" r:id="Rb1cfad3ce89a4957"/>
+    <p:sldId xmlns:r="http://schemas.openxmlformats.org/officeDocument/2006/relationships" id="262" r:id="Ra01102663fe34c96"/>
+    <p:sldId xmlns:r="http://schemas.openxmlformats.org/officeDocument/2006/relationships" id="263" r:id="R3e2396350abb4a78"/>
+    <p:sldId xmlns:r="http://schemas.openxmlformats.org/officeDocument/2006/relationships" id="264" r:id="R05b441c5b3644d43"/>
   </p:sldIdLst>
   <p:sldSz cx="12192000" cy="6858000"/>
   <p:notesSz cx="6858000" cy="9144000"/>
@@ -520,7 +520,7 @@
           <a:lstStyle xmlns:a="http://schemas.openxmlformats.org/drawingml/2006/main"/>
           <a:p xmlns:a="http://schemas.openxmlformats.org/drawingml/2006/main">
             <a:r>
-              <a:t>Here is the short version. The same sixty-four pins and forty-four signals. The same one point eight and three point three volt rails. One added clock: the engine runs at one hundred fourteen megahertz, beside the fifty megahertz control domain. For a board, DG32-2DOM is a drop-in DG32-LITE. For firmware, it adds one memory-mapped engine.</a:t>
+              <a:t>If you have designed with DG32-LITE, most of this is already familiar. The package, the sixty-four pins and the forty-four signals do not move, and neither do the one point eight and three point three volt supplies. What is new is a second clock at one hundred fourteen megahertz, driving the engine beside the fifty megahertz CPU. A board designer sees the same chip; only the firmware sees something extra.</a:t>
             </a:r>
           </a:p>
         </p:txBody>
@@ -590,7 +590,7 @@
           <a:lstStyle xmlns:a="http://schemas.openxmlformats.org/drawingml/2006/main"/>
           <a:p xmlns:a="http://schemas.openxmlformats.org/drawingml/2006/main">
             <a:r>
-              <a:t>The datasheet lists five new features. An attention accelerator that computes a band of query rows in one kick, bit-exact to the golden model. A shared datapath with a weight table and a forty-bit numerator. A cost of about thirty-two hundred cycles per row, by analysis. A second clock domain. And a larger die of its own.</a:t>
+              <a:t>Only five entries in the feature list are new, and all of them exist because of the engine. It computes a whole span of rows for an attention head each time it is started, and its results match the reference software exactly. One shared multiplier and a small weight table keep that hardware compact. Each row costs about thirty-two hundred cycles by analysis. And the engine brings its own faster clock, plus a larger die to hold its buffers.</a:t>
             </a:r>
           </a:p>
         </p:txBody>
@@ -730,7 +730,7 @@
           <a:lstStyle xmlns:a="http://schemas.openxmlformats.org/drawingml/2006/main"/>
           <a:p xmlns:a="http://schemas.openxmlformats.org/drawingml/2006/main">
             <a:r>
-              <a:t>The engine runs on a second clock, at one hundred fourteen megahertz. The CPU, the bus and the peripherals stay at fifty, so the control core's timing is untouched. The engine reaches memory through two-flop clock bridges, so it never stalls the control core. Timing closes with positive slack at both clocks, on a die of three point four by four point five millimetres.</a:t>
+              <a:t>Why give the engine a clock of its own? Speeding up the whole chip would push the lockstep core past its timing limit, so the processor, the bus and all of the peripherals stay at fifty megahertz while the engine runs at one hundred fourteen. The two sides meet only through synchronised bridges, which means the engine can never hold up control. After layout, both clocks meet timing with positive slack.</a:t>
             </a:r>
           </a:p>
         </p:txBody>
@@ -800,7 +800,7 @@
           <a:lstStyle xmlns:a="http://schemas.openxmlformats.org/drawingml/2006/main"/>
           <a:p xmlns:a="http://schemas.openxmlformats.org/drawingml/2006/main">
             <a:r>
-              <a:t>Firmware drives the engine in four steps. Tell it where the query, key, value and output buffers live. Set the geometry: rows, keys, and the key and value sizes. Set start, optionally reusing the buffers already loaded. Then poll for done, or take the engine's interrupt. The engine also reports a rejected geometry or an arithmetic overflow.</a:t>
+              <a:t>From firmware, running the engine takes four moves. Point it at the memory holding its inputs and where its results should go. Describe the shape of the job: how many rows and keys, and how wide each vector is. Start it, reusing anything still loaded from last time if that saves work. Then wait, by polling or with an interrupt. If the job is shaped wrongly or the arithmetic would overflow, the engine says so.</a:t>
             </a:r>
           </a:p>
         </p:txBody>
@@ -870,7 +870,7 @@
           <a:lstStyle xmlns:a="http://schemas.openxmlformats.org/drawingml/2006/main"/>
           <a:p xmlns:a="http://schemas.openxmlformats.org/drawingml/2006/main">
             <a:r>
-              <a:t>Its limits are fixed in the silicon. Up to sixty-five thousand five hundred thirty-five query rows per kick, and up to four hundred keys per head. Key vectors up to thirty-two bytes, and value vectors up to sixty-four. Sixteen multiply lanes, a two-hundred-fifty-six entry weight table, and a forty-bit numerator that stays exact to one hundred thirty-one thousand keys.</a:t>
+              <a:t>The engine's limits are set in silicon, so a model has to fit them rather than the other way round. One start covers up to sixty-five thousand five hundred thirty-five query rows, and each head can hold up to four hundred keys. Keys can be thirty-two bytes wide and values sixty-four. Sixteen multiply lanes, a two-hundred-fifty-six entry weight table and a forty-bit numerator keep the result exact up to one hundred thirty-one thousand keys.</a:t>
             </a:r>
           </a:p>
         </p:txBody>
@@ -1010,7 +1010,7 @@
           <a:lstStyle xmlns:a="http://schemas.openxmlformats.org/drawingml/2006/main"/>
           <a:p xmlns:a="http://schemas.openxmlformats.org/drawingml/2006/main">
             <a:r>
-              <a:t>Three things to take away. The board is a DG32-LITE board. The engine is one memory-mapped block on its own clock that cannot stall control. And its limits are already fixed: four hundred keys, sixty-four-byte values, and about thirty-two hundred cycles per row. First silicon turns these design values into measurements.</a:t>
+              <a:t>Here is what matters for a design team. Any board laid out for DG32-LITE already fits DG32-2DOM. The new engine runs from a separate, faster clock and can never hold up motor control. And its limits are settled today, at four hundred keys, values of sixty-four bytes and roughly thirty-two hundred cycles per row, by analysis. Real measurements arrive with first silicon.</a:t>
             </a:r>
           </a:p>
         </p:txBody>
@@ -1078,7 +1078,7 @@
   </p:cSld>
   <p:clrMap bg1="lt1" tx1="dk1" bg2="lt2" tx2="dk2" accent1="accent1" accent2="accent2" accent3="accent3" accent4="accent4" accent5="accent5" accent6="accent6" hlink="hlink" folHlink="folHlink"/>
   <p:sldLayoutIdLst>
-    <p:sldLayoutId xmlns:r="http://schemas.openxmlformats.org/officeDocument/2006/relationships" id="2147483649" r:id="Rbd1d56187a0e4a06"/>
+    <p:sldLayoutId xmlns:r="http://schemas.openxmlformats.org/officeDocument/2006/relationships" id="2147483649" r:id="R4555638b148243a7"/>
   </p:sldLayoutIdLst>
   <p:txStyles>
     <p:titleStyle>
@@ -1622,7 +1622,7 @@
           <p:cNvPr id="105" name="">
             <a:extLst xmlns:a="http://schemas.openxmlformats.org/drawingml/2006/main">
               <a:ext uri="{FF2B5EF4-FFF2-40B4-BE49-F238E27FC236}">
-                <a16:creationId xmlns:a16="http://schemas.microsoft.com/office/drawing/2014/main" id="{665D4F92-E85A-43EE-84FF-2B12A3B03D2F}"/>
+                <a16:creationId xmlns:a16="http://schemas.microsoft.com/office/drawing/2014/main" id="{E01D0589-AF7E-4A44-9DF3-F60A820CB0EF}"/>
               </a:ext>
             </a:extLst>
           </p:cNvPr>
@@ -1653,7 +1653,7 @@
           <p:cNvPr id="2" name="">
             <a:extLst xmlns:a="http://schemas.openxmlformats.org/drawingml/2006/main">
               <a:ext uri="{FF2B5EF4-FFF2-40B4-BE49-F238E27FC236}">
-                <a16:creationId xmlns:a16="http://schemas.microsoft.com/office/drawing/2014/main" id="{1BE18714-DF09-4D48-8E58-CBDDC5BA4E2D}"/>
+                <a16:creationId xmlns:a16="http://schemas.microsoft.com/office/drawing/2014/main" id="{D38EA8EB-9A0E-4F75-B2BC-C36DC0741F90}"/>
               </a:ext>
             </a:extLst>
           </p:cNvPr>
@@ -1698,7 +1698,7 @@
           <p:cNvPr id="3" name="">
             <a:extLst xmlns:a="http://schemas.openxmlformats.org/drawingml/2006/main">
               <a:ext uri="{FF2B5EF4-FFF2-40B4-BE49-F238E27FC236}">
-                <a16:creationId xmlns:a16="http://schemas.microsoft.com/office/drawing/2014/main" id="{69F76A1D-E619-444C-ABCE-4FC2F7A2B303}"/>
+                <a16:creationId xmlns:a16="http://schemas.microsoft.com/office/drawing/2014/main" id="{3DBA215E-C367-47D0-87E3-87089F43CE3E}"/>
               </a:ext>
             </a:extLst>
           </p:cNvPr>
@@ -1743,7 +1743,7 @@
           <p:cNvPr id="4" name="">
             <a:extLst xmlns:a="http://schemas.openxmlformats.org/drawingml/2006/main">
               <a:ext uri="{FF2B5EF4-FFF2-40B4-BE49-F238E27FC236}">
-                <a16:creationId xmlns:a16="http://schemas.microsoft.com/office/drawing/2014/main" id="{DFDFEF46-8DCC-4D40-BF4C-F6987C36653F}"/>
+                <a16:creationId xmlns:a16="http://schemas.microsoft.com/office/drawing/2014/main" id="{C79C562E-642E-4D54-82E0-E9A62459EF66}"/>
               </a:ext>
             </a:extLst>
           </p:cNvPr>
@@ -1774,7 +1774,7 @@
           <p:cNvPr id="5" name="">
             <a:extLst xmlns:a="http://schemas.openxmlformats.org/drawingml/2006/main">
               <a:ext uri="{FF2B5EF4-FFF2-40B4-BE49-F238E27FC236}">
-                <a16:creationId xmlns:a16="http://schemas.microsoft.com/office/drawing/2014/main" id="{32B225A0-E64C-46BB-BF46-8FE8754BE007}"/>
+                <a16:creationId xmlns:a16="http://schemas.microsoft.com/office/drawing/2014/main" id="{BE8FBDF4-3367-441D-B949-A8DF1CB07E95}"/>
               </a:ext>
             </a:extLst>
           </p:cNvPr>
@@ -1819,7 +1819,7 @@
           <p:cNvPr id="6" name="">
             <a:extLst xmlns:a="http://schemas.openxmlformats.org/drawingml/2006/main">
               <a:ext uri="{FF2B5EF4-FFF2-40B4-BE49-F238E27FC236}">
-                <a16:creationId xmlns:a16="http://schemas.microsoft.com/office/drawing/2014/main" id="{1EFE1F7E-5AAB-459B-8EDD-C04F8839CABE}"/>
+                <a16:creationId xmlns:a16="http://schemas.microsoft.com/office/drawing/2014/main" id="{541F0171-A9C6-4CE9-A2B2-4286495AC7BE}"/>
               </a:ext>
             </a:extLst>
           </p:cNvPr>
@@ -1852,7 +1852,7 @@
           <p:cNvPr id="7" name="">
             <a:extLst xmlns:a="http://schemas.openxmlformats.org/drawingml/2006/main">
               <a:ext uri="{FF2B5EF4-FFF2-40B4-BE49-F238E27FC236}">
-                <a16:creationId xmlns:a16="http://schemas.microsoft.com/office/drawing/2014/main" id="{B02CA40E-85D2-442E-80A2-A9A90752ACB8}"/>
+                <a16:creationId xmlns:a16="http://schemas.microsoft.com/office/drawing/2014/main" id="{8CCB0EFE-DABF-4694-A07E-22F5418D88C0}"/>
               </a:ext>
             </a:extLst>
           </p:cNvPr>
@@ -1883,7 +1883,7 @@
           <p:cNvPr id="8" name="">
             <a:extLst xmlns:a="http://schemas.openxmlformats.org/drawingml/2006/main">
               <a:ext uri="{FF2B5EF4-FFF2-40B4-BE49-F238E27FC236}">
-                <a16:creationId xmlns:a16="http://schemas.microsoft.com/office/drawing/2014/main" id="{A363C046-44A6-4A9C-9C08-E298A0313BC5}"/>
+                <a16:creationId xmlns:a16="http://schemas.microsoft.com/office/drawing/2014/main" id="{C32A5EB7-5F4C-4FD8-ACDC-B9FABEF68D5B}"/>
               </a:ext>
             </a:extLst>
           </p:cNvPr>
@@ -1914,7 +1914,7 @@
           <p:cNvPr id="9" name="">
             <a:extLst xmlns:a="http://schemas.openxmlformats.org/drawingml/2006/main">
               <a:ext uri="{FF2B5EF4-FFF2-40B4-BE49-F238E27FC236}">
-                <a16:creationId xmlns:a16="http://schemas.microsoft.com/office/drawing/2014/main" id="{30433F61-7BA2-4E09-8136-589A99A8D309}"/>
+                <a16:creationId xmlns:a16="http://schemas.microsoft.com/office/drawing/2014/main" id="{2E4E937E-03D3-482B-A6C5-83C1A3C183E0}"/>
               </a:ext>
             </a:extLst>
           </p:cNvPr>
@@ -1945,7 +1945,7 @@
           <p:cNvPr id="10" name="">
             <a:extLst xmlns:a="http://schemas.openxmlformats.org/drawingml/2006/main">
               <a:ext uri="{FF2B5EF4-FFF2-40B4-BE49-F238E27FC236}">
-                <a16:creationId xmlns:a16="http://schemas.microsoft.com/office/drawing/2014/main" id="{8333D5EE-EFE8-4AAD-BB04-C0B3A7214454}"/>
+                <a16:creationId xmlns:a16="http://schemas.microsoft.com/office/drawing/2014/main" id="{02D4ED0E-E43F-42B4-BC96-F10645E34D49}"/>
               </a:ext>
             </a:extLst>
           </p:cNvPr>
@@ -1976,7 +1976,7 @@
           <p:cNvPr id="11" name="">
             <a:extLst xmlns:a="http://schemas.openxmlformats.org/drawingml/2006/main">
               <a:ext uri="{FF2B5EF4-FFF2-40B4-BE49-F238E27FC236}">
-                <a16:creationId xmlns:a16="http://schemas.microsoft.com/office/drawing/2014/main" id="{B66E9F52-C938-4893-A212-B1D3422CEE09}"/>
+                <a16:creationId xmlns:a16="http://schemas.microsoft.com/office/drawing/2014/main" id="{E28B7DE9-A255-404F-9D5C-79BB04BB8F38}"/>
               </a:ext>
             </a:extLst>
           </p:cNvPr>
@@ -2007,7 +2007,7 @@
           <p:cNvPr id="12" name="">
             <a:extLst xmlns:a="http://schemas.openxmlformats.org/drawingml/2006/main">
               <a:ext uri="{FF2B5EF4-FFF2-40B4-BE49-F238E27FC236}">
-                <a16:creationId xmlns:a16="http://schemas.microsoft.com/office/drawing/2014/main" id="{A2DEFE24-E71E-4944-B235-3E3D5ED3886A}"/>
+                <a16:creationId xmlns:a16="http://schemas.microsoft.com/office/drawing/2014/main" id="{EEEC16ED-4764-4662-B51A-CFE72178AB9D}"/>
               </a:ext>
             </a:extLst>
           </p:cNvPr>
@@ -2038,7 +2038,7 @@
           <p:cNvPr id="13" name="">
             <a:extLst xmlns:a="http://schemas.openxmlformats.org/drawingml/2006/main">
               <a:ext uri="{FF2B5EF4-FFF2-40B4-BE49-F238E27FC236}">
-                <a16:creationId xmlns:a16="http://schemas.microsoft.com/office/drawing/2014/main" id="{1B6FD358-3696-49DE-9D6C-D2E40F75DEA3}"/>
+                <a16:creationId xmlns:a16="http://schemas.microsoft.com/office/drawing/2014/main" id="{5E624745-F55E-4B7C-8BF3-4C585C0E6E3C}"/>
               </a:ext>
             </a:extLst>
           </p:cNvPr>
@@ -2069,7 +2069,7 @@
           <p:cNvPr id="14" name="">
             <a:extLst xmlns:a="http://schemas.openxmlformats.org/drawingml/2006/main">
               <a:ext uri="{FF2B5EF4-FFF2-40B4-BE49-F238E27FC236}">
-                <a16:creationId xmlns:a16="http://schemas.microsoft.com/office/drawing/2014/main" id="{F04AAFFE-40D2-407C-919C-ED1657EF3620}"/>
+                <a16:creationId xmlns:a16="http://schemas.microsoft.com/office/drawing/2014/main" id="{EC5CFB09-03F6-4DD7-83BB-45FC619C5338}"/>
               </a:ext>
             </a:extLst>
           </p:cNvPr>
@@ -2100,7 +2100,7 @@
           <p:cNvPr id="15" name="">
             <a:extLst xmlns:a="http://schemas.openxmlformats.org/drawingml/2006/main">
               <a:ext uri="{FF2B5EF4-FFF2-40B4-BE49-F238E27FC236}">
-                <a16:creationId xmlns:a16="http://schemas.microsoft.com/office/drawing/2014/main" id="{427205DC-9AE1-416C-88A6-D99EFA2FAB1D}"/>
+                <a16:creationId xmlns:a16="http://schemas.microsoft.com/office/drawing/2014/main" id="{C04306BE-9A89-498E-8C07-43E6C87099D2}"/>
               </a:ext>
             </a:extLst>
           </p:cNvPr>
@@ -2131,7 +2131,7 @@
           <p:cNvPr id="16" name="">
             <a:extLst xmlns:a="http://schemas.openxmlformats.org/drawingml/2006/main">
               <a:ext uri="{FF2B5EF4-FFF2-40B4-BE49-F238E27FC236}">
-                <a16:creationId xmlns:a16="http://schemas.microsoft.com/office/drawing/2014/main" id="{22655FEA-ADFA-49F5-BC10-8B6D142E5718}"/>
+                <a16:creationId xmlns:a16="http://schemas.microsoft.com/office/drawing/2014/main" id="{A5AB1941-100E-4D25-AB25-6F823327839C}"/>
               </a:ext>
             </a:extLst>
           </p:cNvPr>
@@ -2162,7 +2162,7 @@
           <p:cNvPr id="17" name="">
             <a:extLst xmlns:a="http://schemas.openxmlformats.org/drawingml/2006/main">
               <a:ext uri="{FF2B5EF4-FFF2-40B4-BE49-F238E27FC236}">
-                <a16:creationId xmlns:a16="http://schemas.microsoft.com/office/drawing/2014/main" id="{3615402B-59CD-4EE0-99DB-AE39E3D4DDEF}"/>
+                <a16:creationId xmlns:a16="http://schemas.microsoft.com/office/drawing/2014/main" id="{0E941845-614E-42B4-B793-0BDF5BF17AC4}"/>
               </a:ext>
             </a:extLst>
           </p:cNvPr>
@@ -2193,7 +2193,7 @@
           <p:cNvPr id="18" name="">
             <a:extLst xmlns:a="http://schemas.openxmlformats.org/drawingml/2006/main">
               <a:ext uri="{FF2B5EF4-FFF2-40B4-BE49-F238E27FC236}">
-                <a16:creationId xmlns:a16="http://schemas.microsoft.com/office/drawing/2014/main" id="{AD184627-11D6-418F-A573-CA862B964B05}"/>
+                <a16:creationId xmlns:a16="http://schemas.microsoft.com/office/drawing/2014/main" id="{C9963CD4-AEC9-41B7-9213-09AD09C6C427}"/>
               </a:ext>
             </a:extLst>
           </p:cNvPr>
@@ -2224,7 +2224,7 @@
           <p:cNvPr id="19" name="">
             <a:extLst xmlns:a="http://schemas.openxmlformats.org/drawingml/2006/main">
               <a:ext uri="{FF2B5EF4-FFF2-40B4-BE49-F238E27FC236}">
-                <a16:creationId xmlns:a16="http://schemas.microsoft.com/office/drawing/2014/main" id="{045177F3-7CFC-43FB-9AF4-03BE896279BF}"/>
+                <a16:creationId xmlns:a16="http://schemas.microsoft.com/office/drawing/2014/main" id="{CCBFC3F2-E081-47A0-B8CF-43BBF40F7E3B}"/>
               </a:ext>
             </a:extLst>
           </p:cNvPr>
@@ -2255,7 +2255,7 @@
           <p:cNvPr id="20" name="">
             <a:extLst xmlns:a="http://schemas.openxmlformats.org/drawingml/2006/main">
               <a:ext uri="{FF2B5EF4-FFF2-40B4-BE49-F238E27FC236}">
-                <a16:creationId xmlns:a16="http://schemas.microsoft.com/office/drawing/2014/main" id="{D8115B30-024E-42AC-95A0-F05C0269A0B9}"/>
+                <a16:creationId xmlns:a16="http://schemas.microsoft.com/office/drawing/2014/main" id="{650B60C1-2440-42C9-A3B9-8C276EBAD1CE}"/>
               </a:ext>
             </a:extLst>
           </p:cNvPr>
@@ -2286,7 +2286,7 @@
           <p:cNvPr id="21" name="">
             <a:extLst xmlns:a="http://schemas.openxmlformats.org/drawingml/2006/main">
               <a:ext uri="{FF2B5EF4-FFF2-40B4-BE49-F238E27FC236}">
-                <a16:creationId xmlns:a16="http://schemas.microsoft.com/office/drawing/2014/main" id="{C4A13201-4953-4042-8CD1-2018CE65CADF}"/>
+                <a16:creationId xmlns:a16="http://schemas.microsoft.com/office/drawing/2014/main" id="{79594E0E-1823-41AF-80FD-A9A5D3571C80}"/>
               </a:ext>
             </a:extLst>
           </p:cNvPr>
@@ -2317,7 +2317,7 @@
           <p:cNvPr id="22" name="">
             <a:extLst xmlns:a="http://schemas.openxmlformats.org/drawingml/2006/main">
               <a:ext uri="{FF2B5EF4-FFF2-40B4-BE49-F238E27FC236}">
-                <a16:creationId xmlns:a16="http://schemas.microsoft.com/office/drawing/2014/main" id="{A4FC186E-3AA1-4019-982C-BB2E7A75DFAC}"/>
+                <a16:creationId xmlns:a16="http://schemas.microsoft.com/office/drawing/2014/main" id="{A87501DB-FF04-41A9-A968-CF66B8B261AF}"/>
               </a:ext>
             </a:extLst>
           </p:cNvPr>
@@ -2348,7 +2348,7 @@
           <p:cNvPr id="23" name="">
             <a:extLst xmlns:a="http://schemas.openxmlformats.org/drawingml/2006/main">
               <a:ext uri="{FF2B5EF4-FFF2-40B4-BE49-F238E27FC236}">
-                <a16:creationId xmlns:a16="http://schemas.microsoft.com/office/drawing/2014/main" id="{804239BC-8020-4AC4-9862-3EE47FE01DC7}"/>
+                <a16:creationId xmlns:a16="http://schemas.microsoft.com/office/drawing/2014/main" id="{76BF91AA-1585-4597-BB3A-3595ABC6EF45}"/>
               </a:ext>
             </a:extLst>
           </p:cNvPr>
@@ -2379,7 +2379,7 @@
           <p:cNvPr id="24" name="">
             <a:extLst xmlns:a="http://schemas.openxmlformats.org/drawingml/2006/main">
               <a:ext uri="{FF2B5EF4-FFF2-40B4-BE49-F238E27FC236}">
-                <a16:creationId xmlns:a16="http://schemas.microsoft.com/office/drawing/2014/main" id="{D6EA9FB8-3A63-4AFD-B8F2-25358527E5A9}"/>
+                <a16:creationId xmlns:a16="http://schemas.microsoft.com/office/drawing/2014/main" id="{CACB0C87-5BA0-4588-A7ED-2FEAFCCEA840}"/>
               </a:ext>
             </a:extLst>
           </p:cNvPr>
@@ -2410,7 +2410,7 @@
           <p:cNvPr id="25" name="">
             <a:extLst xmlns:a="http://schemas.openxmlformats.org/drawingml/2006/main">
               <a:ext uri="{FF2B5EF4-FFF2-40B4-BE49-F238E27FC236}">
-                <a16:creationId xmlns:a16="http://schemas.microsoft.com/office/drawing/2014/main" id="{2AD6E1E5-F441-4A10-8CFF-86EA59EF8624}"/>
+                <a16:creationId xmlns:a16="http://schemas.microsoft.com/office/drawing/2014/main" id="{88B98AA9-9C4C-4C5F-9AB5-D383C3D65307}"/>
               </a:ext>
             </a:extLst>
           </p:cNvPr>
@@ -2441,7 +2441,7 @@
           <p:cNvPr id="26" name="">
             <a:extLst xmlns:a="http://schemas.openxmlformats.org/drawingml/2006/main">
               <a:ext uri="{FF2B5EF4-FFF2-40B4-BE49-F238E27FC236}">
-                <a16:creationId xmlns:a16="http://schemas.microsoft.com/office/drawing/2014/main" id="{FED82488-67B7-4F75-A470-A9193749A374}"/>
+                <a16:creationId xmlns:a16="http://schemas.microsoft.com/office/drawing/2014/main" id="{E0F613AD-4162-471E-919A-6E297A837890}"/>
               </a:ext>
             </a:extLst>
           </p:cNvPr>
@@ -2472,7 +2472,7 @@
           <p:cNvPr id="27" name="">
             <a:extLst xmlns:a="http://schemas.openxmlformats.org/drawingml/2006/main">
               <a:ext uri="{FF2B5EF4-FFF2-40B4-BE49-F238E27FC236}">
-                <a16:creationId xmlns:a16="http://schemas.microsoft.com/office/drawing/2014/main" id="{0206C4C5-FFE6-4A0E-B0B9-4D39A02261E6}"/>
+                <a16:creationId xmlns:a16="http://schemas.microsoft.com/office/drawing/2014/main" id="{8210CD35-910D-4B80-9EF0-53F643FE6A0D}"/>
               </a:ext>
             </a:extLst>
           </p:cNvPr>
@@ -2503,7 +2503,7 @@
           <p:cNvPr id="28" name="">
             <a:extLst xmlns:a="http://schemas.openxmlformats.org/drawingml/2006/main">
               <a:ext uri="{FF2B5EF4-FFF2-40B4-BE49-F238E27FC236}">
-                <a16:creationId xmlns:a16="http://schemas.microsoft.com/office/drawing/2014/main" id="{850B9DDB-7297-4999-BF37-6689108E0D80}"/>
+                <a16:creationId xmlns:a16="http://schemas.microsoft.com/office/drawing/2014/main" id="{7D6A0532-DAF2-48C4-8B7A-0E5E1FAA2225}"/>
               </a:ext>
             </a:extLst>
           </p:cNvPr>
@@ -2534,7 +2534,7 @@
           <p:cNvPr id="29" name="">
             <a:extLst xmlns:a="http://schemas.openxmlformats.org/drawingml/2006/main">
               <a:ext uri="{FF2B5EF4-FFF2-40B4-BE49-F238E27FC236}">
-                <a16:creationId xmlns:a16="http://schemas.microsoft.com/office/drawing/2014/main" id="{540B3251-15FF-4CDD-8AD9-E9631DD53B48}"/>
+                <a16:creationId xmlns:a16="http://schemas.microsoft.com/office/drawing/2014/main" id="{7C285077-B6ED-4B69-9EF0-2C42C4D4E795}"/>
               </a:ext>
             </a:extLst>
           </p:cNvPr>
@@ -2565,7 +2565,7 @@
           <p:cNvPr id="30" name="">
             <a:extLst xmlns:a="http://schemas.openxmlformats.org/drawingml/2006/main">
               <a:ext uri="{FF2B5EF4-FFF2-40B4-BE49-F238E27FC236}">
-                <a16:creationId xmlns:a16="http://schemas.microsoft.com/office/drawing/2014/main" id="{E6EDBE86-4A41-47C3-ADE5-60F1A1440225}"/>
+                <a16:creationId xmlns:a16="http://schemas.microsoft.com/office/drawing/2014/main" id="{8C73F090-EEFD-42B7-A4D1-19D143478BF1}"/>
               </a:ext>
             </a:extLst>
           </p:cNvPr>
@@ -2596,7 +2596,7 @@
           <p:cNvPr id="31" name="">
             <a:extLst xmlns:a="http://schemas.openxmlformats.org/drawingml/2006/main">
               <a:ext uri="{FF2B5EF4-FFF2-40B4-BE49-F238E27FC236}">
-                <a16:creationId xmlns:a16="http://schemas.microsoft.com/office/drawing/2014/main" id="{B4DB2BDA-F3CE-4E19-B2C0-AB9E4B9DF4F9}"/>
+                <a16:creationId xmlns:a16="http://schemas.microsoft.com/office/drawing/2014/main" id="{1D25EFBD-4261-4C9A-958C-BA75C4391292}"/>
               </a:ext>
             </a:extLst>
           </p:cNvPr>
@@ -2627,7 +2627,7 @@
           <p:cNvPr id="32" name="">
             <a:extLst xmlns:a="http://schemas.openxmlformats.org/drawingml/2006/main">
               <a:ext uri="{FF2B5EF4-FFF2-40B4-BE49-F238E27FC236}">
-                <a16:creationId xmlns:a16="http://schemas.microsoft.com/office/drawing/2014/main" id="{3A8C411F-974F-4A0B-9B4C-0AA77C6FC432}"/>
+                <a16:creationId xmlns:a16="http://schemas.microsoft.com/office/drawing/2014/main" id="{3AE95EAD-49CC-4473-86CD-9C4D19546E68}"/>
               </a:ext>
             </a:extLst>
           </p:cNvPr>
@@ -2658,7 +2658,7 @@
           <p:cNvPr id="33" name="">
             <a:extLst xmlns:a="http://schemas.openxmlformats.org/drawingml/2006/main">
               <a:ext uri="{FF2B5EF4-FFF2-40B4-BE49-F238E27FC236}">
-                <a16:creationId xmlns:a16="http://schemas.microsoft.com/office/drawing/2014/main" id="{FA1A861C-B55F-4471-AA44-707D85E75B80}"/>
+                <a16:creationId xmlns:a16="http://schemas.microsoft.com/office/drawing/2014/main" id="{9E4F6EED-7761-4716-825B-044180F9FBE0}"/>
               </a:ext>
             </a:extLst>
           </p:cNvPr>
@@ -2689,7 +2689,7 @@
           <p:cNvPr id="34" name="">
             <a:extLst xmlns:a="http://schemas.openxmlformats.org/drawingml/2006/main">
               <a:ext uri="{FF2B5EF4-FFF2-40B4-BE49-F238E27FC236}">
-                <a16:creationId xmlns:a16="http://schemas.microsoft.com/office/drawing/2014/main" id="{EB21F7A7-6966-471F-A1DA-5DC1D32C862D}"/>
+                <a16:creationId xmlns:a16="http://schemas.microsoft.com/office/drawing/2014/main" id="{CD921529-C358-4DC0-963A-09918CEA9CCD}"/>
               </a:ext>
             </a:extLst>
           </p:cNvPr>
@@ -2720,7 +2720,7 @@
           <p:cNvPr id="35" name="">
             <a:extLst xmlns:a="http://schemas.openxmlformats.org/drawingml/2006/main">
               <a:ext uri="{FF2B5EF4-FFF2-40B4-BE49-F238E27FC236}">
-                <a16:creationId xmlns:a16="http://schemas.microsoft.com/office/drawing/2014/main" id="{06485050-729A-4FE6-841C-2B76EF9AD489}"/>
+                <a16:creationId xmlns:a16="http://schemas.microsoft.com/office/drawing/2014/main" id="{949193E1-2805-4E77-8304-C98F9017C428}"/>
               </a:ext>
             </a:extLst>
           </p:cNvPr>
@@ -2751,7 +2751,7 @@
           <p:cNvPr id="36" name="">
             <a:extLst xmlns:a="http://schemas.openxmlformats.org/drawingml/2006/main">
               <a:ext uri="{FF2B5EF4-FFF2-40B4-BE49-F238E27FC236}">
-                <a16:creationId xmlns:a16="http://schemas.microsoft.com/office/drawing/2014/main" id="{8EA331FA-B4B2-403C-8155-4007E6C30A97}"/>
+                <a16:creationId xmlns:a16="http://schemas.microsoft.com/office/drawing/2014/main" id="{E2B1CF5F-4DE6-48FA-9C1B-394DF5C82C89}"/>
               </a:ext>
             </a:extLst>
           </p:cNvPr>
@@ -2782,7 +2782,7 @@
           <p:cNvPr id="37" name="">
             <a:extLst xmlns:a="http://schemas.openxmlformats.org/drawingml/2006/main">
               <a:ext uri="{FF2B5EF4-FFF2-40B4-BE49-F238E27FC236}">
-                <a16:creationId xmlns:a16="http://schemas.microsoft.com/office/drawing/2014/main" id="{CF816CF7-9D9A-4DBF-9524-D9216B53533D}"/>
+                <a16:creationId xmlns:a16="http://schemas.microsoft.com/office/drawing/2014/main" id="{E6762079-A3CC-48D7-96E9-8C5EE417FE1A}"/>
               </a:ext>
             </a:extLst>
           </p:cNvPr>
@@ -2813,7 +2813,7 @@
           <p:cNvPr id="38" name="">
             <a:extLst xmlns:a="http://schemas.openxmlformats.org/drawingml/2006/main">
               <a:ext uri="{FF2B5EF4-FFF2-40B4-BE49-F238E27FC236}">
-                <a16:creationId xmlns:a16="http://schemas.microsoft.com/office/drawing/2014/main" id="{2C55465D-9F36-425A-BCB6-3DAB9068C3D4}"/>
+                <a16:creationId xmlns:a16="http://schemas.microsoft.com/office/drawing/2014/main" id="{8FE82DB5-689F-4DBA-B14C-AF533FDB05CC}"/>
               </a:ext>
             </a:extLst>
           </p:cNvPr>
@@ -2844,7 +2844,7 @@
           <p:cNvPr id="39" name="">
             <a:extLst xmlns:a="http://schemas.openxmlformats.org/drawingml/2006/main">
               <a:ext uri="{FF2B5EF4-FFF2-40B4-BE49-F238E27FC236}">
-                <a16:creationId xmlns:a16="http://schemas.microsoft.com/office/drawing/2014/main" id="{8C1886DE-FC10-4503-8C74-C5203DAB99C2}"/>
+                <a16:creationId xmlns:a16="http://schemas.microsoft.com/office/drawing/2014/main" id="{BC40B965-F8EF-4D93-90BD-CC7853B6D3FB}"/>
               </a:ext>
             </a:extLst>
           </p:cNvPr>
@@ -2875,7 +2875,7 @@
           <p:cNvPr id="40" name="">
             <a:extLst xmlns:a="http://schemas.openxmlformats.org/drawingml/2006/main">
               <a:ext uri="{FF2B5EF4-FFF2-40B4-BE49-F238E27FC236}">
-                <a16:creationId xmlns:a16="http://schemas.microsoft.com/office/drawing/2014/main" id="{79B7A00F-8829-496B-BC42-1FD1C3F190CC}"/>
+                <a16:creationId xmlns:a16="http://schemas.microsoft.com/office/drawing/2014/main" id="{9DA98BB1-88F5-494A-8ABF-A6122F137D53}"/>
               </a:ext>
             </a:extLst>
           </p:cNvPr>
@@ -2906,7 +2906,7 @@
           <p:cNvPr id="41" name="">
             <a:extLst xmlns:a="http://schemas.openxmlformats.org/drawingml/2006/main">
               <a:ext uri="{FF2B5EF4-FFF2-40B4-BE49-F238E27FC236}">
-                <a16:creationId xmlns:a16="http://schemas.microsoft.com/office/drawing/2014/main" id="{6EDFF120-B14F-46F8-BEAC-E6A8F3BBE072}"/>
+                <a16:creationId xmlns:a16="http://schemas.microsoft.com/office/drawing/2014/main" id="{D2D231B0-FC16-42E5-B87C-1962C8E45F0D}"/>
               </a:ext>
             </a:extLst>
           </p:cNvPr>
@@ -2937,7 +2937,7 @@
           <p:cNvPr id="42" name="">
             <a:extLst xmlns:a="http://schemas.openxmlformats.org/drawingml/2006/main">
               <a:ext uri="{FF2B5EF4-FFF2-40B4-BE49-F238E27FC236}">
-                <a16:creationId xmlns:a16="http://schemas.microsoft.com/office/drawing/2014/main" id="{01C0C2D7-D4DC-4F89-8634-4B486FFF15B7}"/>
+                <a16:creationId xmlns:a16="http://schemas.microsoft.com/office/drawing/2014/main" id="{BE1D4977-FA30-42B2-828F-A0DBC4DA8CCF}"/>
               </a:ext>
             </a:extLst>
           </p:cNvPr>
@@ -2968,7 +2968,7 @@
           <p:cNvPr id="43" name="">
             <a:extLst xmlns:a="http://schemas.openxmlformats.org/drawingml/2006/main">
               <a:ext uri="{FF2B5EF4-FFF2-40B4-BE49-F238E27FC236}">
-                <a16:creationId xmlns:a16="http://schemas.microsoft.com/office/drawing/2014/main" id="{E5F3CA28-B2AB-472B-802E-F15395B18610}"/>
+                <a16:creationId xmlns:a16="http://schemas.microsoft.com/office/drawing/2014/main" id="{56701FB6-BA49-4A4E-9A4F-A30FE275C322}"/>
               </a:ext>
             </a:extLst>
           </p:cNvPr>
@@ -2999,7 +2999,7 @@
           <p:cNvPr id="44" name="">
             <a:extLst xmlns:a="http://schemas.openxmlformats.org/drawingml/2006/main">
               <a:ext uri="{FF2B5EF4-FFF2-40B4-BE49-F238E27FC236}">
-                <a16:creationId xmlns:a16="http://schemas.microsoft.com/office/drawing/2014/main" id="{64C1C32A-45D8-4514-854C-9560CF7C64D1}"/>
+                <a16:creationId xmlns:a16="http://schemas.microsoft.com/office/drawing/2014/main" id="{1534B193-2CD1-4A37-8E7E-68F512049835}"/>
               </a:ext>
             </a:extLst>
           </p:cNvPr>
@@ -3030,7 +3030,7 @@
           <p:cNvPr id="45" name="">
             <a:extLst xmlns:a="http://schemas.openxmlformats.org/drawingml/2006/main">
               <a:ext uri="{FF2B5EF4-FFF2-40B4-BE49-F238E27FC236}">
-                <a16:creationId xmlns:a16="http://schemas.microsoft.com/office/drawing/2014/main" id="{A78D542E-CA9C-43F9-AB42-ED616304A4B4}"/>
+                <a16:creationId xmlns:a16="http://schemas.microsoft.com/office/drawing/2014/main" id="{03DAD1C9-F946-49B9-868D-6A4A6EF66E4F}"/>
               </a:ext>
             </a:extLst>
           </p:cNvPr>
@@ -3061,7 +3061,7 @@
           <p:cNvPr id="46" name="">
             <a:extLst xmlns:a="http://schemas.openxmlformats.org/drawingml/2006/main">
               <a:ext uri="{FF2B5EF4-FFF2-40B4-BE49-F238E27FC236}">
-                <a16:creationId xmlns:a16="http://schemas.microsoft.com/office/drawing/2014/main" id="{36B5AAC1-3F93-48AF-855E-C8FBC5DD67A6}"/>
+                <a16:creationId xmlns:a16="http://schemas.microsoft.com/office/drawing/2014/main" id="{9BC9C02D-1F64-420F-90F4-CEA893501596}"/>
               </a:ext>
             </a:extLst>
           </p:cNvPr>
@@ -3092,7 +3092,7 @@
           <p:cNvPr id="47" name="">
             <a:extLst xmlns:a="http://schemas.openxmlformats.org/drawingml/2006/main">
               <a:ext uri="{FF2B5EF4-FFF2-40B4-BE49-F238E27FC236}">
-                <a16:creationId xmlns:a16="http://schemas.microsoft.com/office/drawing/2014/main" id="{D2DB17D0-348F-498B-9064-4F6887B730C4}"/>
+                <a16:creationId xmlns:a16="http://schemas.microsoft.com/office/drawing/2014/main" id="{EA9A09DC-451C-4B0A-9149-3A768CA7A05E}"/>
               </a:ext>
             </a:extLst>
           </p:cNvPr>
@@ -3123,7 +3123,7 @@
           <p:cNvPr id="48" name="">
             <a:extLst xmlns:a="http://schemas.openxmlformats.org/drawingml/2006/main">
               <a:ext uri="{FF2B5EF4-FFF2-40B4-BE49-F238E27FC236}">
-                <a16:creationId xmlns:a16="http://schemas.microsoft.com/office/drawing/2014/main" id="{F98B1A2D-3D58-4FA8-AB38-EFEF52A4FA66}"/>
+                <a16:creationId xmlns:a16="http://schemas.microsoft.com/office/drawing/2014/main" id="{09AA411F-C2FD-4F63-A7D1-F38BD82CEA8C}"/>
               </a:ext>
             </a:extLst>
           </p:cNvPr>
@@ -3154,7 +3154,7 @@
           <p:cNvPr id="49" name="">
             <a:extLst xmlns:a="http://schemas.openxmlformats.org/drawingml/2006/main">
               <a:ext uri="{FF2B5EF4-FFF2-40B4-BE49-F238E27FC236}">
-                <a16:creationId xmlns:a16="http://schemas.microsoft.com/office/drawing/2014/main" id="{DDE815D4-FCCA-48B7-BF97-F55DA00A2E39}"/>
+                <a16:creationId xmlns:a16="http://schemas.microsoft.com/office/drawing/2014/main" id="{076B30B2-C19A-4D74-953E-ED514090FFE8}"/>
               </a:ext>
             </a:extLst>
           </p:cNvPr>
@@ -3185,7 +3185,7 @@
           <p:cNvPr id="50" name="">
             <a:extLst xmlns:a="http://schemas.openxmlformats.org/drawingml/2006/main">
               <a:ext uri="{FF2B5EF4-FFF2-40B4-BE49-F238E27FC236}">
-                <a16:creationId xmlns:a16="http://schemas.microsoft.com/office/drawing/2014/main" id="{3CD2FC7D-7D59-4362-A019-DBA4A46CF5E1}"/>
+                <a16:creationId xmlns:a16="http://schemas.microsoft.com/office/drawing/2014/main" id="{FA492D49-3C7E-4348-B6D7-B4EA4A4B4B45}"/>
               </a:ext>
             </a:extLst>
           </p:cNvPr>
@@ -3216,7 +3216,7 @@
           <p:cNvPr id="51" name="">
             <a:extLst xmlns:a="http://schemas.openxmlformats.org/drawingml/2006/main">
               <a:ext uri="{FF2B5EF4-FFF2-40B4-BE49-F238E27FC236}">
-                <a16:creationId xmlns:a16="http://schemas.microsoft.com/office/drawing/2014/main" id="{7BE269B3-F22F-4692-96CF-456A4EECC156}"/>
+                <a16:creationId xmlns:a16="http://schemas.microsoft.com/office/drawing/2014/main" id="{48B77E45-0991-4E83-9DFD-97C09A23D969}"/>
               </a:ext>
             </a:extLst>
           </p:cNvPr>
@@ -3247,7 +3247,7 @@
           <p:cNvPr id="52" name="">
             <a:extLst xmlns:a="http://schemas.openxmlformats.org/drawingml/2006/main">
               <a:ext uri="{FF2B5EF4-FFF2-40B4-BE49-F238E27FC236}">
-                <a16:creationId xmlns:a16="http://schemas.microsoft.com/office/drawing/2014/main" id="{4462DB35-6764-4DA5-B7B8-0ADFAE108D01}"/>
+                <a16:creationId xmlns:a16="http://schemas.microsoft.com/office/drawing/2014/main" id="{E72A842C-6070-4357-AB77-00929693D40D}"/>
               </a:ext>
             </a:extLst>
           </p:cNvPr>
@@ -3278,7 +3278,7 @@
           <p:cNvPr id="53" name="">
             <a:extLst xmlns:a="http://schemas.openxmlformats.org/drawingml/2006/main">
               <a:ext uri="{FF2B5EF4-FFF2-40B4-BE49-F238E27FC236}">
-                <a16:creationId xmlns:a16="http://schemas.microsoft.com/office/drawing/2014/main" id="{1D546558-F76B-4B77-AFE3-CF2ED9E94EBA}"/>
+                <a16:creationId xmlns:a16="http://schemas.microsoft.com/office/drawing/2014/main" id="{146DB560-6FDD-47DD-BB9D-1529A06F2D68}"/>
               </a:ext>
             </a:extLst>
           </p:cNvPr>
@@ -3309,7 +3309,7 @@
           <p:cNvPr id="54" name="">
             <a:extLst xmlns:a="http://schemas.openxmlformats.org/drawingml/2006/main">
               <a:ext uri="{FF2B5EF4-FFF2-40B4-BE49-F238E27FC236}">
-                <a16:creationId xmlns:a16="http://schemas.microsoft.com/office/drawing/2014/main" id="{3E47F456-67C5-46AC-9889-0727235E70EB}"/>
+                <a16:creationId xmlns:a16="http://schemas.microsoft.com/office/drawing/2014/main" id="{DED41E10-3FEB-4094-9236-528F2619C271}"/>
               </a:ext>
             </a:extLst>
           </p:cNvPr>
@@ -3340,7 +3340,7 @@
           <p:cNvPr id="55" name="">
             <a:extLst xmlns:a="http://schemas.openxmlformats.org/drawingml/2006/main">
               <a:ext uri="{FF2B5EF4-FFF2-40B4-BE49-F238E27FC236}">
-                <a16:creationId xmlns:a16="http://schemas.microsoft.com/office/drawing/2014/main" id="{B5C954A7-821D-4409-BFF1-3ECB65ED54CC}"/>
+                <a16:creationId xmlns:a16="http://schemas.microsoft.com/office/drawing/2014/main" id="{8A4C2A98-3266-4396-AEDB-C4FD8CAF8403}"/>
               </a:ext>
             </a:extLst>
           </p:cNvPr>
@@ -3371,7 +3371,7 @@
           <p:cNvPr id="56" name="">
             <a:extLst xmlns:a="http://schemas.openxmlformats.org/drawingml/2006/main">
               <a:ext uri="{FF2B5EF4-FFF2-40B4-BE49-F238E27FC236}">
-                <a16:creationId xmlns:a16="http://schemas.microsoft.com/office/drawing/2014/main" id="{6EB0C006-FA43-4E9D-A796-6FBD6BBD8C61}"/>
+                <a16:creationId xmlns:a16="http://schemas.microsoft.com/office/drawing/2014/main" id="{6B7AF00D-B386-4520-B179-1ECC293D5A78}"/>
               </a:ext>
             </a:extLst>
           </p:cNvPr>
@@ -3402,7 +3402,7 @@
           <p:cNvPr id="57" name="">
             <a:extLst xmlns:a="http://schemas.openxmlformats.org/drawingml/2006/main">
               <a:ext uri="{FF2B5EF4-FFF2-40B4-BE49-F238E27FC236}">
-                <a16:creationId xmlns:a16="http://schemas.microsoft.com/office/drawing/2014/main" id="{7A85A3D8-0AA3-4B0A-8884-608E5216FF52}"/>
+                <a16:creationId xmlns:a16="http://schemas.microsoft.com/office/drawing/2014/main" id="{B860F970-CBA8-4195-95C4-4E46BCEDFD24}"/>
               </a:ext>
             </a:extLst>
           </p:cNvPr>
@@ -3433,7 +3433,7 @@
           <p:cNvPr id="58" name="">
             <a:extLst xmlns:a="http://schemas.openxmlformats.org/drawingml/2006/main">
               <a:ext uri="{FF2B5EF4-FFF2-40B4-BE49-F238E27FC236}">
-                <a16:creationId xmlns:a16="http://schemas.microsoft.com/office/drawing/2014/main" id="{39B07127-20DE-4B18-826C-771A5B30E865}"/>
+                <a16:creationId xmlns:a16="http://schemas.microsoft.com/office/drawing/2014/main" id="{8B2B4507-E74B-4F4A-AFBB-0E864BF2F3B9}"/>
               </a:ext>
             </a:extLst>
           </p:cNvPr>
@@ -3464,7 +3464,7 @@
           <p:cNvPr id="59" name="">
             <a:extLst xmlns:a="http://schemas.openxmlformats.org/drawingml/2006/main">
               <a:ext uri="{FF2B5EF4-FFF2-40B4-BE49-F238E27FC236}">
-                <a16:creationId xmlns:a16="http://schemas.microsoft.com/office/drawing/2014/main" id="{4B3B0625-42CA-4F24-91EF-BF6D79294B98}"/>
+                <a16:creationId xmlns:a16="http://schemas.microsoft.com/office/drawing/2014/main" id="{33E2EEF4-565A-4E0D-87D9-7CDDBF901648}"/>
               </a:ext>
             </a:extLst>
           </p:cNvPr>
@@ -3495,7 +3495,7 @@
           <p:cNvPr id="60" name="">
             <a:extLst xmlns:a="http://schemas.openxmlformats.org/drawingml/2006/main">
               <a:ext uri="{FF2B5EF4-FFF2-40B4-BE49-F238E27FC236}">
-                <a16:creationId xmlns:a16="http://schemas.microsoft.com/office/drawing/2014/main" id="{DDA7DE3A-09C8-471A-A9EF-FC85B1D04ACF}"/>
+                <a16:creationId xmlns:a16="http://schemas.microsoft.com/office/drawing/2014/main" id="{4963DA13-CBBD-4DE5-9C2B-63AFD99681F1}"/>
               </a:ext>
             </a:extLst>
           </p:cNvPr>
@@ -3526,7 +3526,7 @@
           <p:cNvPr id="61" name="">
             <a:extLst xmlns:a="http://schemas.openxmlformats.org/drawingml/2006/main">
               <a:ext uri="{FF2B5EF4-FFF2-40B4-BE49-F238E27FC236}">
-                <a16:creationId xmlns:a16="http://schemas.microsoft.com/office/drawing/2014/main" id="{96A4AF54-A46A-4086-9774-7B5C8AE6F474}"/>
+                <a16:creationId xmlns:a16="http://schemas.microsoft.com/office/drawing/2014/main" id="{CB8432E2-DE68-43CA-B877-21A5164E53BE}"/>
               </a:ext>
             </a:extLst>
           </p:cNvPr>
@@ -3557,7 +3557,7 @@
           <p:cNvPr id="62" name="">
             <a:extLst xmlns:a="http://schemas.openxmlformats.org/drawingml/2006/main">
               <a:ext uri="{FF2B5EF4-FFF2-40B4-BE49-F238E27FC236}">
-                <a16:creationId xmlns:a16="http://schemas.microsoft.com/office/drawing/2014/main" id="{460D92CE-9CA8-474D-8437-39084CB58662}"/>
+                <a16:creationId xmlns:a16="http://schemas.microsoft.com/office/drawing/2014/main" id="{F5684ED5-DC11-4440-A7B4-693F39EF840C}"/>
               </a:ext>
             </a:extLst>
           </p:cNvPr>
@@ -3588,7 +3588,7 @@
           <p:cNvPr id="63" name="">
             <a:extLst xmlns:a="http://schemas.openxmlformats.org/drawingml/2006/main">
               <a:ext uri="{FF2B5EF4-FFF2-40B4-BE49-F238E27FC236}">
-                <a16:creationId xmlns:a16="http://schemas.microsoft.com/office/drawing/2014/main" id="{B1283B62-32FF-4791-8B09-71A808C1EACB}"/>
+                <a16:creationId xmlns:a16="http://schemas.microsoft.com/office/drawing/2014/main" id="{2E1A2453-595A-4DD0-9DC5-850FEB5D97D7}"/>
               </a:ext>
             </a:extLst>
           </p:cNvPr>
@@ -3619,7 +3619,7 @@
           <p:cNvPr id="64" name="">
             <a:extLst xmlns:a="http://schemas.openxmlformats.org/drawingml/2006/main">
               <a:ext uri="{FF2B5EF4-FFF2-40B4-BE49-F238E27FC236}">
-                <a16:creationId xmlns:a16="http://schemas.microsoft.com/office/drawing/2014/main" id="{8F023908-C5B2-4896-BD94-DA7AEACFE371}"/>
+                <a16:creationId xmlns:a16="http://schemas.microsoft.com/office/drawing/2014/main" id="{37C5CCEC-BF60-4D7A-94B7-3B5FDE1A4CAD}"/>
               </a:ext>
             </a:extLst>
           </p:cNvPr>
@@ -3650,7 +3650,7 @@
           <p:cNvPr id="65" name="">
             <a:extLst xmlns:a="http://schemas.openxmlformats.org/drawingml/2006/main">
               <a:ext uri="{FF2B5EF4-FFF2-40B4-BE49-F238E27FC236}">
-                <a16:creationId xmlns:a16="http://schemas.microsoft.com/office/drawing/2014/main" id="{88A5764C-03F2-418D-9F42-3A6AB6F86112}"/>
+                <a16:creationId xmlns:a16="http://schemas.microsoft.com/office/drawing/2014/main" id="{356921E8-E26B-4144-A544-0B3B18E196EA}"/>
               </a:ext>
             </a:extLst>
           </p:cNvPr>
@@ -3681,7 +3681,7 @@
           <p:cNvPr id="66" name="">
             <a:extLst xmlns:a="http://schemas.openxmlformats.org/drawingml/2006/main">
               <a:ext uri="{FF2B5EF4-FFF2-40B4-BE49-F238E27FC236}">
-                <a16:creationId xmlns:a16="http://schemas.microsoft.com/office/drawing/2014/main" id="{FF374CD8-E8C9-420A-8A23-A00E02F271F0}"/>
+                <a16:creationId xmlns:a16="http://schemas.microsoft.com/office/drawing/2014/main" id="{3A7D8D4B-7DBC-40CF-8033-B915DC685F7C}"/>
               </a:ext>
             </a:extLst>
           </p:cNvPr>
@@ -3712,7 +3712,7 @@
           <p:cNvPr id="67" name="">
             <a:extLst xmlns:a="http://schemas.openxmlformats.org/drawingml/2006/main">
               <a:ext uri="{FF2B5EF4-FFF2-40B4-BE49-F238E27FC236}">
-                <a16:creationId xmlns:a16="http://schemas.microsoft.com/office/drawing/2014/main" id="{C0403E70-B576-4F6A-A63A-612BAD6BB969}"/>
+                <a16:creationId xmlns:a16="http://schemas.microsoft.com/office/drawing/2014/main" id="{9C4004CF-9941-4AF0-8127-70E140EA4890}"/>
               </a:ext>
             </a:extLst>
           </p:cNvPr>
@@ -3743,7 +3743,7 @@
           <p:cNvPr id="68" name="">
             <a:extLst xmlns:a="http://schemas.openxmlformats.org/drawingml/2006/main">
               <a:ext uri="{FF2B5EF4-FFF2-40B4-BE49-F238E27FC236}">
-                <a16:creationId xmlns:a16="http://schemas.microsoft.com/office/drawing/2014/main" id="{3A337416-F990-4CF6-BB89-BCE0D422ED34}"/>
+                <a16:creationId xmlns:a16="http://schemas.microsoft.com/office/drawing/2014/main" id="{9B12038A-A53A-4D4E-8F90-A83118A6CCFD}"/>
               </a:ext>
             </a:extLst>
           </p:cNvPr>
@@ -3774,7 +3774,7 @@
           <p:cNvPr id="69" name="">
             <a:extLst xmlns:a="http://schemas.openxmlformats.org/drawingml/2006/main">
               <a:ext uri="{FF2B5EF4-FFF2-40B4-BE49-F238E27FC236}">
-                <a16:creationId xmlns:a16="http://schemas.microsoft.com/office/drawing/2014/main" id="{E120B60B-F163-4B83-99C5-AA806754983E}"/>
+                <a16:creationId xmlns:a16="http://schemas.microsoft.com/office/drawing/2014/main" id="{32501A88-AE7C-4485-827A-CCEFDC69A136}"/>
               </a:ext>
             </a:extLst>
           </p:cNvPr>
@@ -3805,7 +3805,7 @@
           <p:cNvPr id="70" name="">
             <a:extLst xmlns:a="http://schemas.openxmlformats.org/drawingml/2006/main">
               <a:ext uri="{FF2B5EF4-FFF2-40B4-BE49-F238E27FC236}">
-                <a16:creationId xmlns:a16="http://schemas.microsoft.com/office/drawing/2014/main" id="{D7ABD899-B7F1-4966-BB26-FAD33867D7D3}"/>
+                <a16:creationId xmlns:a16="http://schemas.microsoft.com/office/drawing/2014/main" id="{7835BB88-13C1-476D-8712-F22CF5B568C9}"/>
               </a:ext>
             </a:extLst>
           </p:cNvPr>
@@ -3836,7 +3836,7 @@
           <p:cNvPr id="71" name="">
             <a:extLst xmlns:a="http://schemas.openxmlformats.org/drawingml/2006/main">
               <a:ext uri="{FF2B5EF4-FFF2-40B4-BE49-F238E27FC236}">
-                <a16:creationId xmlns:a16="http://schemas.microsoft.com/office/drawing/2014/main" id="{399A0893-5F82-4F21-B046-B17834FA2F9C}"/>
+                <a16:creationId xmlns:a16="http://schemas.microsoft.com/office/drawing/2014/main" id="{6C06E222-26E0-416B-93DF-9BC3F9C0F33D}"/>
               </a:ext>
             </a:extLst>
           </p:cNvPr>
@@ -3867,7 +3867,7 @@
           <p:cNvPr id="72" name="">
             <a:extLst xmlns:a="http://schemas.openxmlformats.org/drawingml/2006/main">
               <a:ext uri="{FF2B5EF4-FFF2-40B4-BE49-F238E27FC236}">
-                <a16:creationId xmlns:a16="http://schemas.microsoft.com/office/drawing/2014/main" id="{F4F42053-F1F8-488A-B85C-C5E760FD0118}"/>
+                <a16:creationId xmlns:a16="http://schemas.microsoft.com/office/drawing/2014/main" id="{C7959A45-D618-438B-A347-5F7D00D44CA1}"/>
               </a:ext>
             </a:extLst>
           </p:cNvPr>
@@ -3900,7 +3900,7 @@
           <p:cNvPr id="73" name="">
             <a:extLst xmlns:a="http://schemas.openxmlformats.org/drawingml/2006/main">
               <a:ext uri="{FF2B5EF4-FFF2-40B4-BE49-F238E27FC236}">
-                <a16:creationId xmlns:a16="http://schemas.microsoft.com/office/drawing/2014/main" id="{DF658D0A-8DD4-423A-96CF-10BB45AA538F}"/>
+                <a16:creationId xmlns:a16="http://schemas.microsoft.com/office/drawing/2014/main" id="{8A73C279-EC48-4961-9650-A17CD0CCC2A0}"/>
               </a:ext>
             </a:extLst>
           </p:cNvPr>
@@ -3933,7 +3933,7 @@
           <p:cNvPr id="74" name="">
             <a:extLst xmlns:a="http://schemas.openxmlformats.org/drawingml/2006/main">
               <a:ext uri="{FF2B5EF4-FFF2-40B4-BE49-F238E27FC236}">
-                <a16:creationId xmlns:a16="http://schemas.microsoft.com/office/drawing/2014/main" id="{D5675F32-52CD-425B-8B3E-5E717FFEED32}"/>
+                <a16:creationId xmlns:a16="http://schemas.microsoft.com/office/drawing/2014/main" id="{A96A5D9D-240F-4B7C-82CA-27223EEA19BE}"/>
               </a:ext>
             </a:extLst>
           </p:cNvPr>
@@ -3966,7 +3966,7 @@
           <p:cNvPr id="75" name="">
             <a:extLst xmlns:a="http://schemas.openxmlformats.org/drawingml/2006/main">
               <a:ext uri="{FF2B5EF4-FFF2-40B4-BE49-F238E27FC236}">
-                <a16:creationId xmlns:a16="http://schemas.microsoft.com/office/drawing/2014/main" id="{A17CC42F-29AF-4893-9452-85BEBE57ED9C}"/>
+                <a16:creationId xmlns:a16="http://schemas.microsoft.com/office/drawing/2014/main" id="{DC47A160-272F-475D-94DF-1482A1D0DFB5}"/>
               </a:ext>
             </a:extLst>
           </p:cNvPr>
@@ -3997,7 +3997,7 @@
           <p:cNvPr id="76" name="">
             <a:extLst xmlns:a="http://schemas.openxmlformats.org/drawingml/2006/main">
               <a:ext uri="{FF2B5EF4-FFF2-40B4-BE49-F238E27FC236}">
-                <a16:creationId xmlns:a16="http://schemas.microsoft.com/office/drawing/2014/main" id="{BCE54B7E-66D5-42F4-A2F9-A3D34F0909CA}"/>
+                <a16:creationId xmlns:a16="http://schemas.microsoft.com/office/drawing/2014/main" id="{E1248658-4B3E-4783-904D-3BD91586721A}"/>
               </a:ext>
             </a:extLst>
           </p:cNvPr>
@@ -4028,7 +4028,7 @@
           <p:cNvPr id="77" name="">
             <a:extLst xmlns:a="http://schemas.openxmlformats.org/drawingml/2006/main">
               <a:ext uri="{FF2B5EF4-FFF2-40B4-BE49-F238E27FC236}">
-                <a16:creationId xmlns:a16="http://schemas.microsoft.com/office/drawing/2014/main" id="{37A7FD56-171D-4125-8DDD-2B24ED00F4DC}"/>
+                <a16:creationId xmlns:a16="http://schemas.microsoft.com/office/drawing/2014/main" id="{10CB0D00-3ABB-4394-AF1E-E63C78474C2D}"/>
               </a:ext>
             </a:extLst>
           </p:cNvPr>
@@ -4059,7 +4059,7 @@
           <p:cNvPr id="78" name="">
             <a:extLst xmlns:a="http://schemas.openxmlformats.org/drawingml/2006/main">
               <a:ext uri="{FF2B5EF4-FFF2-40B4-BE49-F238E27FC236}">
-                <a16:creationId xmlns:a16="http://schemas.microsoft.com/office/drawing/2014/main" id="{189B5CB2-6E1A-4B57-BB64-D5B4C83610BD}"/>
+                <a16:creationId xmlns:a16="http://schemas.microsoft.com/office/drawing/2014/main" id="{F5C37E3C-206F-4E53-98DE-AE57493D640B}"/>
               </a:ext>
             </a:extLst>
           </p:cNvPr>
@@ -4090,7 +4090,7 @@
           <p:cNvPr id="79" name="">
             <a:extLst xmlns:a="http://schemas.openxmlformats.org/drawingml/2006/main">
               <a:ext uri="{FF2B5EF4-FFF2-40B4-BE49-F238E27FC236}">
-                <a16:creationId xmlns:a16="http://schemas.microsoft.com/office/drawing/2014/main" id="{E54552AA-55EF-434F-94F8-C8D7E2AEE0CC}"/>
+                <a16:creationId xmlns:a16="http://schemas.microsoft.com/office/drawing/2014/main" id="{F5E4E729-A7BD-4E46-8DC0-C683FE6DF3C7}"/>
               </a:ext>
             </a:extLst>
           </p:cNvPr>
@@ -4121,7 +4121,7 @@
           <p:cNvPr id="80" name="">
             <a:extLst xmlns:a="http://schemas.openxmlformats.org/drawingml/2006/main">
               <a:ext uri="{FF2B5EF4-FFF2-40B4-BE49-F238E27FC236}">
-                <a16:creationId xmlns:a16="http://schemas.microsoft.com/office/drawing/2014/main" id="{CC8F054D-6A04-4F14-956D-A54569C2AC70}"/>
+                <a16:creationId xmlns:a16="http://schemas.microsoft.com/office/drawing/2014/main" id="{897F8F99-25F2-4C81-9D9F-31BA26281B94}"/>
               </a:ext>
             </a:extLst>
           </p:cNvPr>
@@ -4152,7 +4152,7 @@
           <p:cNvPr id="81" name="">
             <a:extLst xmlns:a="http://schemas.openxmlformats.org/drawingml/2006/main">
               <a:ext uri="{FF2B5EF4-FFF2-40B4-BE49-F238E27FC236}">
-                <a16:creationId xmlns:a16="http://schemas.microsoft.com/office/drawing/2014/main" id="{BA89A527-77B6-49C0-AFF1-1A2E371425D3}"/>
+                <a16:creationId xmlns:a16="http://schemas.microsoft.com/office/drawing/2014/main" id="{2F47F0E5-3536-4CFC-9231-FF148CCDC5BF}"/>
               </a:ext>
             </a:extLst>
           </p:cNvPr>
@@ -4183,7 +4183,7 @@
           <p:cNvPr id="82" name="">
             <a:extLst xmlns:a="http://schemas.openxmlformats.org/drawingml/2006/main">
               <a:ext uri="{FF2B5EF4-FFF2-40B4-BE49-F238E27FC236}">
-                <a16:creationId xmlns:a16="http://schemas.microsoft.com/office/drawing/2014/main" id="{3114C501-966D-4A2D-87C9-9E11E4E46A0B}"/>
+                <a16:creationId xmlns:a16="http://schemas.microsoft.com/office/drawing/2014/main" id="{C3ACA34E-D300-4F8D-81C5-AF8F81084BF3}"/>
               </a:ext>
             </a:extLst>
           </p:cNvPr>
@@ -4214,7 +4214,7 @@
           <p:cNvPr id="83" name="">
             <a:extLst xmlns:a="http://schemas.openxmlformats.org/drawingml/2006/main">
               <a:ext uri="{FF2B5EF4-FFF2-40B4-BE49-F238E27FC236}">
-                <a16:creationId xmlns:a16="http://schemas.microsoft.com/office/drawing/2014/main" id="{F234FFB5-FC2B-47E3-B609-D2D6529E56E1}"/>
+                <a16:creationId xmlns:a16="http://schemas.microsoft.com/office/drawing/2014/main" id="{80FA3B20-7F39-46B8-904E-2D38231A086A}"/>
               </a:ext>
             </a:extLst>
           </p:cNvPr>
@@ -4245,7 +4245,7 @@
           <p:cNvPr id="84" name="">
             <a:extLst xmlns:a="http://schemas.openxmlformats.org/drawingml/2006/main">
               <a:ext uri="{FF2B5EF4-FFF2-40B4-BE49-F238E27FC236}">
-                <a16:creationId xmlns:a16="http://schemas.microsoft.com/office/drawing/2014/main" id="{4ACF7FC4-2F7E-408C-AEE7-65A0696307A8}"/>
+                <a16:creationId xmlns:a16="http://schemas.microsoft.com/office/drawing/2014/main" id="{FE15EE19-535A-4EE9-8F49-0327A8897D9B}"/>
               </a:ext>
             </a:extLst>
           </p:cNvPr>
@@ -4276,7 +4276,7 @@
           <p:cNvPr id="85" name="">
             <a:extLst xmlns:a="http://schemas.openxmlformats.org/drawingml/2006/main">
               <a:ext uri="{FF2B5EF4-FFF2-40B4-BE49-F238E27FC236}">
-                <a16:creationId xmlns:a16="http://schemas.microsoft.com/office/drawing/2014/main" id="{7DAFD804-1CCB-495E-98EA-3B708C66C345}"/>
+                <a16:creationId xmlns:a16="http://schemas.microsoft.com/office/drawing/2014/main" id="{BD288A2B-CACF-42A9-98A6-D8797C2FF265}"/>
               </a:ext>
             </a:extLst>
           </p:cNvPr>
@@ -4307,7 +4307,7 @@
           <p:cNvPr id="86" name="">
             <a:extLst xmlns:a="http://schemas.openxmlformats.org/drawingml/2006/main">
               <a:ext uri="{FF2B5EF4-FFF2-40B4-BE49-F238E27FC236}">
-                <a16:creationId xmlns:a16="http://schemas.microsoft.com/office/drawing/2014/main" id="{06CF4F79-25E5-4952-93EB-945271F9FDBF}"/>
+                <a16:creationId xmlns:a16="http://schemas.microsoft.com/office/drawing/2014/main" id="{545FB3BF-9C7A-4198-9C8B-A2E91D892F04}"/>
               </a:ext>
             </a:extLst>
           </p:cNvPr>
@@ -4338,7 +4338,7 @@
           <p:cNvPr id="87" name="">
             <a:extLst xmlns:a="http://schemas.openxmlformats.org/drawingml/2006/main">
               <a:ext uri="{FF2B5EF4-FFF2-40B4-BE49-F238E27FC236}">
-                <a16:creationId xmlns:a16="http://schemas.microsoft.com/office/drawing/2014/main" id="{5B66B0C7-C40B-4EED-9803-B19A1257BF34}"/>
+                <a16:creationId xmlns:a16="http://schemas.microsoft.com/office/drawing/2014/main" id="{922AD5E7-010B-48C6-8CA9-DC1659D4BD0C}"/>
               </a:ext>
             </a:extLst>
           </p:cNvPr>
@@ -4369,7 +4369,7 @@
           <p:cNvPr id="88" name="">
             <a:extLst xmlns:a="http://schemas.openxmlformats.org/drawingml/2006/main">
               <a:ext uri="{FF2B5EF4-FFF2-40B4-BE49-F238E27FC236}">
-                <a16:creationId xmlns:a16="http://schemas.microsoft.com/office/drawing/2014/main" id="{37753B4A-2EE1-4E68-8D9C-45C28570E6BA}"/>
+                <a16:creationId xmlns:a16="http://schemas.microsoft.com/office/drawing/2014/main" id="{1DAE4EBF-7EBE-49F2-B23A-3469BD6F9DE5}"/>
               </a:ext>
             </a:extLst>
           </p:cNvPr>
@@ -4414,7 +4414,7 @@
           <p:cNvPr id="89" name="">
             <a:extLst xmlns:a="http://schemas.openxmlformats.org/drawingml/2006/main">
               <a:ext uri="{FF2B5EF4-FFF2-40B4-BE49-F238E27FC236}">
-                <a16:creationId xmlns:a16="http://schemas.microsoft.com/office/drawing/2014/main" id="{DE4F1387-9314-413C-A875-DE0406FBA512}"/>
+                <a16:creationId xmlns:a16="http://schemas.microsoft.com/office/drawing/2014/main" id="{FF3665F0-EB2B-41F6-BC2C-B3263CAB521F}"/>
               </a:ext>
             </a:extLst>
           </p:cNvPr>
@@ -4445,7 +4445,7 @@
           <p:cNvPr id="90" name="">
             <a:extLst xmlns:a="http://schemas.openxmlformats.org/drawingml/2006/main">
               <a:ext uri="{FF2B5EF4-FFF2-40B4-BE49-F238E27FC236}">
-                <a16:creationId xmlns:a16="http://schemas.microsoft.com/office/drawing/2014/main" id="{CDBEE17C-EDA6-42AF-9335-8EE7E5BE727F}"/>
+                <a16:creationId xmlns:a16="http://schemas.microsoft.com/office/drawing/2014/main" id="{3ADA6822-3B1E-410E-A931-6EE553BA5AE9}"/>
               </a:ext>
             </a:extLst>
           </p:cNvPr>
@@ -4490,7 +4490,7 @@
           <p:cNvPr id="91" name="">
             <a:extLst xmlns:a="http://schemas.openxmlformats.org/drawingml/2006/main">
               <a:ext uri="{FF2B5EF4-FFF2-40B4-BE49-F238E27FC236}">
-                <a16:creationId xmlns:a16="http://schemas.microsoft.com/office/drawing/2014/main" id="{20E459F3-D732-4BAA-AF7F-8C5ABDCBA0FE}"/>
+                <a16:creationId xmlns:a16="http://schemas.microsoft.com/office/drawing/2014/main" id="{F098037C-573E-4F55-944D-9446BFFA00D6}"/>
               </a:ext>
             </a:extLst>
           </p:cNvPr>
@@ -4535,7 +4535,7 @@
           <p:cNvPr id="92" name="">
             <a:extLst xmlns:a="http://schemas.openxmlformats.org/drawingml/2006/main">
               <a:ext uri="{FF2B5EF4-FFF2-40B4-BE49-F238E27FC236}">
-                <a16:creationId xmlns:a16="http://schemas.microsoft.com/office/drawing/2014/main" id="{AAC38EB6-E551-49FE-BF79-E49EB49417FB}"/>
+                <a16:creationId xmlns:a16="http://schemas.microsoft.com/office/drawing/2014/main" id="{E587D072-F6B9-46BF-BE5B-DD7979F90D4E}"/>
               </a:ext>
             </a:extLst>
           </p:cNvPr>
@@ -4566,7 +4566,7 @@
           <p:cNvPr id="93" name="">
             <a:extLst xmlns:a="http://schemas.openxmlformats.org/drawingml/2006/main">
               <a:ext uri="{FF2B5EF4-FFF2-40B4-BE49-F238E27FC236}">
-                <a16:creationId xmlns:a16="http://schemas.microsoft.com/office/drawing/2014/main" id="{685DD5A7-093F-428C-B58B-DFEBB9B8768D}"/>
+                <a16:creationId xmlns:a16="http://schemas.microsoft.com/office/drawing/2014/main" id="{A7A547DE-6F1C-4E07-9D49-397B930A1C77}"/>
               </a:ext>
             </a:extLst>
           </p:cNvPr>
@@ -4611,7 +4611,7 @@
           <p:cNvPr id="94" name="">
             <a:extLst xmlns:a="http://schemas.openxmlformats.org/drawingml/2006/main">
               <a:ext uri="{FF2B5EF4-FFF2-40B4-BE49-F238E27FC236}">
-                <a16:creationId xmlns:a16="http://schemas.microsoft.com/office/drawing/2014/main" id="{22DA8C73-CF99-45B6-AB9C-045E543A900D}"/>
+                <a16:creationId xmlns:a16="http://schemas.microsoft.com/office/drawing/2014/main" id="{1B6F9162-B99C-491D-B506-0791E38AD1B5}"/>
               </a:ext>
             </a:extLst>
           </p:cNvPr>
@@ -4656,7 +4656,7 @@
           <p:cNvPr id="95" name="">
             <a:extLst xmlns:a="http://schemas.openxmlformats.org/drawingml/2006/main">
               <a:ext uri="{FF2B5EF4-FFF2-40B4-BE49-F238E27FC236}">
-                <a16:creationId xmlns:a16="http://schemas.microsoft.com/office/drawing/2014/main" id="{3F672EBE-EDD4-45B8-8C23-B2BED06B1E79}"/>
+                <a16:creationId xmlns:a16="http://schemas.microsoft.com/office/drawing/2014/main" id="{2661CE09-DF93-49FC-8027-7BFEDF6C782B}"/>
               </a:ext>
             </a:extLst>
           </p:cNvPr>
@@ -4687,7 +4687,7 @@
           <p:cNvPr id="96" name="">
             <a:extLst xmlns:a="http://schemas.openxmlformats.org/drawingml/2006/main">
               <a:ext uri="{FF2B5EF4-FFF2-40B4-BE49-F238E27FC236}">
-                <a16:creationId xmlns:a16="http://schemas.microsoft.com/office/drawing/2014/main" id="{A796A616-B09B-4B6E-B4EE-A60534ED6103}"/>
+                <a16:creationId xmlns:a16="http://schemas.microsoft.com/office/drawing/2014/main" id="{05F365FA-8053-47E0-842D-43ABFBDD05F8}"/>
               </a:ext>
             </a:extLst>
           </p:cNvPr>
@@ -4732,7 +4732,7 @@
           <p:cNvPr id="97" name="">
             <a:extLst xmlns:a="http://schemas.openxmlformats.org/drawingml/2006/main">
               <a:ext uri="{FF2B5EF4-FFF2-40B4-BE49-F238E27FC236}">
-                <a16:creationId xmlns:a16="http://schemas.microsoft.com/office/drawing/2014/main" id="{8894DC39-EB2C-49F3-B5DB-836B0A1EA067}"/>
+                <a16:creationId xmlns:a16="http://schemas.microsoft.com/office/drawing/2014/main" id="{90F4BBEF-16F6-41E6-9D2D-7D66E6869682}"/>
               </a:ext>
             </a:extLst>
           </p:cNvPr>
@@ -4777,7 +4777,7 @@
           <p:cNvPr id="98" name="">
             <a:extLst xmlns:a="http://schemas.openxmlformats.org/drawingml/2006/main">
               <a:ext uri="{FF2B5EF4-FFF2-40B4-BE49-F238E27FC236}">
-                <a16:creationId xmlns:a16="http://schemas.microsoft.com/office/drawing/2014/main" id="{6E37A8D4-9001-4E6B-8DFB-D0B6102C41E5}"/>
+                <a16:creationId xmlns:a16="http://schemas.microsoft.com/office/drawing/2014/main" id="{8EC01B06-25CB-44A8-8A1F-BA68E03FA5AF}"/>
               </a:ext>
             </a:extLst>
           </p:cNvPr>
@@ -4808,7 +4808,7 @@
           <p:cNvPr id="99" name="">
             <a:extLst xmlns:a="http://schemas.openxmlformats.org/drawingml/2006/main">
               <a:ext uri="{FF2B5EF4-FFF2-40B4-BE49-F238E27FC236}">
-                <a16:creationId xmlns:a16="http://schemas.microsoft.com/office/drawing/2014/main" id="{5E3B589C-CFC3-467F-825B-51B748299BAC}"/>
+                <a16:creationId xmlns:a16="http://schemas.microsoft.com/office/drawing/2014/main" id="{0028027B-A76B-4FF0-A79E-FD86B75098ED}"/>
               </a:ext>
             </a:extLst>
           </p:cNvPr>
@@ -4853,7 +4853,7 @@
           <p:cNvPr id="100" name="">
             <a:extLst xmlns:a="http://schemas.openxmlformats.org/drawingml/2006/main">
               <a:ext uri="{FF2B5EF4-FFF2-40B4-BE49-F238E27FC236}">
-                <a16:creationId xmlns:a16="http://schemas.microsoft.com/office/drawing/2014/main" id="{8621531A-5B2B-4A6E-AB60-606CE7AB6DA9}"/>
+                <a16:creationId xmlns:a16="http://schemas.microsoft.com/office/drawing/2014/main" id="{9CA5D626-09B5-4E4B-AF35-E8A6CE5A568C}"/>
               </a:ext>
             </a:extLst>
           </p:cNvPr>
@@ -4898,7 +4898,7 @@
           <p:cNvPr id="101" name="">
             <a:extLst xmlns:a="http://schemas.openxmlformats.org/drawingml/2006/main">
               <a:ext uri="{FF2B5EF4-FFF2-40B4-BE49-F238E27FC236}">
-                <a16:creationId xmlns:a16="http://schemas.microsoft.com/office/drawing/2014/main" id="{244F5A61-FBA1-49F4-8169-287217DBBAC7}"/>
+                <a16:creationId xmlns:a16="http://schemas.microsoft.com/office/drawing/2014/main" id="{A817F9E8-990D-4B81-B47B-63A5911D7684}"/>
               </a:ext>
             </a:extLst>
           </p:cNvPr>
@@ -4943,7 +4943,7 @@
           <p:cNvPr id="102" name="">
             <a:extLst xmlns:a="http://schemas.openxmlformats.org/drawingml/2006/main">
               <a:ext uri="{FF2B5EF4-FFF2-40B4-BE49-F238E27FC236}">
-                <a16:creationId xmlns:a16="http://schemas.microsoft.com/office/drawing/2014/main" id="{C726DC9B-68E1-438B-85E7-91912F9F21EC}"/>
+                <a16:creationId xmlns:a16="http://schemas.microsoft.com/office/drawing/2014/main" id="{DCFC8648-D70A-452C-9675-09D79071D178}"/>
               </a:ext>
             </a:extLst>
           </p:cNvPr>
@@ -4974,7 +4974,7 @@
           <p:cNvPr id="103" name="">
             <a:extLst xmlns:a="http://schemas.openxmlformats.org/drawingml/2006/main">
               <a:ext uri="{FF2B5EF4-FFF2-40B4-BE49-F238E27FC236}">
-                <a16:creationId xmlns:a16="http://schemas.microsoft.com/office/drawing/2014/main" id="{859B8987-C6AA-410E-8896-F89635AE053D}"/>
+                <a16:creationId xmlns:a16="http://schemas.microsoft.com/office/drawing/2014/main" id="{F8A11F18-1CE6-46D2-A3D0-ED8C223CDC91}"/>
               </a:ext>
             </a:extLst>
           </p:cNvPr>
@@ -5019,7 +5019,7 @@
           <p:cNvPr id="104" name="">
             <a:extLst xmlns:a="http://schemas.openxmlformats.org/drawingml/2006/main">
               <a:ext uri="{FF2B5EF4-FFF2-40B4-BE49-F238E27FC236}">
-                <a16:creationId xmlns:a16="http://schemas.microsoft.com/office/drawing/2014/main" id="{25271649-7277-4FCA-B628-A0547C04DCFE}"/>
+                <a16:creationId xmlns:a16="http://schemas.microsoft.com/office/drawing/2014/main" id="{89BABD64-FC23-46E7-A752-AD92AE256CB6}"/>
               </a:ext>
             </a:extLst>
           </p:cNvPr>
@@ -5062,7 +5062,7 @@
     </p:spTree>
     <p:extLst>
       <p:ext uri="{BB962C8B-B14F-4D97-AF65-F5344CB8AC3E}">
-        <p14:creationId xmlns:p14="http://schemas.microsoft.com/office/powerpoint/2010/main" val="537065769"/>
+        <p14:creationId xmlns:p14="http://schemas.microsoft.com/office/powerpoint/2010/main" val="209612940"/>
       </p:ext>
     </p:extLst>
   </p:cSld>
@@ -5086,7 +5086,7 @@
           <p:cNvPr id="41" name="">
             <a:extLst xmlns:a="http://schemas.openxmlformats.org/drawingml/2006/main">
               <a:ext uri="{FF2B5EF4-FFF2-40B4-BE49-F238E27FC236}">
-                <a16:creationId xmlns:a16="http://schemas.microsoft.com/office/drawing/2014/main" id="{D3434ED8-F7C4-484D-8F6A-602772FB3BB1}"/>
+                <a16:creationId xmlns:a16="http://schemas.microsoft.com/office/drawing/2014/main" id="{74AC6C45-D171-450E-8420-FBB9BBCEAF96}"/>
               </a:ext>
             </a:extLst>
           </p:cNvPr>
@@ -5117,7 +5117,7 @@
           <p:cNvPr id="2" name="">
             <a:extLst xmlns:a="http://schemas.openxmlformats.org/drawingml/2006/main">
               <a:ext uri="{FF2B5EF4-FFF2-40B4-BE49-F238E27FC236}">
-                <a16:creationId xmlns:a16="http://schemas.microsoft.com/office/drawing/2014/main" id="{255ED43D-4A39-42B7-855D-1DEEAF6EC991}"/>
+                <a16:creationId xmlns:a16="http://schemas.microsoft.com/office/drawing/2014/main" id="{F9C73937-AFC9-4311-BC1B-7279C0D03E61}"/>
               </a:ext>
             </a:extLst>
           </p:cNvPr>
@@ -5162,7 +5162,7 @@
           <p:cNvPr id="3" name="">
             <a:extLst xmlns:a="http://schemas.openxmlformats.org/drawingml/2006/main">
               <a:ext uri="{FF2B5EF4-FFF2-40B4-BE49-F238E27FC236}">
-                <a16:creationId xmlns:a16="http://schemas.microsoft.com/office/drawing/2014/main" id="{F50349E4-9C95-4572-B9C4-A960ADB952E4}"/>
+                <a16:creationId xmlns:a16="http://schemas.microsoft.com/office/drawing/2014/main" id="{B76ECF22-E464-4181-BB54-6CE594C2E601}"/>
               </a:ext>
             </a:extLst>
           </p:cNvPr>
@@ -5207,7 +5207,7 @@
           <p:cNvPr id="4" name="">
             <a:extLst xmlns:a="http://schemas.openxmlformats.org/drawingml/2006/main">
               <a:ext uri="{FF2B5EF4-FFF2-40B4-BE49-F238E27FC236}">
-                <a16:creationId xmlns:a16="http://schemas.microsoft.com/office/drawing/2014/main" id="{32F5AA81-2697-4B0F-8A83-52CE607E6304}"/>
+                <a16:creationId xmlns:a16="http://schemas.microsoft.com/office/drawing/2014/main" id="{976833EA-8E6F-42AD-A4D7-6531371B10FC}"/>
               </a:ext>
             </a:extLst>
           </p:cNvPr>
@@ -5252,7 +5252,7 @@
           <p:cNvPr id="5" name="">
             <a:extLst xmlns:a="http://schemas.openxmlformats.org/drawingml/2006/main">
               <a:ext uri="{FF2B5EF4-FFF2-40B4-BE49-F238E27FC236}">
-                <a16:creationId xmlns:a16="http://schemas.microsoft.com/office/drawing/2014/main" id="{54152E8E-6E7D-4EE5-B6C3-8B629057B1F9}"/>
+                <a16:creationId xmlns:a16="http://schemas.microsoft.com/office/drawing/2014/main" id="{CA81D0DA-D79A-4125-B3D3-7D0FB0D8DB3E}"/>
               </a:ext>
             </a:extLst>
           </p:cNvPr>
@@ -5283,7 +5283,7 @@
           <p:cNvPr id="6" name="">
             <a:extLst xmlns:a="http://schemas.openxmlformats.org/drawingml/2006/main">
               <a:ext uri="{FF2B5EF4-FFF2-40B4-BE49-F238E27FC236}">
-                <a16:creationId xmlns:a16="http://schemas.microsoft.com/office/drawing/2014/main" id="{C08C9222-9EA3-4242-9B53-65273C500B86}"/>
+                <a16:creationId xmlns:a16="http://schemas.microsoft.com/office/drawing/2014/main" id="{CC8384F1-9E8B-45A2-8FEC-D215B3C32A03}"/>
               </a:ext>
             </a:extLst>
           </p:cNvPr>
@@ -5314,7 +5314,7 @@
           <p:cNvPr id="7" name="">
             <a:extLst xmlns:a="http://schemas.openxmlformats.org/drawingml/2006/main">
               <a:ext uri="{FF2B5EF4-FFF2-40B4-BE49-F238E27FC236}">
-                <a16:creationId xmlns:a16="http://schemas.microsoft.com/office/drawing/2014/main" id="{97777C47-E5A1-498C-AD99-5214A6BB5B01}"/>
+                <a16:creationId xmlns:a16="http://schemas.microsoft.com/office/drawing/2014/main" id="{7E1A74FF-948F-4614-A3FD-8BDB079BEC0F}"/>
               </a:ext>
             </a:extLst>
           </p:cNvPr>
@@ -5359,7 +5359,7 @@
           <p:cNvPr id="8" name="">
             <a:extLst xmlns:a="http://schemas.openxmlformats.org/drawingml/2006/main">
               <a:ext uri="{FF2B5EF4-FFF2-40B4-BE49-F238E27FC236}">
-                <a16:creationId xmlns:a16="http://schemas.microsoft.com/office/drawing/2014/main" id="{6BC80FAE-5981-4946-8A46-0BB2AB02E06A}"/>
+                <a16:creationId xmlns:a16="http://schemas.microsoft.com/office/drawing/2014/main" id="{CD566D9D-FD11-4166-B400-326E73C3EB2F}"/>
               </a:ext>
             </a:extLst>
           </p:cNvPr>
@@ -5404,7 +5404,7 @@
           <p:cNvPr id="9" name="">
             <a:extLst xmlns:a="http://schemas.openxmlformats.org/drawingml/2006/main">
               <a:ext uri="{FF2B5EF4-FFF2-40B4-BE49-F238E27FC236}">
-                <a16:creationId xmlns:a16="http://schemas.microsoft.com/office/drawing/2014/main" id="{B8AC489D-5604-430B-8978-052A1E901191}"/>
+                <a16:creationId xmlns:a16="http://schemas.microsoft.com/office/drawing/2014/main" id="{B12623F3-9673-4398-9935-02A5DA4D0BB0}"/>
               </a:ext>
             </a:extLst>
           </p:cNvPr>
@@ -5439,7 +5439,7 @@
           <p:cNvPr id="10" name="">
             <a:extLst xmlns:a="http://schemas.openxmlformats.org/drawingml/2006/main">
               <a:ext uri="{FF2B5EF4-FFF2-40B4-BE49-F238E27FC236}">
-                <a16:creationId xmlns:a16="http://schemas.microsoft.com/office/drawing/2014/main" id="{F13EF6A8-EA02-48A2-9DAF-57FA0551A5B4}"/>
+                <a16:creationId xmlns:a16="http://schemas.microsoft.com/office/drawing/2014/main" id="{4121FA96-0DF0-4076-9F02-1AC8A8DA8F37}"/>
               </a:ext>
             </a:extLst>
           </p:cNvPr>
@@ -5484,7 +5484,7 @@
           <p:cNvPr id="11" name="">
             <a:extLst xmlns:a="http://schemas.openxmlformats.org/drawingml/2006/main">
               <a:ext uri="{FF2B5EF4-FFF2-40B4-BE49-F238E27FC236}">
-                <a16:creationId xmlns:a16="http://schemas.microsoft.com/office/drawing/2014/main" id="{2ECB87A3-63CF-4617-A651-FFAE03F8A366}"/>
+                <a16:creationId xmlns:a16="http://schemas.microsoft.com/office/drawing/2014/main" id="{75330FCA-9EC2-4C88-AC55-FEEDC2636CAE}"/>
               </a:ext>
             </a:extLst>
           </p:cNvPr>
@@ -5529,7 +5529,7 @@
           <p:cNvPr id="12" name="">
             <a:extLst xmlns:a="http://schemas.openxmlformats.org/drawingml/2006/main">
               <a:ext uri="{FF2B5EF4-FFF2-40B4-BE49-F238E27FC236}">
-                <a16:creationId xmlns:a16="http://schemas.microsoft.com/office/drawing/2014/main" id="{99637AC5-9D77-4BA4-A34C-1B1C7EF2E87E}"/>
+                <a16:creationId xmlns:a16="http://schemas.microsoft.com/office/drawing/2014/main" id="{511E4C3D-1856-4A02-99FE-5F1774D9BE90}"/>
               </a:ext>
             </a:extLst>
           </p:cNvPr>
@@ -5574,7 +5574,7 @@
           <p:cNvPr id="13" name="">
             <a:extLst xmlns:a="http://schemas.openxmlformats.org/drawingml/2006/main">
               <a:ext uri="{FF2B5EF4-FFF2-40B4-BE49-F238E27FC236}">
-                <a16:creationId xmlns:a16="http://schemas.microsoft.com/office/drawing/2014/main" id="{2C778629-6080-4238-8104-3F24C47999FC}"/>
+                <a16:creationId xmlns:a16="http://schemas.microsoft.com/office/drawing/2014/main" id="{27C143A0-4539-40ED-B6D9-9524390E7B97}"/>
               </a:ext>
             </a:extLst>
           </p:cNvPr>
@@ -5609,7 +5609,7 @@
           <p:cNvPr id="14" name="">
             <a:extLst xmlns:a="http://schemas.openxmlformats.org/drawingml/2006/main">
               <a:ext uri="{FF2B5EF4-FFF2-40B4-BE49-F238E27FC236}">
-                <a16:creationId xmlns:a16="http://schemas.microsoft.com/office/drawing/2014/main" id="{075DCA52-1DCB-465D-A1B2-EC401645A749}"/>
+                <a16:creationId xmlns:a16="http://schemas.microsoft.com/office/drawing/2014/main" id="{590CEFAC-AD9F-4894-8FC7-523C1936F5A3}"/>
               </a:ext>
             </a:extLst>
           </p:cNvPr>
@@ -5654,7 +5654,7 @@
           <p:cNvPr id="15" name="">
             <a:extLst xmlns:a="http://schemas.openxmlformats.org/drawingml/2006/main">
               <a:ext uri="{FF2B5EF4-FFF2-40B4-BE49-F238E27FC236}">
-                <a16:creationId xmlns:a16="http://schemas.microsoft.com/office/drawing/2014/main" id="{432BEC9F-158C-472A-832A-14EC774FAD7E}"/>
+                <a16:creationId xmlns:a16="http://schemas.microsoft.com/office/drawing/2014/main" id="{05EE4B79-31F0-448D-B758-A1F153EC8D22}"/>
               </a:ext>
             </a:extLst>
           </p:cNvPr>
@@ -5699,7 +5699,7 @@
           <p:cNvPr id="16" name="">
             <a:extLst xmlns:a="http://schemas.openxmlformats.org/drawingml/2006/main">
               <a:ext uri="{FF2B5EF4-FFF2-40B4-BE49-F238E27FC236}">
-                <a16:creationId xmlns:a16="http://schemas.microsoft.com/office/drawing/2014/main" id="{84D26642-D141-43F9-86D4-BAA6F14303B5}"/>
+                <a16:creationId xmlns:a16="http://schemas.microsoft.com/office/drawing/2014/main" id="{A02125A5-C237-41DE-B1AC-77D42673C632}"/>
               </a:ext>
             </a:extLst>
           </p:cNvPr>
@@ -5744,7 +5744,7 @@
           <p:cNvPr id="17" name="">
             <a:extLst xmlns:a="http://schemas.openxmlformats.org/drawingml/2006/main">
               <a:ext uri="{FF2B5EF4-FFF2-40B4-BE49-F238E27FC236}">
-                <a16:creationId xmlns:a16="http://schemas.microsoft.com/office/drawing/2014/main" id="{79423591-F9A2-4335-9501-D928C12F0247}"/>
+                <a16:creationId xmlns:a16="http://schemas.microsoft.com/office/drawing/2014/main" id="{C62CDB25-0CE5-427A-B0A6-342089C3126F}"/>
               </a:ext>
             </a:extLst>
           </p:cNvPr>
@@ -5779,7 +5779,7 @@
           <p:cNvPr id="18" name="">
             <a:extLst xmlns:a="http://schemas.openxmlformats.org/drawingml/2006/main">
               <a:ext uri="{FF2B5EF4-FFF2-40B4-BE49-F238E27FC236}">
-                <a16:creationId xmlns:a16="http://schemas.microsoft.com/office/drawing/2014/main" id="{ACD23DDC-B327-4397-B588-F67AAAA67510}"/>
+                <a16:creationId xmlns:a16="http://schemas.microsoft.com/office/drawing/2014/main" id="{2703B159-F8E2-4864-A8F7-C356F6F063C4}"/>
               </a:ext>
             </a:extLst>
           </p:cNvPr>
@@ -5824,7 +5824,7 @@
           <p:cNvPr id="19" name="">
             <a:extLst xmlns:a="http://schemas.openxmlformats.org/drawingml/2006/main">
               <a:ext uri="{FF2B5EF4-FFF2-40B4-BE49-F238E27FC236}">
-                <a16:creationId xmlns:a16="http://schemas.microsoft.com/office/drawing/2014/main" id="{13455D68-A525-4E47-8BCF-B8764C1E8C5A}"/>
+                <a16:creationId xmlns:a16="http://schemas.microsoft.com/office/drawing/2014/main" id="{7F587CFD-5495-4DA8-A22E-B9567BFF89DF}"/>
               </a:ext>
             </a:extLst>
           </p:cNvPr>
@@ -5869,7 +5869,7 @@
           <p:cNvPr id="20" name="">
             <a:extLst xmlns:a="http://schemas.openxmlformats.org/drawingml/2006/main">
               <a:ext uri="{FF2B5EF4-FFF2-40B4-BE49-F238E27FC236}">
-                <a16:creationId xmlns:a16="http://schemas.microsoft.com/office/drawing/2014/main" id="{69320E5C-9A88-4BB4-A1D7-37F4ACA04252}"/>
+                <a16:creationId xmlns:a16="http://schemas.microsoft.com/office/drawing/2014/main" id="{FFD3AF11-3747-4D3F-87FD-664B8AF5CC58}"/>
               </a:ext>
             </a:extLst>
           </p:cNvPr>
@@ -5914,7 +5914,7 @@
           <p:cNvPr id="21" name="">
             <a:extLst xmlns:a="http://schemas.openxmlformats.org/drawingml/2006/main">
               <a:ext uri="{FF2B5EF4-FFF2-40B4-BE49-F238E27FC236}">
-                <a16:creationId xmlns:a16="http://schemas.microsoft.com/office/drawing/2014/main" id="{D5CF3954-5054-417B-AD4B-62F2046C5D8F}"/>
+                <a16:creationId xmlns:a16="http://schemas.microsoft.com/office/drawing/2014/main" id="{05172309-AF6B-4B57-A572-5C0A85994DB8}"/>
               </a:ext>
             </a:extLst>
           </p:cNvPr>
@@ -5949,7 +5949,7 @@
           <p:cNvPr id="22" name="">
             <a:extLst xmlns:a="http://schemas.openxmlformats.org/drawingml/2006/main">
               <a:ext uri="{FF2B5EF4-FFF2-40B4-BE49-F238E27FC236}">
-                <a16:creationId xmlns:a16="http://schemas.microsoft.com/office/drawing/2014/main" id="{F41F020E-DD86-455C-B6E7-03325BEF2B59}"/>
+                <a16:creationId xmlns:a16="http://schemas.microsoft.com/office/drawing/2014/main" id="{9C3D6B7D-3827-40BE-8B7C-C1CBB2281821}"/>
               </a:ext>
             </a:extLst>
           </p:cNvPr>
@@ -5994,7 +5994,7 @@
           <p:cNvPr id="23" name="">
             <a:extLst xmlns:a="http://schemas.openxmlformats.org/drawingml/2006/main">
               <a:ext uri="{FF2B5EF4-FFF2-40B4-BE49-F238E27FC236}">
-                <a16:creationId xmlns:a16="http://schemas.microsoft.com/office/drawing/2014/main" id="{DEAD2344-3576-48DF-8018-C96FB1BE0F66}"/>
+                <a16:creationId xmlns:a16="http://schemas.microsoft.com/office/drawing/2014/main" id="{B30D0BC3-8A06-4DCF-8DAC-D94F4E3DD44D}"/>
               </a:ext>
             </a:extLst>
           </p:cNvPr>
@@ -6039,7 +6039,7 @@
           <p:cNvPr id="24" name="">
             <a:extLst xmlns:a="http://schemas.openxmlformats.org/drawingml/2006/main">
               <a:ext uri="{FF2B5EF4-FFF2-40B4-BE49-F238E27FC236}">
-                <a16:creationId xmlns:a16="http://schemas.microsoft.com/office/drawing/2014/main" id="{72270BEA-EA3B-4A3D-89D4-3F1207113ADB}"/>
+                <a16:creationId xmlns:a16="http://schemas.microsoft.com/office/drawing/2014/main" id="{D8ACC1C3-296E-47E2-8FD0-13EF6E4F7979}"/>
               </a:ext>
             </a:extLst>
           </p:cNvPr>
@@ -6084,7 +6084,7 @@
           <p:cNvPr id="25" name="">
             <a:extLst xmlns:a="http://schemas.openxmlformats.org/drawingml/2006/main">
               <a:ext uri="{FF2B5EF4-FFF2-40B4-BE49-F238E27FC236}">
-                <a16:creationId xmlns:a16="http://schemas.microsoft.com/office/drawing/2014/main" id="{B02B4CB6-2BB1-4986-9503-0E60ECA3F99A}"/>
+                <a16:creationId xmlns:a16="http://schemas.microsoft.com/office/drawing/2014/main" id="{1C3497B0-E249-47B0-B846-388D505D506F}"/>
               </a:ext>
             </a:extLst>
           </p:cNvPr>
@@ -6119,7 +6119,7 @@
           <p:cNvPr id="26" name="">
             <a:extLst xmlns:a="http://schemas.openxmlformats.org/drawingml/2006/main">
               <a:ext uri="{FF2B5EF4-FFF2-40B4-BE49-F238E27FC236}">
-                <a16:creationId xmlns:a16="http://schemas.microsoft.com/office/drawing/2014/main" id="{8C105B54-EF49-4D9C-B4B6-53B72ACA7F41}"/>
+                <a16:creationId xmlns:a16="http://schemas.microsoft.com/office/drawing/2014/main" id="{27CA5388-E972-4979-B9B9-DE1D7D094957}"/>
               </a:ext>
             </a:extLst>
           </p:cNvPr>
@@ -6150,7 +6150,7 @@
           <p:cNvPr id="27" name="">
             <a:extLst xmlns:a="http://schemas.openxmlformats.org/drawingml/2006/main">
               <a:ext uri="{FF2B5EF4-FFF2-40B4-BE49-F238E27FC236}">
-                <a16:creationId xmlns:a16="http://schemas.microsoft.com/office/drawing/2014/main" id="{558CD087-079F-4045-AADA-36914E7C1D6C}"/>
+                <a16:creationId xmlns:a16="http://schemas.microsoft.com/office/drawing/2014/main" id="{1EE91E95-87DE-41BF-8B99-01727AA29636}"/>
               </a:ext>
             </a:extLst>
           </p:cNvPr>
@@ -6195,7 +6195,7 @@
           <p:cNvPr id="28" name="">
             <a:extLst xmlns:a="http://schemas.openxmlformats.org/drawingml/2006/main">
               <a:ext uri="{FF2B5EF4-FFF2-40B4-BE49-F238E27FC236}">
-                <a16:creationId xmlns:a16="http://schemas.microsoft.com/office/drawing/2014/main" id="{D5668F36-C480-4BE7-B086-771891DBBDF6}"/>
+                <a16:creationId xmlns:a16="http://schemas.microsoft.com/office/drawing/2014/main" id="{1D9F17E5-9206-4518-B970-0C8ADE0CD013}"/>
               </a:ext>
             </a:extLst>
           </p:cNvPr>
@@ -6240,7 +6240,7 @@
           <p:cNvPr id="29" name="">
             <a:extLst xmlns:a="http://schemas.openxmlformats.org/drawingml/2006/main">
               <a:ext uri="{FF2B5EF4-FFF2-40B4-BE49-F238E27FC236}">
-                <a16:creationId xmlns:a16="http://schemas.microsoft.com/office/drawing/2014/main" id="{03876328-62A5-464B-9297-7E3A2EDEF8FC}"/>
+                <a16:creationId xmlns:a16="http://schemas.microsoft.com/office/drawing/2014/main" id="{8043760E-B462-4D2C-8700-41ED7A913B58}"/>
               </a:ext>
             </a:extLst>
           </p:cNvPr>
@@ -6275,7 +6275,7 @@
           <p:cNvPr id="30" name="">
             <a:extLst xmlns:a="http://schemas.openxmlformats.org/drawingml/2006/main">
               <a:ext uri="{FF2B5EF4-FFF2-40B4-BE49-F238E27FC236}">
-                <a16:creationId xmlns:a16="http://schemas.microsoft.com/office/drawing/2014/main" id="{319ED984-A984-4174-946C-C37C2B5A4D13}"/>
+                <a16:creationId xmlns:a16="http://schemas.microsoft.com/office/drawing/2014/main" id="{C992ED84-D899-4A09-B46C-D82A336A7A0A}"/>
               </a:ext>
             </a:extLst>
           </p:cNvPr>
@@ -6306,7 +6306,7 @@
           <p:cNvPr id="31" name="">
             <a:extLst xmlns:a="http://schemas.openxmlformats.org/drawingml/2006/main">
               <a:ext uri="{FF2B5EF4-FFF2-40B4-BE49-F238E27FC236}">
-                <a16:creationId xmlns:a16="http://schemas.microsoft.com/office/drawing/2014/main" id="{92C00489-884B-43A2-B96A-7DA8B3797506}"/>
+                <a16:creationId xmlns:a16="http://schemas.microsoft.com/office/drawing/2014/main" id="{C2B18EA1-5A4D-4C97-8BBE-F2154E556536}"/>
               </a:ext>
             </a:extLst>
           </p:cNvPr>
@@ -6351,7 +6351,7 @@
           <p:cNvPr id="32" name="">
             <a:extLst xmlns:a="http://schemas.openxmlformats.org/drawingml/2006/main">
               <a:ext uri="{FF2B5EF4-FFF2-40B4-BE49-F238E27FC236}">
-                <a16:creationId xmlns:a16="http://schemas.microsoft.com/office/drawing/2014/main" id="{0E490819-D1E9-4899-A84C-4C0BA0736528}"/>
+                <a16:creationId xmlns:a16="http://schemas.microsoft.com/office/drawing/2014/main" id="{997014A7-A074-4D9C-BEBC-F34A8CE1728D}"/>
               </a:ext>
             </a:extLst>
           </p:cNvPr>
@@ -6396,7 +6396,7 @@
           <p:cNvPr id="33" name="">
             <a:extLst xmlns:a="http://schemas.openxmlformats.org/drawingml/2006/main">
               <a:ext uri="{FF2B5EF4-FFF2-40B4-BE49-F238E27FC236}">
-                <a16:creationId xmlns:a16="http://schemas.microsoft.com/office/drawing/2014/main" id="{C50C598D-A337-4940-8CD1-60AB9146490B}"/>
+                <a16:creationId xmlns:a16="http://schemas.microsoft.com/office/drawing/2014/main" id="{791035A8-72CC-40C3-B4B4-228F1AE4A432}"/>
               </a:ext>
             </a:extLst>
           </p:cNvPr>
@@ -6431,7 +6431,7 @@
           <p:cNvPr id="34" name="">
             <a:extLst xmlns:a="http://schemas.openxmlformats.org/drawingml/2006/main">
               <a:ext uri="{FF2B5EF4-FFF2-40B4-BE49-F238E27FC236}">
-                <a16:creationId xmlns:a16="http://schemas.microsoft.com/office/drawing/2014/main" id="{59A00A4F-90BB-4593-932D-96EE20BA65CB}"/>
+                <a16:creationId xmlns:a16="http://schemas.microsoft.com/office/drawing/2014/main" id="{91099C36-62B0-406B-A2D5-09A774DB0BD3}"/>
               </a:ext>
             </a:extLst>
           </p:cNvPr>
@@ -6462,7 +6462,7 @@
           <p:cNvPr id="35" name="">
             <a:extLst xmlns:a="http://schemas.openxmlformats.org/drawingml/2006/main">
               <a:ext uri="{FF2B5EF4-FFF2-40B4-BE49-F238E27FC236}">
-                <a16:creationId xmlns:a16="http://schemas.microsoft.com/office/drawing/2014/main" id="{064B5222-BE3C-49FD-86BD-8686EDAE8CB0}"/>
+                <a16:creationId xmlns:a16="http://schemas.microsoft.com/office/drawing/2014/main" id="{57643653-2951-4ABF-9EE7-89DF4A51C5B4}"/>
               </a:ext>
             </a:extLst>
           </p:cNvPr>
@@ -6507,7 +6507,7 @@
           <p:cNvPr id="36" name="">
             <a:extLst xmlns:a="http://schemas.openxmlformats.org/drawingml/2006/main">
               <a:ext uri="{FF2B5EF4-FFF2-40B4-BE49-F238E27FC236}">
-                <a16:creationId xmlns:a16="http://schemas.microsoft.com/office/drawing/2014/main" id="{150AAB8A-BE8D-4BB1-8F7C-808ED1D9B957}"/>
+                <a16:creationId xmlns:a16="http://schemas.microsoft.com/office/drawing/2014/main" id="{C33C86B3-1CCA-4EB3-A012-4B08A83BE28C}"/>
               </a:ext>
             </a:extLst>
           </p:cNvPr>
@@ -6552,7 +6552,7 @@
           <p:cNvPr id="37" name="">
             <a:extLst xmlns:a="http://schemas.openxmlformats.org/drawingml/2006/main">
               <a:ext uri="{FF2B5EF4-FFF2-40B4-BE49-F238E27FC236}">
-                <a16:creationId xmlns:a16="http://schemas.microsoft.com/office/drawing/2014/main" id="{08F86912-7705-4B60-B707-0F9A52801D8D}"/>
+                <a16:creationId xmlns:a16="http://schemas.microsoft.com/office/drawing/2014/main" id="{B7556A17-3A81-445E-8538-022C5F5318D1}"/>
               </a:ext>
             </a:extLst>
           </p:cNvPr>
@@ -6583,7 +6583,7 @@
           <p:cNvPr id="38" name="">
             <a:extLst xmlns:a="http://schemas.openxmlformats.org/drawingml/2006/main">
               <a:ext uri="{FF2B5EF4-FFF2-40B4-BE49-F238E27FC236}">
-                <a16:creationId xmlns:a16="http://schemas.microsoft.com/office/drawing/2014/main" id="{B6F72672-457C-4094-B4B8-7D90557F6209}"/>
+                <a16:creationId xmlns:a16="http://schemas.microsoft.com/office/drawing/2014/main" id="{94F017A9-7C4C-46E2-A763-CD1F880CD32B}"/>
               </a:ext>
             </a:extLst>
           </p:cNvPr>
@@ -6614,7 +6614,7 @@
           <p:cNvPr id="39" name="">
             <a:extLst xmlns:a="http://schemas.openxmlformats.org/drawingml/2006/main">
               <a:ext uri="{FF2B5EF4-FFF2-40B4-BE49-F238E27FC236}">
-                <a16:creationId xmlns:a16="http://schemas.microsoft.com/office/drawing/2014/main" id="{8C508CCC-3072-4B01-94D5-EB69904B3A5D}"/>
+                <a16:creationId xmlns:a16="http://schemas.microsoft.com/office/drawing/2014/main" id="{74030647-8408-4C39-AFF3-EEBC5DF4BF1A}"/>
               </a:ext>
             </a:extLst>
           </p:cNvPr>
@@ -6659,7 +6659,7 @@
           <p:cNvPr id="40" name="">
             <a:extLst xmlns:a="http://schemas.openxmlformats.org/drawingml/2006/main">
               <a:ext uri="{FF2B5EF4-FFF2-40B4-BE49-F238E27FC236}">
-                <a16:creationId xmlns:a16="http://schemas.microsoft.com/office/drawing/2014/main" id="{A03FD764-1E7F-4C39-8FE5-F25B679B9E5E}"/>
+                <a16:creationId xmlns:a16="http://schemas.microsoft.com/office/drawing/2014/main" id="{800F0CA2-9B60-4708-8ECE-60827BBA749E}"/>
               </a:ext>
             </a:extLst>
           </p:cNvPr>
@@ -6702,7 +6702,7 @@
     </p:spTree>
     <p:extLst>
       <p:ext uri="{BB962C8B-B14F-4D97-AF65-F5344CB8AC3E}">
-        <p14:creationId xmlns:p14="http://schemas.microsoft.com/office/powerpoint/2010/main" val="594392731"/>
+        <p14:creationId xmlns:p14="http://schemas.microsoft.com/office/powerpoint/2010/main" val="940014361"/>
       </p:ext>
     </p:extLst>
   </p:cSld>
@@ -6726,7 +6726,7 @@
           <p:cNvPr id="30" name="">
             <a:extLst xmlns:a="http://schemas.openxmlformats.org/drawingml/2006/main">
               <a:ext uri="{FF2B5EF4-FFF2-40B4-BE49-F238E27FC236}">
-                <a16:creationId xmlns:a16="http://schemas.microsoft.com/office/drawing/2014/main" id="{D9176C6F-661B-4BC3-A17A-E0C495947829}"/>
+                <a16:creationId xmlns:a16="http://schemas.microsoft.com/office/drawing/2014/main" id="{23CA1342-D84A-4B0E-96EB-C96C08931A43}"/>
               </a:ext>
             </a:extLst>
           </p:cNvPr>
@@ -6757,7 +6757,7 @@
           <p:cNvPr id="2" name="">
             <a:extLst xmlns:a="http://schemas.openxmlformats.org/drawingml/2006/main">
               <a:ext uri="{FF2B5EF4-FFF2-40B4-BE49-F238E27FC236}">
-                <a16:creationId xmlns:a16="http://schemas.microsoft.com/office/drawing/2014/main" id="{7C1C1EBD-8D4F-45D4-A71E-FE5F472591A9}"/>
+                <a16:creationId xmlns:a16="http://schemas.microsoft.com/office/drawing/2014/main" id="{0A90E4CC-ED65-4839-A939-F93127630A80}"/>
               </a:ext>
             </a:extLst>
           </p:cNvPr>
@@ -6802,7 +6802,7 @@
           <p:cNvPr id="3" name="">
             <a:extLst xmlns:a="http://schemas.openxmlformats.org/drawingml/2006/main">
               <a:ext uri="{FF2B5EF4-FFF2-40B4-BE49-F238E27FC236}">
-                <a16:creationId xmlns:a16="http://schemas.microsoft.com/office/drawing/2014/main" id="{8DA86440-D7BA-4BFB-9879-51F50417DFA8}"/>
+                <a16:creationId xmlns:a16="http://schemas.microsoft.com/office/drawing/2014/main" id="{B1D566B3-8110-497B-8A09-6D74E36960AD}"/>
               </a:ext>
             </a:extLst>
           </p:cNvPr>
@@ -6847,7 +6847,7 @@
           <p:cNvPr id="4" name="">
             <a:extLst xmlns:a="http://schemas.openxmlformats.org/drawingml/2006/main">
               <a:ext uri="{FF2B5EF4-FFF2-40B4-BE49-F238E27FC236}">
-                <a16:creationId xmlns:a16="http://schemas.microsoft.com/office/drawing/2014/main" id="{8F931A2F-E407-440C-9687-8E3C2AAADC25}"/>
+                <a16:creationId xmlns:a16="http://schemas.microsoft.com/office/drawing/2014/main" id="{EC124CFD-5BC9-4D29-86A5-6A18789548BE}"/>
               </a:ext>
             </a:extLst>
           </p:cNvPr>
@@ -6892,7 +6892,7 @@
           <p:cNvPr id="5" name="">
             <a:extLst xmlns:a="http://schemas.openxmlformats.org/drawingml/2006/main">
               <a:ext uri="{FF2B5EF4-FFF2-40B4-BE49-F238E27FC236}">
-                <a16:creationId xmlns:a16="http://schemas.microsoft.com/office/drawing/2014/main" id="{C0543506-5586-4124-8C96-B3F025277335}"/>
+                <a16:creationId xmlns:a16="http://schemas.microsoft.com/office/drawing/2014/main" id="{B5990368-A81A-4360-96B0-7B351A179371}"/>
               </a:ext>
             </a:extLst>
           </p:cNvPr>
@@ -6923,7 +6923,7 @@
           <p:cNvPr id="6" name="">
             <a:extLst xmlns:a="http://schemas.openxmlformats.org/drawingml/2006/main">
               <a:ext uri="{FF2B5EF4-FFF2-40B4-BE49-F238E27FC236}">
-                <a16:creationId xmlns:a16="http://schemas.microsoft.com/office/drawing/2014/main" id="{7F3816A0-3746-4335-A603-5B8D9166262A}"/>
+                <a16:creationId xmlns:a16="http://schemas.microsoft.com/office/drawing/2014/main" id="{A9E9113D-9838-4A69-A051-F8D241C95421}"/>
               </a:ext>
             </a:extLst>
           </p:cNvPr>
@@ -6954,7 +6954,7 @@
           <p:cNvPr id="7" name="">
             <a:extLst xmlns:a="http://schemas.openxmlformats.org/drawingml/2006/main">
               <a:ext uri="{FF2B5EF4-FFF2-40B4-BE49-F238E27FC236}">
-                <a16:creationId xmlns:a16="http://schemas.microsoft.com/office/drawing/2014/main" id="{A93034E1-4911-4033-A7F5-6E3ECA6F8B8F}"/>
+                <a16:creationId xmlns:a16="http://schemas.microsoft.com/office/drawing/2014/main" id="{EBF405B7-737C-4109-A8BB-B9C4C05A4516}"/>
               </a:ext>
             </a:extLst>
           </p:cNvPr>
@@ -6999,7 +6999,7 @@
           <p:cNvPr id="8" name="">
             <a:extLst xmlns:a="http://schemas.openxmlformats.org/drawingml/2006/main">
               <a:ext uri="{FF2B5EF4-FFF2-40B4-BE49-F238E27FC236}">
-                <a16:creationId xmlns:a16="http://schemas.microsoft.com/office/drawing/2014/main" id="{E43966D3-FE0C-427F-8461-BCD597D456D3}"/>
+                <a16:creationId xmlns:a16="http://schemas.microsoft.com/office/drawing/2014/main" id="{990AE606-88F8-48DF-81CA-E657568EA9B9}"/>
               </a:ext>
             </a:extLst>
           </p:cNvPr>
@@ -7044,7 +7044,7 @@
           <p:cNvPr id="9" name="">
             <a:extLst xmlns:a="http://schemas.openxmlformats.org/drawingml/2006/main">
               <a:ext uri="{FF2B5EF4-FFF2-40B4-BE49-F238E27FC236}">
-                <a16:creationId xmlns:a16="http://schemas.microsoft.com/office/drawing/2014/main" id="{7D8AE2A9-43B5-49F5-8B7E-4B8CA15B6176}"/>
+                <a16:creationId xmlns:a16="http://schemas.microsoft.com/office/drawing/2014/main" id="{2BBE611A-73F5-4372-8B9A-B01A50A7165D}"/>
               </a:ext>
             </a:extLst>
           </p:cNvPr>
@@ -7075,7 +7075,7 @@
           <p:cNvPr id="10" name="">
             <a:extLst xmlns:a="http://schemas.openxmlformats.org/drawingml/2006/main">
               <a:ext uri="{FF2B5EF4-FFF2-40B4-BE49-F238E27FC236}">
-                <a16:creationId xmlns:a16="http://schemas.microsoft.com/office/drawing/2014/main" id="{9FB64EB1-E472-4EC7-9B92-B1A07BCDDA1C}"/>
+                <a16:creationId xmlns:a16="http://schemas.microsoft.com/office/drawing/2014/main" id="{4EFA8F67-7CA6-43C2-BF90-6A3C96CEF1F5}"/>
               </a:ext>
             </a:extLst>
           </p:cNvPr>
@@ -7120,7 +7120,7 @@
           <p:cNvPr id="11" name="">
             <a:extLst xmlns:a="http://schemas.openxmlformats.org/drawingml/2006/main">
               <a:ext uri="{FF2B5EF4-FFF2-40B4-BE49-F238E27FC236}">
-                <a16:creationId xmlns:a16="http://schemas.microsoft.com/office/drawing/2014/main" id="{DE320CE8-813B-4AB6-99F3-6DA109F42BF2}"/>
+                <a16:creationId xmlns:a16="http://schemas.microsoft.com/office/drawing/2014/main" id="{4168859D-38B2-49EF-B8BC-FAAF06BCED53}"/>
               </a:ext>
             </a:extLst>
           </p:cNvPr>
@@ -7165,7 +7165,7 @@
           <p:cNvPr id="12" name="">
             <a:extLst xmlns:a="http://schemas.openxmlformats.org/drawingml/2006/main">
               <a:ext uri="{FF2B5EF4-FFF2-40B4-BE49-F238E27FC236}">
-                <a16:creationId xmlns:a16="http://schemas.microsoft.com/office/drawing/2014/main" id="{9EBE7A66-4DA1-4ED6-B3DA-24CF7C3F2886}"/>
+                <a16:creationId xmlns:a16="http://schemas.microsoft.com/office/drawing/2014/main" id="{D37744D4-D032-43B5-8073-6FD940C8F1B2}"/>
               </a:ext>
             </a:extLst>
           </p:cNvPr>
@@ -7198,7 +7198,7 @@
           <p:cNvPr id="13" name="">
             <a:extLst xmlns:a="http://schemas.openxmlformats.org/drawingml/2006/main">
               <a:ext uri="{FF2B5EF4-FFF2-40B4-BE49-F238E27FC236}">
-                <a16:creationId xmlns:a16="http://schemas.microsoft.com/office/drawing/2014/main" id="{A73B2367-CF22-44D1-AD3A-8012D3CE074C}"/>
+                <a16:creationId xmlns:a16="http://schemas.microsoft.com/office/drawing/2014/main" id="{5B94461D-AA51-44EE-9E1B-D53B5B55CAA9}"/>
               </a:ext>
             </a:extLst>
           </p:cNvPr>
@@ -7229,7 +7229,7 @@
           <p:cNvPr id="14" name="">
             <a:extLst xmlns:a="http://schemas.openxmlformats.org/drawingml/2006/main">
               <a:ext uri="{FF2B5EF4-FFF2-40B4-BE49-F238E27FC236}">
-                <a16:creationId xmlns:a16="http://schemas.microsoft.com/office/drawing/2014/main" id="{CC217F44-F708-46F2-B576-FBD0F1165DB3}"/>
+                <a16:creationId xmlns:a16="http://schemas.microsoft.com/office/drawing/2014/main" id="{AFB85EB8-E82C-47A3-AF16-8ECC0537704B}"/>
               </a:ext>
             </a:extLst>
           </p:cNvPr>
@@ -7274,7 +7274,7 @@
           <p:cNvPr id="15" name="">
             <a:extLst xmlns:a="http://schemas.openxmlformats.org/drawingml/2006/main">
               <a:ext uri="{FF2B5EF4-FFF2-40B4-BE49-F238E27FC236}">
-                <a16:creationId xmlns:a16="http://schemas.microsoft.com/office/drawing/2014/main" id="{81F6441C-06EB-484E-82C7-BED0CB354CE9}"/>
+                <a16:creationId xmlns:a16="http://schemas.microsoft.com/office/drawing/2014/main" id="{4FEF2C0B-773E-4212-A480-588F79041FCF}"/>
               </a:ext>
             </a:extLst>
           </p:cNvPr>
@@ -7319,7 +7319,7 @@
           <p:cNvPr id="16" name="">
             <a:extLst xmlns:a="http://schemas.openxmlformats.org/drawingml/2006/main">
               <a:ext uri="{FF2B5EF4-FFF2-40B4-BE49-F238E27FC236}">
-                <a16:creationId xmlns:a16="http://schemas.microsoft.com/office/drawing/2014/main" id="{429BABAA-265A-43A8-8AB5-E3B90D5FE79E}"/>
+                <a16:creationId xmlns:a16="http://schemas.microsoft.com/office/drawing/2014/main" id="{3BBED14F-4E30-4BA3-A6A3-1D2EEB6E4411}"/>
               </a:ext>
             </a:extLst>
           </p:cNvPr>
@@ -7352,7 +7352,7 @@
           <p:cNvPr id="17" name="">
             <a:extLst xmlns:a="http://schemas.openxmlformats.org/drawingml/2006/main">
               <a:ext uri="{FF2B5EF4-FFF2-40B4-BE49-F238E27FC236}">
-                <a16:creationId xmlns:a16="http://schemas.microsoft.com/office/drawing/2014/main" id="{F88BE821-FB80-4E56-8FC0-1559296A72B3}"/>
+                <a16:creationId xmlns:a16="http://schemas.microsoft.com/office/drawing/2014/main" id="{CAD83706-F426-499A-AC90-92E1E04871AD}"/>
               </a:ext>
             </a:extLst>
           </p:cNvPr>
@@ -7397,7 +7397,7 @@
           <p:cNvPr id="18" name="">
             <a:extLst xmlns:a="http://schemas.openxmlformats.org/drawingml/2006/main">
               <a:ext uri="{FF2B5EF4-FFF2-40B4-BE49-F238E27FC236}">
-                <a16:creationId xmlns:a16="http://schemas.microsoft.com/office/drawing/2014/main" id="{3FE4F707-7ABF-4F8D-95A5-BEBAD21898C3}"/>
+                <a16:creationId xmlns:a16="http://schemas.microsoft.com/office/drawing/2014/main" id="{E844E452-C07B-4474-B876-F42C8D5A422E}"/>
               </a:ext>
             </a:extLst>
           </p:cNvPr>
@@ -7442,7 +7442,7 @@
           <p:cNvPr id="19" name="">
             <a:extLst xmlns:a="http://schemas.openxmlformats.org/drawingml/2006/main">
               <a:ext uri="{FF2B5EF4-FFF2-40B4-BE49-F238E27FC236}">
-                <a16:creationId xmlns:a16="http://schemas.microsoft.com/office/drawing/2014/main" id="{62B0889E-4E29-4C5E-A61D-3EAF6E1052AA}"/>
+                <a16:creationId xmlns:a16="http://schemas.microsoft.com/office/drawing/2014/main" id="{57F92D16-9296-4483-AE54-DC554A883561}"/>
               </a:ext>
             </a:extLst>
           </p:cNvPr>
@@ -7475,7 +7475,7 @@
           <p:cNvPr id="20" name="">
             <a:extLst xmlns:a="http://schemas.openxmlformats.org/drawingml/2006/main">
               <a:ext uri="{FF2B5EF4-FFF2-40B4-BE49-F238E27FC236}">
-                <a16:creationId xmlns:a16="http://schemas.microsoft.com/office/drawing/2014/main" id="{34EC1D69-A966-491F-B1DD-7F3C8CBB7ACD}"/>
+                <a16:creationId xmlns:a16="http://schemas.microsoft.com/office/drawing/2014/main" id="{1C4842BF-BD94-4B54-B9BE-73C9CB0C8D06}"/>
               </a:ext>
             </a:extLst>
           </p:cNvPr>
@@ -7520,7 +7520,7 @@
           <p:cNvPr id="21" name="">
             <a:extLst xmlns:a="http://schemas.openxmlformats.org/drawingml/2006/main">
               <a:ext uri="{FF2B5EF4-FFF2-40B4-BE49-F238E27FC236}">
-                <a16:creationId xmlns:a16="http://schemas.microsoft.com/office/drawing/2014/main" id="{78EEB957-6942-4C01-9B26-5EB158D68289}"/>
+                <a16:creationId xmlns:a16="http://schemas.microsoft.com/office/drawing/2014/main" id="{DAB854B1-46B8-4ED8-A86A-BA6131DC6225}"/>
               </a:ext>
             </a:extLst>
           </p:cNvPr>
@@ -7565,7 +7565,7 @@
           <p:cNvPr id="22" name="">
             <a:extLst xmlns:a="http://schemas.openxmlformats.org/drawingml/2006/main">
               <a:ext uri="{FF2B5EF4-FFF2-40B4-BE49-F238E27FC236}">
-                <a16:creationId xmlns:a16="http://schemas.microsoft.com/office/drawing/2014/main" id="{8611CEE2-8A5E-460E-BC23-B92E14FF2C5A}"/>
+                <a16:creationId xmlns:a16="http://schemas.microsoft.com/office/drawing/2014/main" id="{F0FCCBA5-F279-47B5-B0CB-42B1E6DE6728}"/>
               </a:ext>
             </a:extLst>
           </p:cNvPr>
@@ -7598,7 +7598,7 @@
           <p:cNvPr id="23" name="">
             <a:extLst xmlns:a="http://schemas.openxmlformats.org/drawingml/2006/main">
               <a:ext uri="{FF2B5EF4-FFF2-40B4-BE49-F238E27FC236}">
-                <a16:creationId xmlns:a16="http://schemas.microsoft.com/office/drawing/2014/main" id="{B3BEC120-3C4A-4657-83F2-04D10F9D530E}"/>
+                <a16:creationId xmlns:a16="http://schemas.microsoft.com/office/drawing/2014/main" id="{CD79BA06-B2A6-4D1F-9714-02F7F00675D4}"/>
               </a:ext>
             </a:extLst>
           </p:cNvPr>
@@ -7643,7 +7643,7 @@
           <p:cNvPr id="24" name="">
             <a:extLst xmlns:a="http://schemas.openxmlformats.org/drawingml/2006/main">
               <a:ext uri="{FF2B5EF4-FFF2-40B4-BE49-F238E27FC236}">
-                <a16:creationId xmlns:a16="http://schemas.microsoft.com/office/drawing/2014/main" id="{58A1E2FA-86EB-4676-8453-6D7E0D52FBF6}"/>
+                <a16:creationId xmlns:a16="http://schemas.microsoft.com/office/drawing/2014/main" id="{C5A37FF4-099F-4560-ABBA-2EDB99382EAB}"/>
               </a:ext>
             </a:extLst>
           </p:cNvPr>
@@ -7688,7 +7688,7 @@
           <p:cNvPr id="25" name="">
             <a:extLst xmlns:a="http://schemas.openxmlformats.org/drawingml/2006/main">
               <a:ext uri="{FF2B5EF4-FFF2-40B4-BE49-F238E27FC236}">
-                <a16:creationId xmlns:a16="http://schemas.microsoft.com/office/drawing/2014/main" id="{B012DE9F-5524-4DFD-980F-53424D6636FE}"/>
+                <a16:creationId xmlns:a16="http://schemas.microsoft.com/office/drawing/2014/main" id="{FF90F551-CEB5-448A-9998-11434DB31C6E}"/>
               </a:ext>
             </a:extLst>
           </p:cNvPr>
@@ -7721,7 +7721,7 @@
           <p:cNvPr id="26" name="">
             <a:extLst xmlns:a="http://schemas.openxmlformats.org/drawingml/2006/main">
               <a:ext uri="{FF2B5EF4-FFF2-40B4-BE49-F238E27FC236}">
-                <a16:creationId xmlns:a16="http://schemas.microsoft.com/office/drawing/2014/main" id="{2CB3CF23-0361-41BF-9B99-EA5879828755}"/>
+                <a16:creationId xmlns:a16="http://schemas.microsoft.com/office/drawing/2014/main" id="{89FE29E8-F9B8-4FE3-AF99-F7127E3884F6}"/>
               </a:ext>
             </a:extLst>
           </p:cNvPr>
@@ -7766,7 +7766,7 @@
           <p:cNvPr id="27" name="">
             <a:extLst xmlns:a="http://schemas.openxmlformats.org/drawingml/2006/main">
               <a:ext uri="{FF2B5EF4-FFF2-40B4-BE49-F238E27FC236}">
-                <a16:creationId xmlns:a16="http://schemas.microsoft.com/office/drawing/2014/main" id="{09B3FF77-99FF-4E97-897D-3C4E1714F34C}"/>
+                <a16:creationId xmlns:a16="http://schemas.microsoft.com/office/drawing/2014/main" id="{7DD2CE55-785C-4975-8117-725C97F377BB}"/>
               </a:ext>
             </a:extLst>
           </p:cNvPr>
@@ -7811,7 +7811,7 @@
           <p:cNvPr id="28" name="">
             <a:extLst xmlns:a="http://schemas.openxmlformats.org/drawingml/2006/main">
               <a:ext uri="{FF2B5EF4-FFF2-40B4-BE49-F238E27FC236}">
-                <a16:creationId xmlns:a16="http://schemas.microsoft.com/office/drawing/2014/main" id="{30CC85DB-98DF-4D57-8420-0D1F3E570839}"/>
+                <a16:creationId xmlns:a16="http://schemas.microsoft.com/office/drawing/2014/main" id="{A3C7C4FE-150F-479B-BDAD-8E26A7F56F2B}"/>
               </a:ext>
             </a:extLst>
           </p:cNvPr>
@@ -7856,7 +7856,7 @@
           <p:cNvPr id="29" name="">
             <a:extLst xmlns:a="http://schemas.openxmlformats.org/drawingml/2006/main">
               <a:ext uri="{FF2B5EF4-FFF2-40B4-BE49-F238E27FC236}">
-                <a16:creationId xmlns:a16="http://schemas.microsoft.com/office/drawing/2014/main" id="{88416AEF-BC12-45BF-92C3-BC78942F6F9F}"/>
+                <a16:creationId xmlns:a16="http://schemas.microsoft.com/office/drawing/2014/main" id="{F25EA0BE-7067-4720-9811-0C45148C7CCE}"/>
               </a:ext>
             </a:extLst>
           </p:cNvPr>
@@ -7899,7 +7899,7 @@
     </p:spTree>
     <p:extLst>
       <p:ext uri="{BB962C8B-B14F-4D97-AF65-F5344CB8AC3E}">
-        <p14:creationId xmlns:p14="http://schemas.microsoft.com/office/powerpoint/2010/main" val="763114843"/>
+        <p14:creationId xmlns:p14="http://schemas.microsoft.com/office/powerpoint/2010/main" val="1935844493"/>
       </p:ext>
     </p:extLst>
   </p:cSld>
@@ -7923,7 +7923,7 @@
           <p:cNvPr id="50" name="">
             <a:extLst xmlns:a="http://schemas.openxmlformats.org/drawingml/2006/main">
               <a:ext uri="{FF2B5EF4-FFF2-40B4-BE49-F238E27FC236}">
-                <a16:creationId xmlns:a16="http://schemas.microsoft.com/office/drawing/2014/main" id="{80CBD745-C869-4F9B-819A-A0B9B131C36F}"/>
+                <a16:creationId xmlns:a16="http://schemas.microsoft.com/office/drawing/2014/main" id="{341C7689-3C22-4C5F-9B3B-62A73B4F1CC5}"/>
               </a:ext>
             </a:extLst>
           </p:cNvPr>
@@ -7954,7 +7954,7 @@
           <p:cNvPr id="2" name="">
             <a:extLst xmlns:a="http://schemas.openxmlformats.org/drawingml/2006/main">
               <a:ext uri="{FF2B5EF4-FFF2-40B4-BE49-F238E27FC236}">
-                <a16:creationId xmlns:a16="http://schemas.microsoft.com/office/drawing/2014/main" id="{CD016FA7-BFFF-4482-BF37-3C634C0E8D14}"/>
+                <a16:creationId xmlns:a16="http://schemas.microsoft.com/office/drawing/2014/main" id="{06AC35F4-06AD-4425-ACD9-A4B1759D2E4B}"/>
               </a:ext>
             </a:extLst>
           </p:cNvPr>
@@ -7999,7 +7999,7 @@
           <p:cNvPr id="3" name="">
             <a:extLst xmlns:a="http://schemas.openxmlformats.org/drawingml/2006/main">
               <a:ext uri="{FF2B5EF4-FFF2-40B4-BE49-F238E27FC236}">
-                <a16:creationId xmlns:a16="http://schemas.microsoft.com/office/drawing/2014/main" id="{A2229128-5B8E-45FF-A4BA-B3240657891B}"/>
+                <a16:creationId xmlns:a16="http://schemas.microsoft.com/office/drawing/2014/main" id="{CFF04E65-B455-4EFD-A634-F9C82E20D983}"/>
               </a:ext>
             </a:extLst>
           </p:cNvPr>
@@ -8044,7 +8044,7 @@
           <p:cNvPr id="4" name="">
             <a:extLst xmlns:a="http://schemas.openxmlformats.org/drawingml/2006/main">
               <a:ext uri="{FF2B5EF4-FFF2-40B4-BE49-F238E27FC236}">
-                <a16:creationId xmlns:a16="http://schemas.microsoft.com/office/drawing/2014/main" id="{81C72857-E5C1-493F-8C69-BA69DAC2475A}"/>
+                <a16:creationId xmlns:a16="http://schemas.microsoft.com/office/drawing/2014/main" id="{5079AA64-EF6B-4CC5-80D3-5B8B3709CDB8}"/>
               </a:ext>
             </a:extLst>
           </p:cNvPr>
@@ -8089,7 +8089,7 @@
           <p:cNvPr id="5" name="">
             <a:extLst xmlns:a="http://schemas.openxmlformats.org/drawingml/2006/main">
               <a:ext uri="{FF2B5EF4-FFF2-40B4-BE49-F238E27FC236}">
-                <a16:creationId xmlns:a16="http://schemas.microsoft.com/office/drawing/2014/main" id="{1EE89618-2DAC-457F-88B5-EA3E461339E0}"/>
+                <a16:creationId xmlns:a16="http://schemas.microsoft.com/office/drawing/2014/main" id="{F5A3D738-A3CC-46A7-A6FC-92A3AD6D0125}"/>
               </a:ext>
             </a:extLst>
           </p:cNvPr>
@@ -8120,7 +8120,7 @@
           <p:cNvPr id="6" name="">
             <a:extLst xmlns:a="http://schemas.openxmlformats.org/drawingml/2006/main">
               <a:ext uri="{FF2B5EF4-FFF2-40B4-BE49-F238E27FC236}">
-                <a16:creationId xmlns:a16="http://schemas.microsoft.com/office/drawing/2014/main" id="{0C834FC0-1741-4EF4-A08A-5E471ADDEB9E}"/>
+                <a16:creationId xmlns:a16="http://schemas.microsoft.com/office/drawing/2014/main" id="{CDE1A02F-754E-44C6-840F-55A07258B574}"/>
               </a:ext>
             </a:extLst>
           </p:cNvPr>
@@ -8151,7 +8151,7 @@
           <p:cNvPr id="7" name="">
             <a:extLst xmlns:a="http://schemas.openxmlformats.org/drawingml/2006/main">
               <a:ext uri="{FF2B5EF4-FFF2-40B4-BE49-F238E27FC236}">
-                <a16:creationId xmlns:a16="http://schemas.microsoft.com/office/drawing/2014/main" id="{15E5E6D5-5E7A-4FBF-9D9B-4FFAE348FB20}"/>
+                <a16:creationId xmlns:a16="http://schemas.microsoft.com/office/drawing/2014/main" id="{308B1731-563B-4EC9-9BCE-BEF17A845014}"/>
               </a:ext>
             </a:extLst>
           </p:cNvPr>
@@ -8196,7 +8196,7 @@
           <p:cNvPr id="8" name="">
             <a:extLst xmlns:a="http://schemas.openxmlformats.org/drawingml/2006/main">
               <a:ext uri="{FF2B5EF4-FFF2-40B4-BE49-F238E27FC236}">
-                <a16:creationId xmlns:a16="http://schemas.microsoft.com/office/drawing/2014/main" id="{F33BFDD6-71A9-45CA-9DA7-14798F1C3524}"/>
+                <a16:creationId xmlns:a16="http://schemas.microsoft.com/office/drawing/2014/main" id="{5F3FE430-B044-41B8-8EC7-2C7A9EB89B5A}"/>
               </a:ext>
             </a:extLst>
           </p:cNvPr>
@@ -8241,7 +8241,7 @@
           <p:cNvPr id="9" name="">
             <a:extLst xmlns:a="http://schemas.openxmlformats.org/drawingml/2006/main">
               <a:ext uri="{FF2B5EF4-FFF2-40B4-BE49-F238E27FC236}">
-                <a16:creationId xmlns:a16="http://schemas.microsoft.com/office/drawing/2014/main" id="{FA3923E5-E23E-4514-9D41-01955250CFFB}"/>
+                <a16:creationId xmlns:a16="http://schemas.microsoft.com/office/drawing/2014/main" id="{F0DBE98B-7BD8-4469-AB2E-B02115BF6B8C}"/>
               </a:ext>
             </a:extLst>
           </p:cNvPr>
@@ -8272,7 +8272,7 @@
           <p:cNvPr id="10" name="">
             <a:extLst xmlns:a="http://schemas.openxmlformats.org/drawingml/2006/main">
               <a:ext uri="{FF2B5EF4-FFF2-40B4-BE49-F238E27FC236}">
-                <a16:creationId xmlns:a16="http://schemas.microsoft.com/office/drawing/2014/main" id="{48379962-C570-486F-B6CC-16FF9B5BFA80}"/>
+                <a16:creationId xmlns:a16="http://schemas.microsoft.com/office/drawing/2014/main" id="{933D5FE8-E232-4208-9568-4F0474FB938E}"/>
               </a:ext>
             </a:extLst>
           </p:cNvPr>
@@ -8317,7 +8317,7 @@
           <p:cNvPr id="11" name="">
             <a:extLst xmlns:a="http://schemas.openxmlformats.org/drawingml/2006/main">
               <a:ext uri="{FF2B5EF4-FFF2-40B4-BE49-F238E27FC236}">
-                <a16:creationId xmlns:a16="http://schemas.microsoft.com/office/drawing/2014/main" id="{C95587C4-01C3-4644-86F6-416552DFBE30}"/>
+                <a16:creationId xmlns:a16="http://schemas.microsoft.com/office/drawing/2014/main" id="{A03653C3-4365-4C4B-8E1C-6E19BE65BBD1}"/>
               </a:ext>
             </a:extLst>
           </p:cNvPr>
@@ -8362,7 +8362,7 @@
           <p:cNvPr id="12" name="">
             <a:extLst xmlns:a="http://schemas.openxmlformats.org/drawingml/2006/main">
               <a:ext uri="{FF2B5EF4-FFF2-40B4-BE49-F238E27FC236}">
-                <a16:creationId xmlns:a16="http://schemas.microsoft.com/office/drawing/2014/main" id="{F76FB4C4-B9F1-4876-BA47-9E792FE8CDD4}"/>
+                <a16:creationId xmlns:a16="http://schemas.microsoft.com/office/drawing/2014/main" id="{216E406F-FC61-4072-AD5E-CCA17D320D59}"/>
               </a:ext>
             </a:extLst>
           </p:cNvPr>
@@ -8393,7 +8393,7 @@
           <p:cNvPr id="13" name="">
             <a:extLst xmlns:a="http://schemas.openxmlformats.org/drawingml/2006/main">
               <a:ext uri="{FF2B5EF4-FFF2-40B4-BE49-F238E27FC236}">
-                <a16:creationId xmlns:a16="http://schemas.microsoft.com/office/drawing/2014/main" id="{6506EBAC-6EEE-4D45-A342-2DA4D3982254}"/>
+                <a16:creationId xmlns:a16="http://schemas.microsoft.com/office/drawing/2014/main" id="{0262239A-26AB-448E-B329-EFC72B120D87}"/>
               </a:ext>
             </a:extLst>
           </p:cNvPr>
@@ -8438,7 +8438,7 @@
           <p:cNvPr id="14" name="">
             <a:extLst xmlns:a="http://schemas.openxmlformats.org/drawingml/2006/main">
               <a:ext uri="{FF2B5EF4-FFF2-40B4-BE49-F238E27FC236}">
-                <a16:creationId xmlns:a16="http://schemas.microsoft.com/office/drawing/2014/main" id="{481351AE-0276-45AB-A4B2-53A93BEB3A11}"/>
+                <a16:creationId xmlns:a16="http://schemas.microsoft.com/office/drawing/2014/main" id="{05CAD366-7227-4424-B485-2A3F86120652}"/>
               </a:ext>
             </a:extLst>
           </p:cNvPr>
@@ -8471,7 +8471,7 @@
           <p:cNvPr id="15" name="">
             <a:extLst xmlns:a="http://schemas.openxmlformats.org/drawingml/2006/main">
               <a:ext uri="{FF2B5EF4-FFF2-40B4-BE49-F238E27FC236}">
-                <a16:creationId xmlns:a16="http://schemas.microsoft.com/office/drawing/2014/main" id="{2503C78F-B298-4577-BF13-C0B5235091B3}"/>
+                <a16:creationId xmlns:a16="http://schemas.microsoft.com/office/drawing/2014/main" id="{4BB08957-ED1D-4EA0-BA7A-826D5C484640}"/>
               </a:ext>
             </a:extLst>
           </p:cNvPr>
@@ -8516,7 +8516,7 @@
           <p:cNvPr id="16" name="">
             <a:extLst xmlns:a="http://schemas.openxmlformats.org/drawingml/2006/main">
               <a:ext uri="{FF2B5EF4-FFF2-40B4-BE49-F238E27FC236}">
-                <a16:creationId xmlns:a16="http://schemas.microsoft.com/office/drawing/2014/main" id="{95E45287-2715-467B-986D-1B755C2D9BD3}"/>
+                <a16:creationId xmlns:a16="http://schemas.microsoft.com/office/drawing/2014/main" id="{D55EB161-8595-4A2B-A450-22193D8AF700}"/>
               </a:ext>
             </a:extLst>
           </p:cNvPr>
@@ -8561,7 +8561,7 @@
           <p:cNvPr id="17" name="">
             <a:extLst xmlns:a="http://schemas.openxmlformats.org/drawingml/2006/main">
               <a:ext uri="{FF2B5EF4-FFF2-40B4-BE49-F238E27FC236}">
-                <a16:creationId xmlns:a16="http://schemas.microsoft.com/office/drawing/2014/main" id="{FD0AB92A-1D3E-4614-9A3E-54F454A8D8B5}"/>
+                <a16:creationId xmlns:a16="http://schemas.microsoft.com/office/drawing/2014/main" id="{60177E77-D0EC-4481-A36B-EFEFD8C4E6C1}"/>
               </a:ext>
             </a:extLst>
           </p:cNvPr>
@@ -8594,7 +8594,7 @@
           <p:cNvPr id="18" name="">
             <a:extLst xmlns:a="http://schemas.openxmlformats.org/drawingml/2006/main">
               <a:ext uri="{FF2B5EF4-FFF2-40B4-BE49-F238E27FC236}">
-                <a16:creationId xmlns:a16="http://schemas.microsoft.com/office/drawing/2014/main" id="{5960CB98-DA11-41B7-ACAD-ABF229D45736}"/>
+                <a16:creationId xmlns:a16="http://schemas.microsoft.com/office/drawing/2014/main" id="{D3832A86-61FF-408C-8AF4-EC076F0EC7BF}"/>
               </a:ext>
             </a:extLst>
           </p:cNvPr>
@@ -8639,7 +8639,7 @@
           <p:cNvPr id="19" name="">
             <a:extLst xmlns:a="http://schemas.openxmlformats.org/drawingml/2006/main">
               <a:ext uri="{FF2B5EF4-FFF2-40B4-BE49-F238E27FC236}">
-                <a16:creationId xmlns:a16="http://schemas.microsoft.com/office/drawing/2014/main" id="{826E4382-DCD5-4914-B79B-5F41782C9D00}"/>
+                <a16:creationId xmlns:a16="http://schemas.microsoft.com/office/drawing/2014/main" id="{3E174533-8F06-408D-A7F9-950A3A6FD37C}"/>
               </a:ext>
             </a:extLst>
           </p:cNvPr>
@@ -8672,7 +8672,7 @@
           <p:cNvPr id="20" name="">
             <a:extLst xmlns:a="http://schemas.openxmlformats.org/drawingml/2006/main">
               <a:ext uri="{FF2B5EF4-FFF2-40B4-BE49-F238E27FC236}">
-                <a16:creationId xmlns:a16="http://schemas.microsoft.com/office/drawing/2014/main" id="{47F4CEE8-7E43-46FB-8658-42A6F0B1CF39}"/>
+                <a16:creationId xmlns:a16="http://schemas.microsoft.com/office/drawing/2014/main" id="{502701C5-F0D1-4EFD-B359-AAB2959D74D3}"/>
               </a:ext>
             </a:extLst>
           </p:cNvPr>
@@ -8717,7 +8717,7 @@
           <p:cNvPr id="21" name="">
             <a:extLst xmlns:a="http://schemas.openxmlformats.org/drawingml/2006/main">
               <a:ext uri="{FF2B5EF4-FFF2-40B4-BE49-F238E27FC236}">
-                <a16:creationId xmlns:a16="http://schemas.microsoft.com/office/drawing/2014/main" id="{87F000B7-48D4-45EE-8D25-50D76371BD54}"/>
+                <a16:creationId xmlns:a16="http://schemas.microsoft.com/office/drawing/2014/main" id="{A78F0C66-E7A8-4C88-9AB9-7E1812029E83}"/>
               </a:ext>
             </a:extLst>
           </p:cNvPr>
@@ -8762,7 +8762,7 @@
           <p:cNvPr id="22" name="">
             <a:extLst xmlns:a="http://schemas.openxmlformats.org/drawingml/2006/main">
               <a:ext uri="{FF2B5EF4-FFF2-40B4-BE49-F238E27FC236}">
-                <a16:creationId xmlns:a16="http://schemas.microsoft.com/office/drawing/2014/main" id="{2FACC146-E267-4343-BC37-AA4C57A42B06}"/>
+                <a16:creationId xmlns:a16="http://schemas.microsoft.com/office/drawing/2014/main" id="{F972074C-C79E-4976-AD0F-0C94B031E6DC}"/>
               </a:ext>
             </a:extLst>
           </p:cNvPr>
@@ -8795,7 +8795,7 @@
           <p:cNvPr id="23" name="">
             <a:extLst xmlns:a="http://schemas.openxmlformats.org/drawingml/2006/main">
               <a:ext uri="{FF2B5EF4-FFF2-40B4-BE49-F238E27FC236}">
-                <a16:creationId xmlns:a16="http://schemas.microsoft.com/office/drawing/2014/main" id="{0DEBFA21-FF46-471F-A279-EE8DEBD829B9}"/>
+                <a16:creationId xmlns:a16="http://schemas.microsoft.com/office/drawing/2014/main" id="{46908227-D423-4939-A213-73AC8E68D33E}"/>
               </a:ext>
             </a:extLst>
           </p:cNvPr>
@@ -8840,7 +8840,7 @@
           <p:cNvPr id="24" name="">
             <a:extLst xmlns:a="http://schemas.openxmlformats.org/drawingml/2006/main">
               <a:ext uri="{FF2B5EF4-FFF2-40B4-BE49-F238E27FC236}">
-                <a16:creationId xmlns:a16="http://schemas.microsoft.com/office/drawing/2014/main" id="{8023AA70-E249-4771-BD1C-FD43E0DA4F92}"/>
+                <a16:creationId xmlns:a16="http://schemas.microsoft.com/office/drawing/2014/main" id="{81E41653-3C64-448D-A79A-527D04C40B84}"/>
               </a:ext>
             </a:extLst>
           </p:cNvPr>
@@ -8873,7 +8873,7 @@
           <p:cNvPr id="25" name="">
             <a:extLst xmlns:a="http://schemas.openxmlformats.org/drawingml/2006/main">
               <a:ext uri="{FF2B5EF4-FFF2-40B4-BE49-F238E27FC236}">
-                <a16:creationId xmlns:a16="http://schemas.microsoft.com/office/drawing/2014/main" id="{C7D146BD-ACF4-4B63-87A8-FA0F1CE35E09}"/>
+                <a16:creationId xmlns:a16="http://schemas.microsoft.com/office/drawing/2014/main" id="{6C04C3B8-463A-425E-BD71-2078831C7E38}"/>
               </a:ext>
             </a:extLst>
           </p:cNvPr>
@@ -8918,7 +8918,7 @@
           <p:cNvPr id="26" name="">
             <a:extLst xmlns:a="http://schemas.openxmlformats.org/drawingml/2006/main">
               <a:ext uri="{FF2B5EF4-FFF2-40B4-BE49-F238E27FC236}">
-                <a16:creationId xmlns:a16="http://schemas.microsoft.com/office/drawing/2014/main" id="{8E3356EC-3949-4910-B7D3-C0E23E051686}"/>
+                <a16:creationId xmlns:a16="http://schemas.microsoft.com/office/drawing/2014/main" id="{F758D2BA-C7DE-4FCD-AE9B-40F117424ED4}"/>
               </a:ext>
             </a:extLst>
           </p:cNvPr>
@@ -8963,7 +8963,7 @@
           <p:cNvPr id="27" name="">
             <a:extLst xmlns:a="http://schemas.openxmlformats.org/drawingml/2006/main">
               <a:ext uri="{FF2B5EF4-FFF2-40B4-BE49-F238E27FC236}">
-                <a16:creationId xmlns:a16="http://schemas.microsoft.com/office/drawing/2014/main" id="{1E35BB9E-CF1E-49D5-88A3-E4CA83949EE1}"/>
+                <a16:creationId xmlns:a16="http://schemas.microsoft.com/office/drawing/2014/main" id="{57B35C10-9B0D-4E84-A9EE-EE19E5BE9A37}"/>
               </a:ext>
             </a:extLst>
           </p:cNvPr>
@@ -8996,7 +8996,7 @@
           <p:cNvPr id="28" name="">
             <a:extLst xmlns:a="http://schemas.openxmlformats.org/drawingml/2006/main">
               <a:ext uri="{FF2B5EF4-FFF2-40B4-BE49-F238E27FC236}">
-                <a16:creationId xmlns:a16="http://schemas.microsoft.com/office/drawing/2014/main" id="{608C87DA-FE53-4C70-9F2A-0E331EC65822}"/>
+                <a16:creationId xmlns:a16="http://schemas.microsoft.com/office/drawing/2014/main" id="{781FFF9D-7A2D-43B1-8BEF-8579C1C0FA60}"/>
               </a:ext>
             </a:extLst>
           </p:cNvPr>
@@ -9041,7 +9041,7 @@
           <p:cNvPr id="29" name="">
             <a:extLst xmlns:a="http://schemas.openxmlformats.org/drawingml/2006/main">
               <a:ext uri="{FF2B5EF4-FFF2-40B4-BE49-F238E27FC236}">
-                <a16:creationId xmlns:a16="http://schemas.microsoft.com/office/drawing/2014/main" id="{437CD353-6622-4D9D-888C-573A89182297}"/>
+                <a16:creationId xmlns:a16="http://schemas.microsoft.com/office/drawing/2014/main" id="{88389A33-1F16-4012-90C6-1635D51D971C}"/>
               </a:ext>
             </a:extLst>
           </p:cNvPr>
@@ -9074,7 +9074,7 @@
           <p:cNvPr id="30" name="">
             <a:extLst xmlns:a="http://schemas.openxmlformats.org/drawingml/2006/main">
               <a:ext uri="{FF2B5EF4-FFF2-40B4-BE49-F238E27FC236}">
-                <a16:creationId xmlns:a16="http://schemas.microsoft.com/office/drawing/2014/main" id="{1814C2AB-C380-46EB-827E-F4752CA688A3}"/>
+                <a16:creationId xmlns:a16="http://schemas.microsoft.com/office/drawing/2014/main" id="{0038CCD7-6A43-4766-A87B-512E03532876}"/>
               </a:ext>
             </a:extLst>
           </p:cNvPr>
@@ -9119,7 +9119,7 @@
           <p:cNvPr id="31" name="">
             <a:extLst xmlns:a="http://schemas.openxmlformats.org/drawingml/2006/main">
               <a:ext uri="{FF2B5EF4-FFF2-40B4-BE49-F238E27FC236}">
-                <a16:creationId xmlns:a16="http://schemas.microsoft.com/office/drawing/2014/main" id="{2915DDF9-B9C3-42BA-9E4C-875F28360360}"/>
+                <a16:creationId xmlns:a16="http://schemas.microsoft.com/office/drawing/2014/main" id="{0E0996C8-5E41-4F55-B4EF-C37A94E255BA}"/>
               </a:ext>
             </a:extLst>
           </p:cNvPr>
@@ -9164,7 +9164,7 @@
           <p:cNvPr id="32" name="">
             <a:extLst xmlns:a="http://schemas.openxmlformats.org/drawingml/2006/main">
               <a:ext uri="{FF2B5EF4-FFF2-40B4-BE49-F238E27FC236}">
-                <a16:creationId xmlns:a16="http://schemas.microsoft.com/office/drawing/2014/main" id="{DC2019BF-258D-4931-B5E3-D8231A8C72D5}"/>
+                <a16:creationId xmlns:a16="http://schemas.microsoft.com/office/drawing/2014/main" id="{9B712A22-BE21-4624-9045-F918AB3FEF86}"/>
               </a:ext>
             </a:extLst>
           </p:cNvPr>
@@ -9197,7 +9197,7 @@
           <p:cNvPr id="33" name="">
             <a:extLst xmlns:a="http://schemas.openxmlformats.org/drawingml/2006/main">
               <a:ext uri="{FF2B5EF4-FFF2-40B4-BE49-F238E27FC236}">
-                <a16:creationId xmlns:a16="http://schemas.microsoft.com/office/drawing/2014/main" id="{07EF8355-D233-48AB-987D-9BEEC9A40F7B}"/>
+                <a16:creationId xmlns:a16="http://schemas.microsoft.com/office/drawing/2014/main" id="{48E4E28C-B8B2-42D7-A79A-F941836DDC8D}"/>
               </a:ext>
             </a:extLst>
           </p:cNvPr>
@@ -9242,7 +9242,7 @@
           <p:cNvPr id="34" name="">
             <a:extLst xmlns:a="http://schemas.openxmlformats.org/drawingml/2006/main">
               <a:ext uri="{FF2B5EF4-FFF2-40B4-BE49-F238E27FC236}">
-                <a16:creationId xmlns:a16="http://schemas.microsoft.com/office/drawing/2014/main" id="{26910529-0E6F-4A30-BDEF-87BD7D719C2A}"/>
+                <a16:creationId xmlns:a16="http://schemas.microsoft.com/office/drawing/2014/main" id="{02AD04B5-EC26-45EF-8C6A-1EAE3B36BB1C}"/>
               </a:ext>
             </a:extLst>
           </p:cNvPr>
@@ -9275,7 +9275,7 @@
           <p:cNvPr id="35" name="">
             <a:extLst xmlns:a="http://schemas.openxmlformats.org/drawingml/2006/main">
               <a:ext uri="{FF2B5EF4-FFF2-40B4-BE49-F238E27FC236}">
-                <a16:creationId xmlns:a16="http://schemas.microsoft.com/office/drawing/2014/main" id="{45E99577-695F-41E2-8B33-B318738FD320}"/>
+                <a16:creationId xmlns:a16="http://schemas.microsoft.com/office/drawing/2014/main" id="{CD394BD0-F344-45D0-B921-20F74B657A44}"/>
               </a:ext>
             </a:extLst>
           </p:cNvPr>
@@ -9320,7 +9320,7 @@
           <p:cNvPr id="36" name="">
             <a:extLst xmlns:a="http://schemas.openxmlformats.org/drawingml/2006/main">
               <a:ext uri="{FF2B5EF4-FFF2-40B4-BE49-F238E27FC236}">
-                <a16:creationId xmlns:a16="http://schemas.microsoft.com/office/drawing/2014/main" id="{50A5C110-8178-414B-BBEE-26E759F95D4A}"/>
+                <a16:creationId xmlns:a16="http://schemas.microsoft.com/office/drawing/2014/main" id="{33FADAB7-6AFA-402E-87D7-0CA55E7FC259}"/>
               </a:ext>
             </a:extLst>
           </p:cNvPr>
@@ -9365,7 +9365,7 @@
           <p:cNvPr id="37" name="">
             <a:extLst xmlns:a="http://schemas.openxmlformats.org/drawingml/2006/main">
               <a:ext uri="{FF2B5EF4-FFF2-40B4-BE49-F238E27FC236}">
-                <a16:creationId xmlns:a16="http://schemas.microsoft.com/office/drawing/2014/main" id="{E3AF154F-3FF5-4982-AA3E-8A44F62B33C3}"/>
+                <a16:creationId xmlns:a16="http://schemas.microsoft.com/office/drawing/2014/main" id="{C0814B6F-E226-4A11-96BB-F442DC7DE8D7}"/>
               </a:ext>
             </a:extLst>
           </p:cNvPr>
@@ -9398,7 +9398,7 @@
           <p:cNvPr id="38" name="">
             <a:extLst xmlns:a="http://schemas.openxmlformats.org/drawingml/2006/main">
               <a:ext uri="{FF2B5EF4-FFF2-40B4-BE49-F238E27FC236}">
-                <a16:creationId xmlns:a16="http://schemas.microsoft.com/office/drawing/2014/main" id="{5B57382E-5BEA-44AA-8831-351DCF7CF9F6}"/>
+                <a16:creationId xmlns:a16="http://schemas.microsoft.com/office/drawing/2014/main" id="{02034DD3-0DD2-4F21-8180-B7A22F4A1473}"/>
               </a:ext>
             </a:extLst>
           </p:cNvPr>
@@ -9443,7 +9443,7 @@
           <p:cNvPr id="39" name="">
             <a:extLst xmlns:a="http://schemas.openxmlformats.org/drawingml/2006/main">
               <a:ext uri="{FF2B5EF4-FFF2-40B4-BE49-F238E27FC236}">
-                <a16:creationId xmlns:a16="http://schemas.microsoft.com/office/drawing/2014/main" id="{9249BCD1-A619-45DB-B54A-7979007CEB6E}"/>
+                <a16:creationId xmlns:a16="http://schemas.microsoft.com/office/drawing/2014/main" id="{CAF8463B-0A25-47C6-99BB-7BFF91854637}"/>
               </a:ext>
             </a:extLst>
           </p:cNvPr>
@@ -9476,7 +9476,7 @@
           <p:cNvPr id="40" name="">
             <a:extLst xmlns:a="http://schemas.openxmlformats.org/drawingml/2006/main">
               <a:ext uri="{FF2B5EF4-FFF2-40B4-BE49-F238E27FC236}">
-                <a16:creationId xmlns:a16="http://schemas.microsoft.com/office/drawing/2014/main" id="{0C2D43D7-1CCB-4544-907B-A3C6377CC8FE}"/>
+                <a16:creationId xmlns:a16="http://schemas.microsoft.com/office/drawing/2014/main" id="{0448A624-B135-447B-A08A-35D1DCFFB23E}"/>
               </a:ext>
             </a:extLst>
           </p:cNvPr>
@@ -9521,7 +9521,7 @@
           <p:cNvPr id="41" name="">
             <a:extLst xmlns:a="http://schemas.openxmlformats.org/drawingml/2006/main">
               <a:ext uri="{FF2B5EF4-FFF2-40B4-BE49-F238E27FC236}">
-                <a16:creationId xmlns:a16="http://schemas.microsoft.com/office/drawing/2014/main" id="{920F0E14-999A-4192-992B-B39D65C51746}"/>
+                <a16:creationId xmlns:a16="http://schemas.microsoft.com/office/drawing/2014/main" id="{DB288797-08D4-444F-8615-420EE332FCA6}"/>
               </a:ext>
             </a:extLst>
           </p:cNvPr>
@@ -9566,7 +9566,7 @@
           <p:cNvPr id="42" name="">
             <a:extLst xmlns:a="http://schemas.openxmlformats.org/drawingml/2006/main">
               <a:ext uri="{FF2B5EF4-FFF2-40B4-BE49-F238E27FC236}">
-                <a16:creationId xmlns:a16="http://schemas.microsoft.com/office/drawing/2014/main" id="{F4340032-E40B-4506-99A4-77E0F2085A5B}"/>
+                <a16:creationId xmlns:a16="http://schemas.microsoft.com/office/drawing/2014/main" id="{95FE1A4E-D893-455C-A9AD-ED35A55773E3}"/>
               </a:ext>
             </a:extLst>
           </p:cNvPr>
@@ -9599,7 +9599,7 @@
           <p:cNvPr id="43" name="">
             <a:extLst xmlns:a="http://schemas.openxmlformats.org/drawingml/2006/main">
               <a:ext uri="{FF2B5EF4-FFF2-40B4-BE49-F238E27FC236}">
-                <a16:creationId xmlns:a16="http://schemas.microsoft.com/office/drawing/2014/main" id="{764E762E-2FFF-43C1-8CCB-87784946D760}"/>
+                <a16:creationId xmlns:a16="http://schemas.microsoft.com/office/drawing/2014/main" id="{2BC3D81B-58B4-4937-9841-7FACE934DA94}"/>
               </a:ext>
             </a:extLst>
           </p:cNvPr>
@@ -9644,7 +9644,7 @@
           <p:cNvPr id="44" name="">
             <a:extLst xmlns:a="http://schemas.openxmlformats.org/drawingml/2006/main">
               <a:ext uri="{FF2B5EF4-FFF2-40B4-BE49-F238E27FC236}">
-                <a16:creationId xmlns:a16="http://schemas.microsoft.com/office/drawing/2014/main" id="{BD0C3EA8-3AFD-43C7-AC7C-8A501D0ABBF8}"/>
+                <a16:creationId xmlns:a16="http://schemas.microsoft.com/office/drawing/2014/main" id="{4761D3C1-C5DB-4623-AE58-C5E90571E4FC}"/>
               </a:ext>
             </a:extLst>
           </p:cNvPr>
@@ -9677,7 +9677,7 @@
           <p:cNvPr id="45" name="">
             <a:extLst xmlns:a="http://schemas.openxmlformats.org/drawingml/2006/main">
               <a:ext uri="{FF2B5EF4-FFF2-40B4-BE49-F238E27FC236}">
-                <a16:creationId xmlns:a16="http://schemas.microsoft.com/office/drawing/2014/main" id="{E9D72044-A8FB-4BF0-8888-AE28D8B6D3A6}"/>
+                <a16:creationId xmlns:a16="http://schemas.microsoft.com/office/drawing/2014/main" id="{2173A285-D848-44AC-9D9B-0861B46569CE}"/>
               </a:ext>
             </a:extLst>
           </p:cNvPr>
@@ -9722,7 +9722,7 @@
           <p:cNvPr id="46" name="">
             <a:extLst xmlns:a="http://schemas.openxmlformats.org/drawingml/2006/main">
               <a:ext uri="{FF2B5EF4-FFF2-40B4-BE49-F238E27FC236}">
-                <a16:creationId xmlns:a16="http://schemas.microsoft.com/office/drawing/2014/main" id="{D8EED090-342F-4A13-8284-63A211B2F27C}"/>
+                <a16:creationId xmlns:a16="http://schemas.microsoft.com/office/drawing/2014/main" id="{656D8753-37C9-429A-8499-C77D6BF9BC05}"/>
               </a:ext>
             </a:extLst>
           </p:cNvPr>
@@ -9767,7 +9767,7 @@
           <p:cNvPr id="47" name="">
             <a:extLst xmlns:a="http://schemas.openxmlformats.org/drawingml/2006/main">
               <a:ext uri="{FF2B5EF4-FFF2-40B4-BE49-F238E27FC236}">
-                <a16:creationId xmlns:a16="http://schemas.microsoft.com/office/drawing/2014/main" id="{50E6C8ED-1CEF-4577-9D43-E78E21E9A634}"/>
+                <a16:creationId xmlns:a16="http://schemas.microsoft.com/office/drawing/2014/main" id="{08539A33-16E4-4F7B-BAF9-9AA2977AB701}"/>
               </a:ext>
             </a:extLst>
           </p:cNvPr>
@@ -9800,7 +9800,7 @@
           <p:cNvPr id="48" name="">
             <a:extLst xmlns:a="http://schemas.openxmlformats.org/drawingml/2006/main">
               <a:ext uri="{FF2B5EF4-FFF2-40B4-BE49-F238E27FC236}">
-                <a16:creationId xmlns:a16="http://schemas.microsoft.com/office/drawing/2014/main" id="{5C500AFE-0BA3-4E8B-AB56-119EB14147B5}"/>
+                <a16:creationId xmlns:a16="http://schemas.microsoft.com/office/drawing/2014/main" id="{930423A0-4688-4139-B9F4-23BCCF8689AB}"/>
               </a:ext>
             </a:extLst>
           </p:cNvPr>
@@ -9845,7 +9845,7 @@
           <p:cNvPr id="49" name="">
             <a:extLst xmlns:a="http://schemas.openxmlformats.org/drawingml/2006/main">
               <a:ext uri="{FF2B5EF4-FFF2-40B4-BE49-F238E27FC236}">
-                <a16:creationId xmlns:a16="http://schemas.microsoft.com/office/drawing/2014/main" id="{DDF5B516-D28E-4B30-B03B-1C6A27768437}"/>
+                <a16:creationId xmlns:a16="http://schemas.microsoft.com/office/drawing/2014/main" id="{B92C7931-B493-4892-BC71-FCB0B1066B95}"/>
               </a:ext>
             </a:extLst>
           </p:cNvPr>
@@ -9888,7 +9888,7 @@
     </p:spTree>
     <p:extLst>
       <p:ext uri="{BB962C8B-B14F-4D97-AF65-F5344CB8AC3E}">
-        <p14:creationId xmlns:p14="http://schemas.microsoft.com/office/powerpoint/2010/main" val="1824173764"/>
+        <p14:creationId xmlns:p14="http://schemas.microsoft.com/office/powerpoint/2010/main" val="896623099"/>
       </p:ext>
     </p:extLst>
   </p:cSld>
@@ -9912,7 +9912,7 @@
           <p:cNvPr id="44" name="">
             <a:extLst xmlns:a="http://schemas.openxmlformats.org/drawingml/2006/main">
               <a:ext uri="{FF2B5EF4-FFF2-40B4-BE49-F238E27FC236}">
-                <a16:creationId xmlns:a16="http://schemas.microsoft.com/office/drawing/2014/main" id="{599204C4-1394-4175-BE99-D3AF28B3E77F}"/>
+                <a16:creationId xmlns:a16="http://schemas.microsoft.com/office/drawing/2014/main" id="{3220D71B-AE17-4825-A6B1-7A1C96EDEAA5}"/>
               </a:ext>
             </a:extLst>
           </p:cNvPr>
@@ -9943,7 +9943,7 @@
           <p:cNvPr id="2" name="">
             <a:extLst xmlns:a="http://schemas.openxmlformats.org/drawingml/2006/main">
               <a:ext uri="{FF2B5EF4-FFF2-40B4-BE49-F238E27FC236}">
-                <a16:creationId xmlns:a16="http://schemas.microsoft.com/office/drawing/2014/main" id="{53155ACE-CF8C-436F-9983-3545111DFEB3}"/>
+                <a16:creationId xmlns:a16="http://schemas.microsoft.com/office/drawing/2014/main" id="{E9FFC59C-EC17-4E52-A801-3D3CED79E646}"/>
               </a:ext>
             </a:extLst>
           </p:cNvPr>
@@ -9988,7 +9988,7 @@
           <p:cNvPr id="3" name="">
             <a:extLst xmlns:a="http://schemas.openxmlformats.org/drawingml/2006/main">
               <a:ext uri="{FF2B5EF4-FFF2-40B4-BE49-F238E27FC236}">
-                <a16:creationId xmlns:a16="http://schemas.microsoft.com/office/drawing/2014/main" id="{3F750077-6CE5-44C2-8E17-D713826A1D5C}"/>
+                <a16:creationId xmlns:a16="http://schemas.microsoft.com/office/drawing/2014/main" id="{A5761EB6-4250-44D5-9971-648F96605E2A}"/>
               </a:ext>
             </a:extLst>
           </p:cNvPr>
@@ -10033,7 +10033,7 @@
           <p:cNvPr id="4" name="">
             <a:extLst xmlns:a="http://schemas.openxmlformats.org/drawingml/2006/main">
               <a:ext uri="{FF2B5EF4-FFF2-40B4-BE49-F238E27FC236}">
-                <a16:creationId xmlns:a16="http://schemas.microsoft.com/office/drawing/2014/main" id="{372F5C82-9157-4B3F-865E-E500584527AE}"/>
+                <a16:creationId xmlns:a16="http://schemas.microsoft.com/office/drawing/2014/main" id="{20336439-F3E9-403B-9632-4D072C671A19}"/>
               </a:ext>
             </a:extLst>
           </p:cNvPr>
@@ -10078,7 +10078,7 @@
           <p:cNvPr id="5" name="">
             <a:extLst xmlns:a="http://schemas.openxmlformats.org/drawingml/2006/main">
               <a:ext uri="{FF2B5EF4-FFF2-40B4-BE49-F238E27FC236}">
-                <a16:creationId xmlns:a16="http://schemas.microsoft.com/office/drawing/2014/main" id="{7FC2D602-6FC5-4EC1-98E2-0132F51FA913}"/>
+                <a16:creationId xmlns:a16="http://schemas.microsoft.com/office/drawing/2014/main" id="{D2C8CC76-4B5F-48F2-B55C-75F5A4947ABF}"/>
               </a:ext>
             </a:extLst>
           </p:cNvPr>
@@ -10109,7 +10109,7 @@
           <p:cNvPr id="6" name="">
             <a:extLst xmlns:a="http://schemas.openxmlformats.org/drawingml/2006/main">
               <a:ext uri="{FF2B5EF4-FFF2-40B4-BE49-F238E27FC236}">
-                <a16:creationId xmlns:a16="http://schemas.microsoft.com/office/drawing/2014/main" id="{F71F73D7-349D-4262-A4CD-2774048E52C3}"/>
+                <a16:creationId xmlns:a16="http://schemas.microsoft.com/office/drawing/2014/main" id="{FBA3EAF2-489B-46D6-B96A-E4844CD5811C}"/>
               </a:ext>
             </a:extLst>
           </p:cNvPr>
@@ -10140,7 +10140,7 @@
           <p:cNvPr id="7" name="">
             <a:extLst xmlns:a="http://schemas.openxmlformats.org/drawingml/2006/main">
               <a:ext uri="{FF2B5EF4-FFF2-40B4-BE49-F238E27FC236}">
-                <a16:creationId xmlns:a16="http://schemas.microsoft.com/office/drawing/2014/main" id="{BB5F21CF-72C9-413C-9438-B68B69F67E41}"/>
+                <a16:creationId xmlns:a16="http://schemas.microsoft.com/office/drawing/2014/main" id="{4094B3CC-C98A-493A-98BB-3A93440D690D}"/>
               </a:ext>
             </a:extLst>
           </p:cNvPr>
@@ -10185,7 +10185,7 @@
           <p:cNvPr id="8" name="">
             <a:extLst xmlns:a="http://schemas.openxmlformats.org/drawingml/2006/main">
               <a:ext uri="{FF2B5EF4-FFF2-40B4-BE49-F238E27FC236}">
-                <a16:creationId xmlns:a16="http://schemas.microsoft.com/office/drawing/2014/main" id="{DF6A7387-E804-4792-8662-ED59E781A8DC}"/>
+                <a16:creationId xmlns:a16="http://schemas.microsoft.com/office/drawing/2014/main" id="{63F591C6-087C-461A-8B03-8EAE8BAF1626}"/>
               </a:ext>
             </a:extLst>
           </p:cNvPr>
@@ -10230,7 +10230,7 @@
           <p:cNvPr id="9" name="">
             <a:extLst xmlns:a="http://schemas.openxmlformats.org/drawingml/2006/main">
               <a:ext uri="{FF2B5EF4-FFF2-40B4-BE49-F238E27FC236}">
-                <a16:creationId xmlns:a16="http://schemas.microsoft.com/office/drawing/2014/main" id="{2EBD89E7-E148-48C9-BB5A-3ADA8221ECB0}"/>
+                <a16:creationId xmlns:a16="http://schemas.microsoft.com/office/drawing/2014/main" id="{EAC377C5-22F9-46FE-8EA5-1B34F4BCDCFF}"/>
               </a:ext>
             </a:extLst>
           </p:cNvPr>
@@ -10263,7 +10263,7 @@
           <p:cNvPr id="10" name="">
             <a:extLst xmlns:a="http://schemas.openxmlformats.org/drawingml/2006/main">
               <a:ext uri="{FF2B5EF4-FFF2-40B4-BE49-F238E27FC236}">
-                <a16:creationId xmlns:a16="http://schemas.microsoft.com/office/drawing/2014/main" id="{85CF0091-05AC-4377-93A7-7B6A5A97E9FC}"/>
+                <a16:creationId xmlns:a16="http://schemas.microsoft.com/office/drawing/2014/main" id="{CF7F1C70-1B13-4C5C-BCF7-47DEFAA4B726}"/>
               </a:ext>
             </a:extLst>
           </p:cNvPr>
@@ -10294,7 +10294,7 @@
           <p:cNvPr id="11" name="">
             <a:extLst xmlns:a="http://schemas.openxmlformats.org/drawingml/2006/main">
               <a:ext uri="{FF2B5EF4-FFF2-40B4-BE49-F238E27FC236}">
-                <a16:creationId xmlns:a16="http://schemas.microsoft.com/office/drawing/2014/main" id="{C15E8676-9024-40FA-AD23-6547989C4819}"/>
+                <a16:creationId xmlns:a16="http://schemas.microsoft.com/office/drawing/2014/main" id="{84193A41-8707-4FBF-9629-CC5D6EE56AED}"/>
               </a:ext>
             </a:extLst>
           </p:cNvPr>
@@ -10339,7 +10339,7 @@
           <p:cNvPr id="12" name="">
             <a:extLst xmlns:a="http://schemas.openxmlformats.org/drawingml/2006/main">
               <a:ext uri="{FF2B5EF4-FFF2-40B4-BE49-F238E27FC236}">
-                <a16:creationId xmlns:a16="http://schemas.microsoft.com/office/drawing/2014/main" id="{34B8325E-C22C-4CED-8AE8-82305E7F7B73}"/>
+                <a16:creationId xmlns:a16="http://schemas.microsoft.com/office/drawing/2014/main" id="{D44B84AF-3FC7-44F3-B20E-FBA679FC1688}"/>
               </a:ext>
             </a:extLst>
           </p:cNvPr>
@@ -10384,7 +10384,7 @@
           <p:cNvPr id="13" name="">
             <a:extLst xmlns:a="http://schemas.openxmlformats.org/drawingml/2006/main">
               <a:ext uri="{FF2B5EF4-FFF2-40B4-BE49-F238E27FC236}">
-                <a16:creationId xmlns:a16="http://schemas.microsoft.com/office/drawing/2014/main" id="{6D2A68DE-98B7-4C3D-8497-B9A15C6F6933}"/>
+                <a16:creationId xmlns:a16="http://schemas.microsoft.com/office/drawing/2014/main" id="{0840F1D2-51B4-44B6-9981-C660EDA39688}"/>
               </a:ext>
             </a:extLst>
           </p:cNvPr>
@@ -10417,7 +10417,7 @@
           <p:cNvPr id="14" name="">
             <a:extLst xmlns:a="http://schemas.openxmlformats.org/drawingml/2006/main">
               <a:ext uri="{FF2B5EF4-FFF2-40B4-BE49-F238E27FC236}">
-                <a16:creationId xmlns:a16="http://schemas.microsoft.com/office/drawing/2014/main" id="{99AA7170-AE95-4E4F-A6E3-F9B1CA00F487}"/>
+                <a16:creationId xmlns:a16="http://schemas.microsoft.com/office/drawing/2014/main" id="{E651EA6B-5841-4294-96EA-887892415C74}"/>
               </a:ext>
             </a:extLst>
           </p:cNvPr>
@@ -10450,7 +10450,7 @@
           <p:cNvPr id="15" name="">
             <a:extLst xmlns:a="http://schemas.openxmlformats.org/drawingml/2006/main">
               <a:ext uri="{FF2B5EF4-FFF2-40B4-BE49-F238E27FC236}">
-                <a16:creationId xmlns:a16="http://schemas.microsoft.com/office/drawing/2014/main" id="{8ACD93BC-F7EB-47BC-8C9C-7F626087DD63}"/>
+                <a16:creationId xmlns:a16="http://schemas.microsoft.com/office/drawing/2014/main" id="{7DABEF2B-CF9B-4EE2-AF1F-DF6B0876D7A4}"/>
               </a:ext>
             </a:extLst>
           </p:cNvPr>
@@ -10481,7 +10481,7 @@
           <p:cNvPr id="16" name="">
             <a:extLst xmlns:a="http://schemas.openxmlformats.org/drawingml/2006/main">
               <a:ext uri="{FF2B5EF4-FFF2-40B4-BE49-F238E27FC236}">
-                <a16:creationId xmlns:a16="http://schemas.microsoft.com/office/drawing/2014/main" id="{0B8434FB-3E96-4142-8F64-AFBA38EF9024}"/>
+                <a16:creationId xmlns:a16="http://schemas.microsoft.com/office/drawing/2014/main" id="{AB7C0D81-7434-435E-A17F-2CB83FEDA846}"/>
               </a:ext>
             </a:extLst>
           </p:cNvPr>
@@ -10526,7 +10526,7 @@
           <p:cNvPr id="17" name="">
             <a:extLst xmlns:a="http://schemas.openxmlformats.org/drawingml/2006/main">
               <a:ext uri="{FF2B5EF4-FFF2-40B4-BE49-F238E27FC236}">
-                <a16:creationId xmlns:a16="http://schemas.microsoft.com/office/drawing/2014/main" id="{F67F7E31-4CDC-4B0D-AF89-1BEFF1A38DBD}"/>
+                <a16:creationId xmlns:a16="http://schemas.microsoft.com/office/drawing/2014/main" id="{85FBFA18-B463-4BEC-9D5C-90B978AB35D2}"/>
               </a:ext>
             </a:extLst>
           </p:cNvPr>
@@ -10571,7 +10571,7 @@
           <p:cNvPr id="18" name="">
             <a:extLst xmlns:a="http://schemas.openxmlformats.org/drawingml/2006/main">
               <a:ext uri="{FF2B5EF4-FFF2-40B4-BE49-F238E27FC236}">
-                <a16:creationId xmlns:a16="http://schemas.microsoft.com/office/drawing/2014/main" id="{DF1B71BA-47A0-408F-A5D6-456F718B9ABC}"/>
+                <a16:creationId xmlns:a16="http://schemas.microsoft.com/office/drawing/2014/main" id="{8E36A276-0C43-424B-8062-4344838F8BB9}"/>
               </a:ext>
             </a:extLst>
           </p:cNvPr>
@@ -10604,7 +10604,7 @@
           <p:cNvPr id="19" name="">
             <a:extLst xmlns:a="http://schemas.openxmlformats.org/drawingml/2006/main">
               <a:ext uri="{FF2B5EF4-FFF2-40B4-BE49-F238E27FC236}">
-                <a16:creationId xmlns:a16="http://schemas.microsoft.com/office/drawing/2014/main" id="{ACDE5D04-B578-4E07-9A70-E0ABD490B2F1}"/>
+                <a16:creationId xmlns:a16="http://schemas.microsoft.com/office/drawing/2014/main" id="{A23EB06F-5C42-4378-9F8B-8008D3B571CF}"/>
               </a:ext>
             </a:extLst>
           </p:cNvPr>
@@ -10637,7 +10637,7 @@
           <p:cNvPr id="20" name="">
             <a:extLst xmlns:a="http://schemas.openxmlformats.org/drawingml/2006/main">
               <a:ext uri="{FF2B5EF4-FFF2-40B4-BE49-F238E27FC236}">
-                <a16:creationId xmlns:a16="http://schemas.microsoft.com/office/drawing/2014/main" id="{30CC216F-69E8-4A45-A447-1CAEEE0C4DDF}"/>
+                <a16:creationId xmlns:a16="http://schemas.microsoft.com/office/drawing/2014/main" id="{C527D5CD-D479-4189-834F-325426CDA98E}"/>
               </a:ext>
             </a:extLst>
           </p:cNvPr>
@@ -10668,7 +10668,7 @@
           <p:cNvPr id="21" name="">
             <a:extLst xmlns:a="http://schemas.openxmlformats.org/drawingml/2006/main">
               <a:ext uri="{FF2B5EF4-FFF2-40B4-BE49-F238E27FC236}">
-                <a16:creationId xmlns:a16="http://schemas.microsoft.com/office/drawing/2014/main" id="{4AB42C10-00D0-4CC2-84F7-683510DF2AAA}"/>
+                <a16:creationId xmlns:a16="http://schemas.microsoft.com/office/drawing/2014/main" id="{6C5CC243-E9FE-4448-B804-07477061C1A4}"/>
               </a:ext>
             </a:extLst>
           </p:cNvPr>
@@ -10713,7 +10713,7 @@
           <p:cNvPr id="22" name="">
             <a:extLst xmlns:a="http://schemas.openxmlformats.org/drawingml/2006/main">
               <a:ext uri="{FF2B5EF4-FFF2-40B4-BE49-F238E27FC236}">
-                <a16:creationId xmlns:a16="http://schemas.microsoft.com/office/drawing/2014/main" id="{4F5F75F4-D149-4F4B-A93B-158D77285F15}"/>
+                <a16:creationId xmlns:a16="http://schemas.microsoft.com/office/drawing/2014/main" id="{F2A67512-4BAE-4377-A77B-0EF12384E673}"/>
               </a:ext>
             </a:extLst>
           </p:cNvPr>
@@ -10758,7 +10758,7 @@
           <p:cNvPr id="23" name="">
             <a:extLst xmlns:a="http://schemas.openxmlformats.org/drawingml/2006/main">
               <a:ext uri="{FF2B5EF4-FFF2-40B4-BE49-F238E27FC236}">
-                <a16:creationId xmlns:a16="http://schemas.microsoft.com/office/drawing/2014/main" id="{EADF57D9-0FAF-4B6A-A090-5F29643A4E8D}"/>
+                <a16:creationId xmlns:a16="http://schemas.microsoft.com/office/drawing/2014/main" id="{DBE03AB9-7206-4927-9B22-0CDF5D012436}"/>
               </a:ext>
             </a:extLst>
           </p:cNvPr>
@@ -10793,7 +10793,7 @@
           <p:cNvPr id="24" name="">
             <a:extLst xmlns:a="http://schemas.openxmlformats.org/drawingml/2006/main">
               <a:ext uri="{FF2B5EF4-FFF2-40B4-BE49-F238E27FC236}">
-                <a16:creationId xmlns:a16="http://schemas.microsoft.com/office/drawing/2014/main" id="{E1C30ADA-AB33-403F-A550-D04BF4C2A5F6}"/>
+                <a16:creationId xmlns:a16="http://schemas.microsoft.com/office/drawing/2014/main" id="{0D080231-D928-4C9A-B2F7-CDDDA0C05294}"/>
               </a:ext>
             </a:extLst>
           </p:cNvPr>
@@ -10824,7 +10824,7 @@
           <p:cNvPr id="25" name="">
             <a:extLst xmlns:a="http://schemas.openxmlformats.org/drawingml/2006/main">
               <a:ext uri="{FF2B5EF4-FFF2-40B4-BE49-F238E27FC236}">
-                <a16:creationId xmlns:a16="http://schemas.microsoft.com/office/drawing/2014/main" id="{102FE5DE-A549-410B-A0D9-7988B67A1FDB}"/>
+                <a16:creationId xmlns:a16="http://schemas.microsoft.com/office/drawing/2014/main" id="{F451FEDA-7E8F-413A-B6A5-F85094D50B55}"/>
               </a:ext>
             </a:extLst>
           </p:cNvPr>
@@ -10869,7 +10869,7 @@
           <p:cNvPr id="26" name="">
             <a:extLst xmlns:a="http://schemas.openxmlformats.org/drawingml/2006/main">
               <a:ext uri="{FF2B5EF4-FFF2-40B4-BE49-F238E27FC236}">
-                <a16:creationId xmlns:a16="http://schemas.microsoft.com/office/drawing/2014/main" id="{FFC657B7-9043-4A32-915D-7BB60B23B56B}"/>
+                <a16:creationId xmlns:a16="http://schemas.microsoft.com/office/drawing/2014/main" id="{CF2BA9C6-5B9C-4763-B290-5DC54F279931}"/>
               </a:ext>
             </a:extLst>
           </p:cNvPr>
@@ -10914,7 +10914,7 @@
           <p:cNvPr id="27" name="">
             <a:extLst xmlns:a="http://schemas.openxmlformats.org/drawingml/2006/main">
               <a:ext uri="{FF2B5EF4-FFF2-40B4-BE49-F238E27FC236}">
-                <a16:creationId xmlns:a16="http://schemas.microsoft.com/office/drawing/2014/main" id="{F4B342A8-4B0C-43C1-A7FF-73B1F4C067C8}"/>
+                <a16:creationId xmlns:a16="http://schemas.microsoft.com/office/drawing/2014/main" id="{4840D769-FA10-47BC-913C-F1EC05D84D99}"/>
               </a:ext>
             </a:extLst>
           </p:cNvPr>
@@ -10949,7 +10949,7 @@
           <p:cNvPr id="28" name="">
             <a:extLst xmlns:a="http://schemas.openxmlformats.org/drawingml/2006/main">
               <a:ext uri="{FF2B5EF4-FFF2-40B4-BE49-F238E27FC236}">
-                <a16:creationId xmlns:a16="http://schemas.microsoft.com/office/drawing/2014/main" id="{431C2C62-CA35-4A32-8E7E-455AB83AFBB8}"/>
+                <a16:creationId xmlns:a16="http://schemas.microsoft.com/office/drawing/2014/main" id="{526592ED-019A-42A5-AA35-D4CF8AD94BF7}"/>
               </a:ext>
             </a:extLst>
           </p:cNvPr>
@@ -10980,7 +10980,7 @@
           <p:cNvPr id="29" name="">
             <a:extLst xmlns:a="http://schemas.openxmlformats.org/drawingml/2006/main">
               <a:ext uri="{FF2B5EF4-FFF2-40B4-BE49-F238E27FC236}">
-                <a16:creationId xmlns:a16="http://schemas.microsoft.com/office/drawing/2014/main" id="{42731425-8ABD-45CC-9D87-F9FF219A8050}"/>
+                <a16:creationId xmlns:a16="http://schemas.microsoft.com/office/drawing/2014/main" id="{ACF8B72F-0AE9-4D1D-8C5E-8B7BD97E4B38}"/>
               </a:ext>
             </a:extLst>
           </p:cNvPr>
@@ -11025,7 +11025,7 @@
           <p:cNvPr id="30" name="">
             <a:extLst xmlns:a="http://schemas.openxmlformats.org/drawingml/2006/main">
               <a:ext uri="{FF2B5EF4-FFF2-40B4-BE49-F238E27FC236}">
-                <a16:creationId xmlns:a16="http://schemas.microsoft.com/office/drawing/2014/main" id="{82BC4F18-5AC2-4E41-96EA-787FC6BAB1C7}"/>
+                <a16:creationId xmlns:a16="http://schemas.microsoft.com/office/drawing/2014/main" id="{7D9CCF23-1FB0-40A1-9EC7-2FF1EE5F2F6C}"/>
               </a:ext>
             </a:extLst>
           </p:cNvPr>
@@ -11070,7 +11070,7 @@
           <p:cNvPr id="31" name="">
             <a:extLst xmlns:a="http://schemas.openxmlformats.org/drawingml/2006/main">
               <a:ext uri="{FF2B5EF4-FFF2-40B4-BE49-F238E27FC236}">
-                <a16:creationId xmlns:a16="http://schemas.microsoft.com/office/drawing/2014/main" id="{1F7FF368-2F49-4EFC-895B-AC5CB82973D6}"/>
+                <a16:creationId xmlns:a16="http://schemas.microsoft.com/office/drawing/2014/main" id="{1702DE60-4C06-4C8C-BE2E-69FB1388C172}"/>
               </a:ext>
             </a:extLst>
           </p:cNvPr>
@@ -11105,7 +11105,7 @@
           <p:cNvPr id="32" name="">
             <a:extLst xmlns:a="http://schemas.openxmlformats.org/drawingml/2006/main">
               <a:ext uri="{FF2B5EF4-FFF2-40B4-BE49-F238E27FC236}">
-                <a16:creationId xmlns:a16="http://schemas.microsoft.com/office/drawing/2014/main" id="{325C87AC-8905-4E9A-9CD1-6370578EB135}"/>
+                <a16:creationId xmlns:a16="http://schemas.microsoft.com/office/drawing/2014/main" id="{1E1DD3FD-F6EB-4B0D-80D3-7EC410EE56AF}"/>
               </a:ext>
             </a:extLst>
           </p:cNvPr>
@@ -11150,7 +11150,7 @@
           <p:cNvPr id="33" name="">
             <a:extLst xmlns:a="http://schemas.openxmlformats.org/drawingml/2006/main">
               <a:ext uri="{FF2B5EF4-FFF2-40B4-BE49-F238E27FC236}">
-                <a16:creationId xmlns:a16="http://schemas.microsoft.com/office/drawing/2014/main" id="{0CBDFADE-1493-42A3-BB59-7EFEBB79E214}"/>
+                <a16:creationId xmlns:a16="http://schemas.microsoft.com/office/drawing/2014/main" id="{90DD23B8-061C-43C1-9CE0-AA74F6DE1C9C}"/>
               </a:ext>
             </a:extLst>
           </p:cNvPr>
@@ -11195,7 +11195,7 @@
           <p:cNvPr id="34" name="">
             <a:extLst xmlns:a="http://schemas.openxmlformats.org/drawingml/2006/main">
               <a:ext uri="{FF2B5EF4-FFF2-40B4-BE49-F238E27FC236}">
-                <a16:creationId xmlns:a16="http://schemas.microsoft.com/office/drawing/2014/main" id="{A729F5B7-8E7D-4881-9957-3683FA847EEC}"/>
+                <a16:creationId xmlns:a16="http://schemas.microsoft.com/office/drawing/2014/main" id="{777EF4AD-98B5-4A45-93E5-E10142186199}"/>
               </a:ext>
             </a:extLst>
           </p:cNvPr>
@@ -11240,7 +11240,7 @@
           <p:cNvPr id="35" name="">
             <a:extLst xmlns:a="http://schemas.openxmlformats.org/drawingml/2006/main">
               <a:ext uri="{FF2B5EF4-FFF2-40B4-BE49-F238E27FC236}">
-                <a16:creationId xmlns:a16="http://schemas.microsoft.com/office/drawing/2014/main" id="{B8A701DF-F77C-4A82-8C3D-D3DDA6779EAE}"/>
+                <a16:creationId xmlns:a16="http://schemas.microsoft.com/office/drawing/2014/main" id="{6637BB10-5E64-4C39-9D9C-41D401217D00}"/>
               </a:ext>
             </a:extLst>
           </p:cNvPr>
@@ -11275,7 +11275,7 @@
           <p:cNvPr id="36" name="">
             <a:extLst xmlns:a="http://schemas.openxmlformats.org/drawingml/2006/main">
               <a:ext uri="{FF2B5EF4-FFF2-40B4-BE49-F238E27FC236}">
-                <a16:creationId xmlns:a16="http://schemas.microsoft.com/office/drawing/2014/main" id="{C780FF88-DACA-484E-BF44-513C1934EA5C}"/>
+                <a16:creationId xmlns:a16="http://schemas.microsoft.com/office/drawing/2014/main" id="{5DABF38B-B0F5-43D6-9EF3-7EA4C8C28036}"/>
               </a:ext>
             </a:extLst>
           </p:cNvPr>
@@ -11320,7 +11320,7 @@
           <p:cNvPr id="37" name="">
             <a:extLst xmlns:a="http://schemas.openxmlformats.org/drawingml/2006/main">
               <a:ext uri="{FF2B5EF4-FFF2-40B4-BE49-F238E27FC236}">
-                <a16:creationId xmlns:a16="http://schemas.microsoft.com/office/drawing/2014/main" id="{8A495955-3743-49F5-B41F-9E90D069AE7E}"/>
+                <a16:creationId xmlns:a16="http://schemas.microsoft.com/office/drawing/2014/main" id="{60DE68DF-E286-4FFE-9654-8787EBFC1B14}"/>
               </a:ext>
             </a:extLst>
           </p:cNvPr>
@@ -11365,7 +11365,7 @@
           <p:cNvPr id="38" name="">
             <a:extLst xmlns:a="http://schemas.openxmlformats.org/drawingml/2006/main">
               <a:ext uri="{FF2B5EF4-FFF2-40B4-BE49-F238E27FC236}">
-                <a16:creationId xmlns:a16="http://schemas.microsoft.com/office/drawing/2014/main" id="{C4671568-FB97-49DA-90BA-FD4D48FB375B}"/>
+                <a16:creationId xmlns:a16="http://schemas.microsoft.com/office/drawing/2014/main" id="{3CE8864C-8A41-498B-8707-F5BEA613412C}"/>
               </a:ext>
             </a:extLst>
           </p:cNvPr>
@@ -11410,7 +11410,7 @@
           <p:cNvPr id="39" name="">
             <a:extLst xmlns:a="http://schemas.openxmlformats.org/drawingml/2006/main">
               <a:ext uri="{FF2B5EF4-FFF2-40B4-BE49-F238E27FC236}">
-                <a16:creationId xmlns:a16="http://schemas.microsoft.com/office/drawing/2014/main" id="{39B8EDE7-D745-40DE-870B-EB9B8CA09D7D}"/>
+                <a16:creationId xmlns:a16="http://schemas.microsoft.com/office/drawing/2014/main" id="{957B6C1A-2D87-4158-AB86-0152B6543150}"/>
               </a:ext>
             </a:extLst>
           </p:cNvPr>
@@ -11445,7 +11445,7 @@
           <p:cNvPr id="40" name="">
             <a:extLst xmlns:a="http://schemas.openxmlformats.org/drawingml/2006/main">
               <a:ext uri="{FF2B5EF4-FFF2-40B4-BE49-F238E27FC236}">
-                <a16:creationId xmlns:a16="http://schemas.microsoft.com/office/drawing/2014/main" id="{630A34D3-60E2-4E4E-B12E-0B3DA5F15E3B}"/>
+                <a16:creationId xmlns:a16="http://schemas.microsoft.com/office/drawing/2014/main" id="{8D682E4F-7763-4208-AB92-3621FDFC0557}"/>
               </a:ext>
             </a:extLst>
           </p:cNvPr>
@@ -11490,7 +11490,7 @@
           <p:cNvPr id="41" name="">
             <a:extLst xmlns:a="http://schemas.openxmlformats.org/drawingml/2006/main">
               <a:ext uri="{FF2B5EF4-FFF2-40B4-BE49-F238E27FC236}">
-                <a16:creationId xmlns:a16="http://schemas.microsoft.com/office/drawing/2014/main" id="{E7E80DF5-4138-43E6-B9E6-18BCA63808CD}"/>
+                <a16:creationId xmlns:a16="http://schemas.microsoft.com/office/drawing/2014/main" id="{642A484E-3B8E-4E5D-9D56-50520E31983E}"/>
               </a:ext>
             </a:extLst>
           </p:cNvPr>
@@ -11535,7 +11535,7 @@
           <p:cNvPr id="42" name="">
             <a:extLst xmlns:a="http://schemas.openxmlformats.org/drawingml/2006/main">
               <a:ext uri="{FF2B5EF4-FFF2-40B4-BE49-F238E27FC236}">
-                <a16:creationId xmlns:a16="http://schemas.microsoft.com/office/drawing/2014/main" id="{D6395A87-9CBE-4FC5-8EB9-409433B2E9EA}"/>
+                <a16:creationId xmlns:a16="http://schemas.microsoft.com/office/drawing/2014/main" id="{BFB84E7B-9A6F-46EE-8B4C-30959D9B78AD}"/>
               </a:ext>
             </a:extLst>
           </p:cNvPr>
@@ -11580,7 +11580,7 @@
           <p:cNvPr id="43" name="">
             <a:extLst xmlns:a="http://schemas.openxmlformats.org/drawingml/2006/main">
               <a:ext uri="{FF2B5EF4-FFF2-40B4-BE49-F238E27FC236}">
-                <a16:creationId xmlns:a16="http://schemas.microsoft.com/office/drawing/2014/main" id="{076FCA5D-F82A-468D-8041-D46D3C4323F5}"/>
+                <a16:creationId xmlns:a16="http://schemas.microsoft.com/office/drawing/2014/main" id="{BCF92672-4EAA-46C3-A6E9-94E48B130051}"/>
               </a:ext>
             </a:extLst>
           </p:cNvPr>
@@ -11623,7 +11623,7 @@
     </p:spTree>
     <p:extLst>
       <p:ext uri="{BB962C8B-B14F-4D97-AF65-F5344CB8AC3E}">
-        <p14:creationId xmlns:p14="http://schemas.microsoft.com/office/powerpoint/2010/main" val="353363881"/>
+        <p14:creationId xmlns:p14="http://schemas.microsoft.com/office/powerpoint/2010/main" val="1121540361"/>
       </p:ext>
     </p:extLst>
   </p:cSld>
@@ -11647,7 +11647,7 @@
           <p:cNvPr id="42" name="">
             <a:extLst xmlns:a="http://schemas.openxmlformats.org/drawingml/2006/main">
               <a:ext uri="{FF2B5EF4-FFF2-40B4-BE49-F238E27FC236}">
-                <a16:creationId xmlns:a16="http://schemas.microsoft.com/office/drawing/2014/main" id="{E9B7065C-3191-4FBD-9A8B-0541B113398A}"/>
+                <a16:creationId xmlns:a16="http://schemas.microsoft.com/office/drawing/2014/main" id="{9A9F2E6B-5318-41CE-AE82-916913880FB6}"/>
               </a:ext>
             </a:extLst>
           </p:cNvPr>
@@ -11678,7 +11678,7 @@
           <p:cNvPr id="2" name="">
             <a:extLst xmlns:a="http://schemas.openxmlformats.org/drawingml/2006/main">
               <a:ext uri="{FF2B5EF4-FFF2-40B4-BE49-F238E27FC236}">
-                <a16:creationId xmlns:a16="http://schemas.microsoft.com/office/drawing/2014/main" id="{4A5DE23F-7C93-4C0B-A584-35EA47311304}"/>
+                <a16:creationId xmlns:a16="http://schemas.microsoft.com/office/drawing/2014/main" id="{7D951F2A-7554-4A4F-9ABE-F5ECB6A20458}"/>
               </a:ext>
             </a:extLst>
           </p:cNvPr>
@@ -11723,7 +11723,7 @@
           <p:cNvPr id="3" name="">
             <a:extLst xmlns:a="http://schemas.openxmlformats.org/drawingml/2006/main">
               <a:ext uri="{FF2B5EF4-FFF2-40B4-BE49-F238E27FC236}">
-                <a16:creationId xmlns:a16="http://schemas.microsoft.com/office/drawing/2014/main" id="{85F0A893-ADE3-4BBD-B487-8F1EEB651EA9}"/>
+                <a16:creationId xmlns:a16="http://schemas.microsoft.com/office/drawing/2014/main" id="{0630999F-4383-45F5-A67B-E8852FF893C3}"/>
               </a:ext>
             </a:extLst>
           </p:cNvPr>
@@ -11768,7 +11768,7 @@
           <p:cNvPr id="4" name="">
             <a:extLst xmlns:a="http://schemas.openxmlformats.org/drawingml/2006/main">
               <a:ext uri="{FF2B5EF4-FFF2-40B4-BE49-F238E27FC236}">
-                <a16:creationId xmlns:a16="http://schemas.microsoft.com/office/drawing/2014/main" id="{DF17D3F5-B89A-4FF5-B8ED-BD3ABE286141}"/>
+                <a16:creationId xmlns:a16="http://schemas.microsoft.com/office/drawing/2014/main" id="{0D8A39BF-C94A-45E5-BD86-BA00130E36E6}"/>
               </a:ext>
             </a:extLst>
           </p:cNvPr>
@@ -11813,7 +11813,7 @@
           <p:cNvPr id="5" name="">
             <a:extLst xmlns:a="http://schemas.openxmlformats.org/drawingml/2006/main">
               <a:ext uri="{FF2B5EF4-FFF2-40B4-BE49-F238E27FC236}">
-                <a16:creationId xmlns:a16="http://schemas.microsoft.com/office/drawing/2014/main" id="{B3E87ACE-B252-4386-85FF-B464F4DD9F26}"/>
+                <a16:creationId xmlns:a16="http://schemas.microsoft.com/office/drawing/2014/main" id="{00DD537F-C1D9-4B8C-BD9D-057A818B6FE5}"/>
               </a:ext>
             </a:extLst>
           </p:cNvPr>
@@ -11844,7 +11844,7 @@
           <p:cNvPr id="6" name="">
             <a:extLst xmlns:a="http://schemas.openxmlformats.org/drawingml/2006/main">
               <a:ext uri="{FF2B5EF4-FFF2-40B4-BE49-F238E27FC236}">
-                <a16:creationId xmlns:a16="http://schemas.microsoft.com/office/drawing/2014/main" id="{49B12B01-5B3D-4AB8-AB9C-6B2CFFFD3C95}"/>
+                <a16:creationId xmlns:a16="http://schemas.microsoft.com/office/drawing/2014/main" id="{DE64F1BD-6381-4284-AFD1-584A924787B9}"/>
               </a:ext>
             </a:extLst>
           </p:cNvPr>
@@ -11875,7 +11875,7 @@
           <p:cNvPr id="7" name="">
             <a:extLst xmlns:a="http://schemas.openxmlformats.org/drawingml/2006/main">
               <a:ext uri="{FF2B5EF4-FFF2-40B4-BE49-F238E27FC236}">
-                <a16:creationId xmlns:a16="http://schemas.microsoft.com/office/drawing/2014/main" id="{F8F71D55-2E04-4242-8BAD-4F347E7B423E}"/>
+                <a16:creationId xmlns:a16="http://schemas.microsoft.com/office/drawing/2014/main" id="{81586309-9CA3-4CEA-9EFB-9B7A2DF9F836}"/>
               </a:ext>
             </a:extLst>
           </p:cNvPr>
@@ -11920,7 +11920,7 @@
           <p:cNvPr id="8" name="">
             <a:extLst xmlns:a="http://schemas.openxmlformats.org/drawingml/2006/main">
               <a:ext uri="{FF2B5EF4-FFF2-40B4-BE49-F238E27FC236}">
-                <a16:creationId xmlns:a16="http://schemas.microsoft.com/office/drawing/2014/main" id="{CD75A01C-8F77-483E-8FAC-0C83AACC3833}"/>
+                <a16:creationId xmlns:a16="http://schemas.microsoft.com/office/drawing/2014/main" id="{145B83F6-D1EE-48AA-B5BA-D065DE31410F}"/>
               </a:ext>
             </a:extLst>
           </p:cNvPr>
@@ -11965,7 +11965,7 @@
           <p:cNvPr id="9" name="">
             <a:extLst xmlns:a="http://schemas.openxmlformats.org/drawingml/2006/main">
               <a:ext uri="{FF2B5EF4-FFF2-40B4-BE49-F238E27FC236}">
-                <a16:creationId xmlns:a16="http://schemas.microsoft.com/office/drawing/2014/main" id="{5D1E752E-5F5D-4210-9C8C-26DA7F83342F}"/>
+                <a16:creationId xmlns:a16="http://schemas.microsoft.com/office/drawing/2014/main" id="{408FC5FC-B1E6-4E80-B431-3385A251A55D}"/>
               </a:ext>
             </a:extLst>
           </p:cNvPr>
@@ -11998,7 +11998,7 @@
           <p:cNvPr id="10" name="">
             <a:extLst xmlns:a="http://schemas.openxmlformats.org/drawingml/2006/main">
               <a:ext uri="{FF2B5EF4-FFF2-40B4-BE49-F238E27FC236}">
-                <a16:creationId xmlns:a16="http://schemas.microsoft.com/office/drawing/2014/main" id="{060C3D2F-5645-4BAF-ADCE-C181E4101566}"/>
+                <a16:creationId xmlns:a16="http://schemas.microsoft.com/office/drawing/2014/main" id="{902E1D36-96C6-4F9F-9C46-5E74E013FAC0}"/>
               </a:ext>
             </a:extLst>
           </p:cNvPr>
@@ -12029,7 +12029,7 @@
           <p:cNvPr id="11" name="">
             <a:extLst xmlns:a="http://schemas.openxmlformats.org/drawingml/2006/main">
               <a:ext uri="{FF2B5EF4-FFF2-40B4-BE49-F238E27FC236}">
-                <a16:creationId xmlns:a16="http://schemas.microsoft.com/office/drawing/2014/main" id="{D3FC83F6-DBB3-4A52-B1CF-0483E6B0A351}"/>
+                <a16:creationId xmlns:a16="http://schemas.microsoft.com/office/drawing/2014/main" id="{4CF15077-D57C-44B9-937D-1F9FF4BE5250}"/>
               </a:ext>
             </a:extLst>
           </p:cNvPr>
@@ -12074,7 +12074,7 @@
           <p:cNvPr id="12" name="">
             <a:extLst xmlns:a="http://schemas.openxmlformats.org/drawingml/2006/main">
               <a:ext uri="{FF2B5EF4-FFF2-40B4-BE49-F238E27FC236}">
-                <a16:creationId xmlns:a16="http://schemas.microsoft.com/office/drawing/2014/main" id="{24F93DA4-7A1F-489F-A634-C3CF05D61C32}"/>
+                <a16:creationId xmlns:a16="http://schemas.microsoft.com/office/drawing/2014/main" id="{91DE44D3-6CEC-423C-96E3-737FE8FD06E1}"/>
               </a:ext>
             </a:extLst>
           </p:cNvPr>
@@ -12119,7 +12119,7 @@
           <p:cNvPr id="13" name="">
             <a:extLst xmlns:a="http://schemas.openxmlformats.org/drawingml/2006/main">
               <a:ext uri="{FF2B5EF4-FFF2-40B4-BE49-F238E27FC236}">
-                <a16:creationId xmlns:a16="http://schemas.microsoft.com/office/drawing/2014/main" id="{3B3BB445-C4D1-43BF-AF46-DBD9DE1BF811}"/>
+                <a16:creationId xmlns:a16="http://schemas.microsoft.com/office/drawing/2014/main" id="{481F2451-0AE5-4E93-998B-9B2B2C55B798}"/>
               </a:ext>
             </a:extLst>
           </p:cNvPr>
@@ -12152,7 +12152,7 @@
           <p:cNvPr id="14" name="">
             <a:extLst xmlns:a="http://schemas.openxmlformats.org/drawingml/2006/main">
               <a:ext uri="{FF2B5EF4-FFF2-40B4-BE49-F238E27FC236}">
-                <a16:creationId xmlns:a16="http://schemas.microsoft.com/office/drawing/2014/main" id="{CF81D063-4041-4971-91F6-1A8727697E25}"/>
+                <a16:creationId xmlns:a16="http://schemas.microsoft.com/office/drawing/2014/main" id="{59DEFA49-F5A1-4A87-BD8B-19F859029F0E}"/>
               </a:ext>
             </a:extLst>
           </p:cNvPr>
@@ -12185,7 +12185,7 @@
           <p:cNvPr id="15" name="">
             <a:extLst xmlns:a="http://schemas.openxmlformats.org/drawingml/2006/main">
               <a:ext uri="{FF2B5EF4-FFF2-40B4-BE49-F238E27FC236}">
-                <a16:creationId xmlns:a16="http://schemas.microsoft.com/office/drawing/2014/main" id="{D69BB173-D56D-403C-A0AE-794A2D1B79BD}"/>
+                <a16:creationId xmlns:a16="http://schemas.microsoft.com/office/drawing/2014/main" id="{70538C4D-818D-494E-9E21-D896B2AAF471}"/>
               </a:ext>
             </a:extLst>
           </p:cNvPr>
@@ -12216,7 +12216,7 @@
           <p:cNvPr id="16" name="">
             <a:extLst xmlns:a="http://schemas.openxmlformats.org/drawingml/2006/main">
               <a:ext uri="{FF2B5EF4-FFF2-40B4-BE49-F238E27FC236}">
-                <a16:creationId xmlns:a16="http://schemas.microsoft.com/office/drawing/2014/main" id="{F7213EA0-18DB-467A-90A6-15E65A8803D0}"/>
+                <a16:creationId xmlns:a16="http://schemas.microsoft.com/office/drawing/2014/main" id="{66EBE2D1-B038-4CB8-8BE5-DBA0A06D5C6D}"/>
               </a:ext>
             </a:extLst>
           </p:cNvPr>
@@ -12261,7 +12261,7 @@
           <p:cNvPr id="17" name="">
             <a:extLst xmlns:a="http://schemas.openxmlformats.org/drawingml/2006/main">
               <a:ext uri="{FF2B5EF4-FFF2-40B4-BE49-F238E27FC236}">
-                <a16:creationId xmlns:a16="http://schemas.microsoft.com/office/drawing/2014/main" id="{8B6DF5FB-2BCE-47CC-B82A-B5F9AE6E5215}"/>
+                <a16:creationId xmlns:a16="http://schemas.microsoft.com/office/drawing/2014/main" id="{5AA72290-591B-40B5-A31A-0C008331937D}"/>
               </a:ext>
             </a:extLst>
           </p:cNvPr>
@@ -12306,7 +12306,7 @@
           <p:cNvPr id="18" name="">
             <a:extLst xmlns:a="http://schemas.openxmlformats.org/drawingml/2006/main">
               <a:ext uri="{FF2B5EF4-FFF2-40B4-BE49-F238E27FC236}">
-                <a16:creationId xmlns:a16="http://schemas.microsoft.com/office/drawing/2014/main" id="{3DBB9A18-C292-41EC-A016-0CFF4F594774}"/>
+                <a16:creationId xmlns:a16="http://schemas.microsoft.com/office/drawing/2014/main" id="{61FF72A7-A0CA-488C-AEEA-EE5D097B64FC}"/>
               </a:ext>
             </a:extLst>
           </p:cNvPr>
@@ -12339,7 +12339,7 @@
           <p:cNvPr id="19" name="">
             <a:extLst xmlns:a="http://schemas.openxmlformats.org/drawingml/2006/main">
               <a:ext uri="{FF2B5EF4-FFF2-40B4-BE49-F238E27FC236}">
-                <a16:creationId xmlns:a16="http://schemas.microsoft.com/office/drawing/2014/main" id="{7AD30D42-4389-48BC-9366-AC5895E4D28D}"/>
+                <a16:creationId xmlns:a16="http://schemas.microsoft.com/office/drawing/2014/main" id="{54B4A3AC-7CA4-4C13-9483-E77CE4210645}"/>
               </a:ext>
             </a:extLst>
           </p:cNvPr>
@@ -12372,7 +12372,7 @@
           <p:cNvPr id="20" name="">
             <a:extLst xmlns:a="http://schemas.openxmlformats.org/drawingml/2006/main">
               <a:ext uri="{FF2B5EF4-FFF2-40B4-BE49-F238E27FC236}">
-                <a16:creationId xmlns:a16="http://schemas.microsoft.com/office/drawing/2014/main" id="{E874CE91-DB4B-455F-9D0D-16E407F347BD}"/>
+                <a16:creationId xmlns:a16="http://schemas.microsoft.com/office/drawing/2014/main" id="{C33A1746-5FC2-4A52-89DC-877AD1A47CA3}"/>
               </a:ext>
             </a:extLst>
           </p:cNvPr>
@@ -12403,7 +12403,7 @@
           <p:cNvPr id="21" name="">
             <a:extLst xmlns:a="http://schemas.openxmlformats.org/drawingml/2006/main">
               <a:ext uri="{FF2B5EF4-FFF2-40B4-BE49-F238E27FC236}">
-                <a16:creationId xmlns:a16="http://schemas.microsoft.com/office/drawing/2014/main" id="{38B7AC0B-E101-4852-884C-B98568B50A04}"/>
+                <a16:creationId xmlns:a16="http://schemas.microsoft.com/office/drawing/2014/main" id="{63424751-AFA2-4343-94E9-41DC112445D0}"/>
               </a:ext>
             </a:extLst>
           </p:cNvPr>
@@ -12448,7 +12448,7 @@
           <p:cNvPr id="22" name="">
             <a:extLst xmlns:a="http://schemas.openxmlformats.org/drawingml/2006/main">
               <a:ext uri="{FF2B5EF4-FFF2-40B4-BE49-F238E27FC236}">
-                <a16:creationId xmlns:a16="http://schemas.microsoft.com/office/drawing/2014/main" id="{4907D9DC-9F68-40AF-B1ED-B779233A15FB}"/>
+                <a16:creationId xmlns:a16="http://schemas.microsoft.com/office/drawing/2014/main" id="{97E28E41-2F3B-40CA-BAAA-A50B4A02E02D}"/>
               </a:ext>
             </a:extLst>
           </p:cNvPr>
@@ -12493,7 +12493,7 @@
           <p:cNvPr id="23" name="">
             <a:extLst xmlns:a="http://schemas.openxmlformats.org/drawingml/2006/main">
               <a:ext uri="{FF2B5EF4-FFF2-40B4-BE49-F238E27FC236}">
-                <a16:creationId xmlns:a16="http://schemas.microsoft.com/office/drawing/2014/main" id="{4C00C9CA-AF00-4B69-B594-2B89DD9BE074}"/>
+                <a16:creationId xmlns:a16="http://schemas.microsoft.com/office/drawing/2014/main" id="{C94C941E-8D17-42F9-8C4B-A9B301435BE6}"/>
               </a:ext>
             </a:extLst>
           </p:cNvPr>
@@ -12526,7 +12526,7 @@
           <p:cNvPr id="24" name="">
             <a:extLst xmlns:a="http://schemas.openxmlformats.org/drawingml/2006/main">
               <a:ext uri="{FF2B5EF4-FFF2-40B4-BE49-F238E27FC236}">
-                <a16:creationId xmlns:a16="http://schemas.microsoft.com/office/drawing/2014/main" id="{64D9D7A4-C5D4-4E44-B8BC-D0FC2BCE06FB}"/>
+                <a16:creationId xmlns:a16="http://schemas.microsoft.com/office/drawing/2014/main" id="{BA28FA37-A9C5-4E3A-BAF0-11C2F937A4DC}"/>
               </a:ext>
             </a:extLst>
           </p:cNvPr>
@@ -12559,7 +12559,7 @@
           <p:cNvPr id="25" name="">
             <a:extLst xmlns:a="http://schemas.openxmlformats.org/drawingml/2006/main">
               <a:ext uri="{FF2B5EF4-FFF2-40B4-BE49-F238E27FC236}">
-                <a16:creationId xmlns:a16="http://schemas.microsoft.com/office/drawing/2014/main" id="{515DC4CB-44E1-463B-8FF1-6C517402B64C}"/>
+                <a16:creationId xmlns:a16="http://schemas.microsoft.com/office/drawing/2014/main" id="{2745BB0F-B331-4CED-BA89-8D973CE92F7D}"/>
               </a:ext>
             </a:extLst>
           </p:cNvPr>
@@ -12590,7 +12590,7 @@
           <p:cNvPr id="26" name="">
             <a:extLst xmlns:a="http://schemas.openxmlformats.org/drawingml/2006/main">
               <a:ext uri="{FF2B5EF4-FFF2-40B4-BE49-F238E27FC236}">
-                <a16:creationId xmlns:a16="http://schemas.microsoft.com/office/drawing/2014/main" id="{E35DC469-0632-400E-88F1-7F2686D188AD}"/>
+                <a16:creationId xmlns:a16="http://schemas.microsoft.com/office/drawing/2014/main" id="{EA197C63-5F6F-481E-BE8E-6ADBCEB76B05}"/>
               </a:ext>
             </a:extLst>
           </p:cNvPr>
@@ -12635,7 +12635,7 @@
           <p:cNvPr id="27" name="">
             <a:extLst xmlns:a="http://schemas.openxmlformats.org/drawingml/2006/main">
               <a:ext uri="{FF2B5EF4-FFF2-40B4-BE49-F238E27FC236}">
-                <a16:creationId xmlns:a16="http://schemas.microsoft.com/office/drawing/2014/main" id="{EBB0C49D-2C34-463D-B2E6-009580433D38}"/>
+                <a16:creationId xmlns:a16="http://schemas.microsoft.com/office/drawing/2014/main" id="{AF04210C-1B61-4C2D-96EB-EA195D71D686}"/>
               </a:ext>
             </a:extLst>
           </p:cNvPr>
@@ -12680,7 +12680,7 @@
           <p:cNvPr id="28" name="">
             <a:extLst xmlns:a="http://schemas.openxmlformats.org/drawingml/2006/main">
               <a:ext uri="{FF2B5EF4-FFF2-40B4-BE49-F238E27FC236}">
-                <a16:creationId xmlns:a16="http://schemas.microsoft.com/office/drawing/2014/main" id="{FDEFC0C7-0217-4B30-B799-7F52BB5E0667}"/>
+                <a16:creationId xmlns:a16="http://schemas.microsoft.com/office/drawing/2014/main" id="{CC03D493-BFD7-4DCD-8A4A-6479F97DA52D}"/>
               </a:ext>
             </a:extLst>
           </p:cNvPr>
@@ -12715,7 +12715,7 @@
           <p:cNvPr id="29" name="">
             <a:extLst xmlns:a="http://schemas.openxmlformats.org/drawingml/2006/main">
               <a:ext uri="{FF2B5EF4-FFF2-40B4-BE49-F238E27FC236}">
-                <a16:creationId xmlns:a16="http://schemas.microsoft.com/office/drawing/2014/main" id="{F301146B-D37A-4B1C-85F9-B94FD846ECAA}"/>
+                <a16:creationId xmlns:a16="http://schemas.microsoft.com/office/drawing/2014/main" id="{CD79B029-C21D-4F40-AA64-83237EB669FA}"/>
               </a:ext>
             </a:extLst>
           </p:cNvPr>
@@ -12746,7 +12746,7 @@
           <p:cNvPr id="30" name="">
             <a:extLst xmlns:a="http://schemas.openxmlformats.org/drawingml/2006/main">
               <a:ext uri="{FF2B5EF4-FFF2-40B4-BE49-F238E27FC236}">
-                <a16:creationId xmlns:a16="http://schemas.microsoft.com/office/drawing/2014/main" id="{7F9AF0F1-35D0-4FC1-8DC4-6B38CEFA5D07}"/>
+                <a16:creationId xmlns:a16="http://schemas.microsoft.com/office/drawing/2014/main" id="{7534B65D-48B5-400B-B9E8-30B48281D5F7}"/>
               </a:ext>
             </a:extLst>
           </p:cNvPr>
@@ -12791,7 +12791,7 @@
           <p:cNvPr id="31" name="">
             <a:extLst xmlns:a="http://schemas.openxmlformats.org/drawingml/2006/main">
               <a:ext uri="{FF2B5EF4-FFF2-40B4-BE49-F238E27FC236}">
-                <a16:creationId xmlns:a16="http://schemas.microsoft.com/office/drawing/2014/main" id="{78B9E50B-36E6-4EEF-AC62-F6C741B99BF4}"/>
+                <a16:creationId xmlns:a16="http://schemas.microsoft.com/office/drawing/2014/main" id="{E9ADE771-CA24-4804-956E-B09F1A2D731D}"/>
               </a:ext>
             </a:extLst>
           </p:cNvPr>
@@ -12836,7 +12836,7 @@
           <p:cNvPr id="32" name="">
             <a:extLst xmlns:a="http://schemas.openxmlformats.org/drawingml/2006/main">
               <a:ext uri="{FF2B5EF4-FFF2-40B4-BE49-F238E27FC236}">
-                <a16:creationId xmlns:a16="http://schemas.microsoft.com/office/drawing/2014/main" id="{4BA2090C-509A-450E-8CE5-51FC96A556FA}"/>
+                <a16:creationId xmlns:a16="http://schemas.microsoft.com/office/drawing/2014/main" id="{1E329A0A-D44F-4898-9F74-2466EA86BA96}"/>
               </a:ext>
             </a:extLst>
           </p:cNvPr>
@@ -12871,7 +12871,7 @@
           <p:cNvPr id="33" name="">
             <a:extLst xmlns:a="http://schemas.openxmlformats.org/drawingml/2006/main">
               <a:ext uri="{FF2B5EF4-FFF2-40B4-BE49-F238E27FC236}">
-                <a16:creationId xmlns:a16="http://schemas.microsoft.com/office/drawing/2014/main" id="{6F9C2887-15B8-4F91-BD82-AC09BD746023}"/>
+                <a16:creationId xmlns:a16="http://schemas.microsoft.com/office/drawing/2014/main" id="{045A68FF-A94F-402F-A1A9-410B49F2B197}"/>
               </a:ext>
             </a:extLst>
           </p:cNvPr>
@@ -12902,7 +12902,7 @@
           <p:cNvPr id="34" name="">
             <a:extLst xmlns:a="http://schemas.openxmlformats.org/drawingml/2006/main">
               <a:ext uri="{FF2B5EF4-FFF2-40B4-BE49-F238E27FC236}">
-                <a16:creationId xmlns:a16="http://schemas.microsoft.com/office/drawing/2014/main" id="{EA0E3E21-C923-4057-92A4-DEF544F64598}"/>
+                <a16:creationId xmlns:a16="http://schemas.microsoft.com/office/drawing/2014/main" id="{4E297F45-8492-4F77-8749-88E9BC6527A4}"/>
               </a:ext>
             </a:extLst>
           </p:cNvPr>
@@ -12947,7 +12947,7 @@
           <p:cNvPr id="35" name="">
             <a:extLst xmlns:a="http://schemas.openxmlformats.org/drawingml/2006/main">
               <a:ext uri="{FF2B5EF4-FFF2-40B4-BE49-F238E27FC236}">
-                <a16:creationId xmlns:a16="http://schemas.microsoft.com/office/drawing/2014/main" id="{607C4101-366A-4DA7-B7CE-0D158635F33A}"/>
+                <a16:creationId xmlns:a16="http://schemas.microsoft.com/office/drawing/2014/main" id="{DD943F76-2362-4F0B-85FD-723C53D2DA9B}"/>
               </a:ext>
             </a:extLst>
           </p:cNvPr>
@@ -12992,7 +12992,7 @@
           <p:cNvPr id="36" name="">
             <a:extLst xmlns:a="http://schemas.openxmlformats.org/drawingml/2006/main">
               <a:ext uri="{FF2B5EF4-FFF2-40B4-BE49-F238E27FC236}">
-                <a16:creationId xmlns:a16="http://schemas.microsoft.com/office/drawing/2014/main" id="{D2C818C1-0117-4886-89D0-55FA8EEC7D9C}"/>
+                <a16:creationId xmlns:a16="http://schemas.microsoft.com/office/drawing/2014/main" id="{FEB5C41C-C845-4D71-9017-19BE8CE50724}"/>
               </a:ext>
             </a:extLst>
           </p:cNvPr>
@@ -13027,7 +13027,7 @@
           <p:cNvPr id="37" name="">
             <a:extLst xmlns:a="http://schemas.openxmlformats.org/drawingml/2006/main">
               <a:ext uri="{FF2B5EF4-FFF2-40B4-BE49-F238E27FC236}">
-                <a16:creationId xmlns:a16="http://schemas.microsoft.com/office/drawing/2014/main" id="{AE44569A-D312-4DFB-B453-1BA8E095C747}"/>
+                <a16:creationId xmlns:a16="http://schemas.microsoft.com/office/drawing/2014/main" id="{7CAFC268-2CF8-45F7-AE99-15681B9D2013}"/>
               </a:ext>
             </a:extLst>
           </p:cNvPr>
@@ -13058,7 +13058,7 @@
           <p:cNvPr id="38" name="">
             <a:extLst xmlns:a="http://schemas.openxmlformats.org/drawingml/2006/main">
               <a:ext uri="{FF2B5EF4-FFF2-40B4-BE49-F238E27FC236}">
-                <a16:creationId xmlns:a16="http://schemas.microsoft.com/office/drawing/2014/main" id="{CE324C71-D417-47C2-91DD-803DDADF469C}"/>
+                <a16:creationId xmlns:a16="http://schemas.microsoft.com/office/drawing/2014/main" id="{6DC4ABD5-3254-47C0-A51A-20FA4FD2B828}"/>
               </a:ext>
             </a:extLst>
           </p:cNvPr>
@@ -13103,7 +13103,7 @@
           <p:cNvPr id="39" name="">
             <a:extLst xmlns:a="http://schemas.openxmlformats.org/drawingml/2006/main">
               <a:ext uri="{FF2B5EF4-FFF2-40B4-BE49-F238E27FC236}">
-                <a16:creationId xmlns:a16="http://schemas.microsoft.com/office/drawing/2014/main" id="{7FAA13D8-FFE0-412E-A091-7E2815D451F1}"/>
+                <a16:creationId xmlns:a16="http://schemas.microsoft.com/office/drawing/2014/main" id="{AB7BC452-3399-4BD4-BFF5-D2E721CBCB27}"/>
               </a:ext>
             </a:extLst>
           </p:cNvPr>
@@ -13148,7 +13148,7 @@
           <p:cNvPr id="40" name="">
             <a:extLst xmlns:a="http://schemas.openxmlformats.org/drawingml/2006/main">
               <a:ext uri="{FF2B5EF4-FFF2-40B4-BE49-F238E27FC236}">
-                <a16:creationId xmlns:a16="http://schemas.microsoft.com/office/drawing/2014/main" id="{D331A056-E3FE-4B8E-A6C7-253C41C91323}"/>
+                <a16:creationId xmlns:a16="http://schemas.microsoft.com/office/drawing/2014/main" id="{67CF0CD4-3275-464D-8608-1E9CF8604FDD}"/>
               </a:ext>
             </a:extLst>
           </p:cNvPr>
@@ -13193,7 +13193,7 @@
           <p:cNvPr id="41" name="">
             <a:extLst xmlns:a="http://schemas.openxmlformats.org/drawingml/2006/main">
               <a:ext uri="{FF2B5EF4-FFF2-40B4-BE49-F238E27FC236}">
-                <a16:creationId xmlns:a16="http://schemas.microsoft.com/office/drawing/2014/main" id="{C3E9B4F5-9F4E-4AEA-8958-E565CCDE3CFC}"/>
+                <a16:creationId xmlns:a16="http://schemas.microsoft.com/office/drawing/2014/main" id="{59C90367-B774-4EE0-A704-2C17642B3B6B}"/>
               </a:ext>
             </a:extLst>
           </p:cNvPr>
@@ -13236,7 +13236,7 @@
     </p:spTree>
     <p:extLst>
       <p:ext uri="{BB962C8B-B14F-4D97-AF65-F5344CB8AC3E}">
-        <p14:creationId xmlns:p14="http://schemas.microsoft.com/office/powerpoint/2010/main" val="1508250431"/>
+        <p14:creationId xmlns:p14="http://schemas.microsoft.com/office/powerpoint/2010/main" val="41730283"/>
       </p:ext>
     </p:extLst>
   </p:cSld>
@@ -13260,7 +13260,7 @@
           <p:cNvPr id="47" name="">
             <a:extLst xmlns:a="http://schemas.openxmlformats.org/drawingml/2006/main">
               <a:ext uri="{FF2B5EF4-FFF2-40B4-BE49-F238E27FC236}">
-                <a16:creationId xmlns:a16="http://schemas.microsoft.com/office/drawing/2014/main" id="{97469A4E-B230-4BF5-A64C-F826736D4700}"/>
+                <a16:creationId xmlns:a16="http://schemas.microsoft.com/office/drawing/2014/main" id="{1411D0D1-8908-4228-AB7B-7F52FCDAC8BC}"/>
               </a:ext>
             </a:extLst>
           </p:cNvPr>
@@ -13291,7 +13291,7 @@
           <p:cNvPr id="2" name="">
             <a:extLst xmlns:a="http://schemas.openxmlformats.org/drawingml/2006/main">
               <a:ext uri="{FF2B5EF4-FFF2-40B4-BE49-F238E27FC236}">
-                <a16:creationId xmlns:a16="http://schemas.microsoft.com/office/drawing/2014/main" id="{C22A9C42-8BCB-43DA-AA32-1A66718C3E42}"/>
+                <a16:creationId xmlns:a16="http://schemas.microsoft.com/office/drawing/2014/main" id="{E88865F8-CD88-47A7-BC2F-57B11EAD669D}"/>
               </a:ext>
             </a:extLst>
           </p:cNvPr>
@@ -13336,7 +13336,7 @@
           <p:cNvPr id="3" name="">
             <a:extLst xmlns:a="http://schemas.openxmlformats.org/drawingml/2006/main">
               <a:ext uri="{FF2B5EF4-FFF2-40B4-BE49-F238E27FC236}">
-                <a16:creationId xmlns:a16="http://schemas.microsoft.com/office/drawing/2014/main" id="{94375B89-6251-4309-A6B9-46D50CD4BE8D}"/>
+                <a16:creationId xmlns:a16="http://schemas.microsoft.com/office/drawing/2014/main" id="{95E3EA13-1961-4C92-859E-15C7DCDA6420}"/>
               </a:ext>
             </a:extLst>
           </p:cNvPr>
@@ -13381,7 +13381,7 @@
           <p:cNvPr id="4" name="">
             <a:extLst xmlns:a="http://schemas.openxmlformats.org/drawingml/2006/main">
               <a:ext uri="{FF2B5EF4-FFF2-40B4-BE49-F238E27FC236}">
-                <a16:creationId xmlns:a16="http://schemas.microsoft.com/office/drawing/2014/main" id="{69ED4A20-4554-484B-8BDB-B56A151B3147}"/>
+                <a16:creationId xmlns:a16="http://schemas.microsoft.com/office/drawing/2014/main" id="{293936ED-A6A2-405D-A014-81994A18AC01}"/>
               </a:ext>
             </a:extLst>
           </p:cNvPr>
@@ -13426,7 +13426,7 @@
           <p:cNvPr id="5" name="">
             <a:extLst xmlns:a="http://schemas.openxmlformats.org/drawingml/2006/main">
               <a:ext uri="{FF2B5EF4-FFF2-40B4-BE49-F238E27FC236}">
-                <a16:creationId xmlns:a16="http://schemas.microsoft.com/office/drawing/2014/main" id="{FDEF4AED-9D16-492F-AE8A-A8C3F1D0EBC6}"/>
+                <a16:creationId xmlns:a16="http://schemas.microsoft.com/office/drawing/2014/main" id="{F004EE54-D378-4EAB-9FD8-A5E85162463C}"/>
               </a:ext>
             </a:extLst>
           </p:cNvPr>
@@ -13457,7 +13457,7 @@
           <p:cNvPr id="6" name="">
             <a:extLst xmlns:a="http://schemas.openxmlformats.org/drawingml/2006/main">
               <a:ext uri="{FF2B5EF4-FFF2-40B4-BE49-F238E27FC236}">
-                <a16:creationId xmlns:a16="http://schemas.microsoft.com/office/drawing/2014/main" id="{6B111373-E421-4545-B6E5-E754685647D8}"/>
+                <a16:creationId xmlns:a16="http://schemas.microsoft.com/office/drawing/2014/main" id="{4B8248F3-A008-4C2C-8E99-1563C38624C0}"/>
               </a:ext>
             </a:extLst>
           </p:cNvPr>
@@ -13488,7 +13488,7 @@
           <p:cNvPr id="7" name="">
             <a:extLst xmlns:a="http://schemas.openxmlformats.org/drawingml/2006/main">
               <a:ext uri="{FF2B5EF4-FFF2-40B4-BE49-F238E27FC236}">
-                <a16:creationId xmlns:a16="http://schemas.microsoft.com/office/drawing/2014/main" id="{9AC23B95-F787-4B57-A7F6-5C3D5F57C358}"/>
+                <a16:creationId xmlns:a16="http://schemas.microsoft.com/office/drawing/2014/main" id="{54EC602D-706B-4CF0-A35D-D80294FAAD7A}"/>
               </a:ext>
             </a:extLst>
           </p:cNvPr>
@@ -13533,7 +13533,7 @@
           <p:cNvPr id="8" name="">
             <a:extLst xmlns:a="http://schemas.openxmlformats.org/drawingml/2006/main">
               <a:ext uri="{FF2B5EF4-FFF2-40B4-BE49-F238E27FC236}">
-                <a16:creationId xmlns:a16="http://schemas.microsoft.com/office/drawing/2014/main" id="{E3AD947A-A853-44DF-A86F-450DF96FDDC9}"/>
+                <a16:creationId xmlns:a16="http://schemas.microsoft.com/office/drawing/2014/main" id="{757741AF-1520-4E57-A0A4-3A69A730A9B1}"/>
               </a:ext>
             </a:extLst>
           </p:cNvPr>
@@ -13578,7 +13578,7 @@
           <p:cNvPr id="9" name="">
             <a:extLst xmlns:a="http://schemas.openxmlformats.org/drawingml/2006/main">
               <a:ext uri="{FF2B5EF4-FFF2-40B4-BE49-F238E27FC236}">
-                <a16:creationId xmlns:a16="http://schemas.microsoft.com/office/drawing/2014/main" id="{B129245C-5082-4B48-8DEB-BC041441D6D9}"/>
+                <a16:creationId xmlns:a16="http://schemas.microsoft.com/office/drawing/2014/main" id="{4FCFC9A8-9AE2-4BC8-86D5-4137DF13ECD7}"/>
               </a:ext>
             </a:extLst>
           </p:cNvPr>
@@ -13609,7 +13609,7 @@
           <p:cNvPr id="10" name="">
             <a:extLst xmlns:a="http://schemas.openxmlformats.org/drawingml/2006/main">
               <a:ext uri="{FF2B5EF4-FFF2-40B4-BE49-F238E27FC236}">
-                <a16:creationId xmlns:a16="http://schemas.microsoft.com/office/drawing/2014/main" id="{0D4C0973-011C-43E2-A4C4-4B1D486C42CC}"/>
+                <a16:creationId xmlns:a16="http://schemas.microsoft.com/office/drawing/2014/main" id="{6C1E77C7-040A-4E77-A45D-FFA87694CC7D}"/>
               </a:ext>
             </a:extLst>
           </p:cNvPr>
@@ -13654,7 +13654,7 @@
           <p:cNvPr id="11" name="">
             <a:extLst xmlns:a="http://schemas.openxmlformats.org/drawingml/2006/main">
               <a:ext uri="{FF2B5EF4-FFF2-40B4-BE49-F238E27FC236}">
-                <a16:creationId xmlns:a16="http://schemas.microsoft.com/office/drawing/2014/main" id="{33F363E1-1B36-4515-AD01-C115711F8B8B}"/>
+                <a16:creationId xmlns:a16="http://schemas.microsoft.com/office/drawing/2014/main" id="{A7ACE9DA-5DB3-41D6-8698-79E74ABA0E5D}"/>
               </a:ext>
             </a:extLst>
           </p:cNvPr>
@@ -13699,7 +13699,7 @@
           <p:cNvPr id="12" name="">
             <a:extLst xmlns:a="http://schemas.openxmlformats.org/drawingml/2006/main">
               <a:ext uri="{FF2B5EF4-FFF2-40B4-BE49-F238E27FC236}">
-                <a16:creationId xmlns:a16="http://schemas.microsoft.com/office/drawing/2014/main" id="{17272ACE-5CC7-4BAE-A514-7BBAD6AF6466}"/>
+                <a16:creationId xmlns:a16="http://schemas.microsoft.com/office/drawing/2014/main" id="{7501F40D-1A3D-402A-BFE7-48927960826F}"/>
               </a:ext>
             </a:extLst>
           </p:cNvPr>
@@ -13744,7 +13744,7 @@
           <p:cNvPr id="13" name="">
             <a:extLst xmlns:a="http://schemas.openxmlformats.org/drawingml/2006/main">
               <a:ext uri="{FF2B5EF4-FFF2-40B4-BE49-F238E27FC236}">
-                <a16:creationId xmlns:a16="http://schemas.microsoft.com/office/drawing/2014/main" id="{5EEC47FA-E9F7-4D90-AD39-04786E642696}"/>
+                <a16:creationId xmlns:a16="http://schemas.microsoft.com/office/drawing/2014/main" id="{E7E4B262-1449-460E-BFB6-CA87B1B18AED}"/>
               </a:ext>
             </a:extLst>
           </p:cNvPr>
@@ -13777,7 +13777,7 @@
           <p:cNvPr id="14" name="">
             <a:extLst xmlns:a="http://schemas.openxmlformats.org/drawingml/2006/main">
               <a:ext uri="{FF2B5EF4-FFF2-40B4-BE49-F238E27FC236}">
-                <a16:creationId xmlns:a16="http://schemas.microsoft.com/office/drawing/2014/main" id="{1D02F320-A1D7-422E-92D7-99CAAD5765AA}"/>
+                <a16:creationId xmlns:a16="http://schemas.microsoft.com/office/drawing/2014/main" id="{95CDBCCE-C3A6-4E85-9932-6AF5CD70BD83}"/>
               </a:ext>
             </a:extLst>
           </p:cNvPr>
@@ -13822,7 +13822,7 @@
           <p:cNvPr id="15" name="">
             <a:extLst xmlns:a="http://schemas.openxmlformats.org/drawingml/2006/main">
               <a:ext uri="{FF2B5EF4-FFF2-40B4-BE49-F238E27FC236}">
-                <a16:creationId xmlns:a16="http://schemas.microsoft.com/office/drawing/2014/main" id="{7BB4E963-FA6B-4E37-A4FB-4AA2B8CE3557}"/>
+                <a16:creationId xmlns:a16="http://schemas.microsoft.com/office/drawing/2014/main" id="{C1F36088-905E-4547-888C-54F01137A3D2}"/>
               </a:ext>
             </a:extLst>
           </p:cNvPr>
@@ -13867,7 +13867,7 @@
           <p:cNvPr id="16" name="">
             <a:extLst xmlns:a="http://schemas.openxmlformats.org/drawingml/2006/main">
               <a:ext uri="{FF2B5EF4-FFF2-40B4-BE49-F238E27FC236}">
-                <a16:creationId xmlns:a16="http://schemas.microsoft.com/office/drawing/2014/main" id="{F099B0AD-399E-41FB-A17E-AD9A3BEDBDBF}"/>
+                <a16:creationId xmlns:a16="http://schemas.microsoft.com/office/drawing/2014/main" id="{88FD6363-BAD5-4FB7-B446-E6D6453BBD7A}"/>
               </a:ext>
             </a:extLst>
           </p:cNvPr>
@@ -13912,7 +13912,7 @@
           <p:cNvPr id="17" name="">
             <a:extLst xmlns:a="http://schemas.openxmlformats.org/drawingml/2006/main">
               <a:ext uri="{FF2B5EF4-FFF2-40B4-BE49-F238E27FC236}">
-                <a16:creationId xmlns:a16="http://schemas.microsoft.com/office/drawing/2014/main" id="{D56DCDC4-CF1E-432E-B054-CE5924A14770}"/>
+                <a16:creationId xmlns:a16="http://schemas.microsoft.com/office/drawing/2014/main" id="{8F816D8F-1682-4161-BDBD-3A5A0AC3CC97}"/>
               </a:ext>
             </a:extLst>
           </p:cNvPr>
@@ -13945,7 +13945,7 @@
           <p:cNvPr id="18" name="">
             <a:extLst xmlns:a="http://schemas.openxmlformats.org/drawingml/2006/main">
               <a:ext uri="{FF2B5EF4-FFF2-40B4-BE49-F238E27FC236}">
-                <a16:creationId xmlns:a16="http://schemas.microsoft.com/office/drawing/2014/main" id="{5ABB4993-8C89-4263-B0F8-D68D1DCB5B93}"/>
+                <a16:creationId xmlns:a16="http://schemas.microsoft.com/office/drawing/2014/main" id="{DE809FCE-3D60-47B0-8A28-445FCA59E8D7}"/>
               </a:ext>
             </a:extLst>
           </p:cNvPr>
@@ -13976,7 +13976,7 @@
           <p:cNvPr id="19" name="">
             <a:extLst xmlns:a="http://schemas.openxmlformats.org/drawingml/2006/main">
               <a:ext uri="{FF2B5EF4-FFF2-40B4-BE49-F238E27FC236}">
-                <a16:creationId xmlns:a16="http://schemas.microsoft.com/office/drawing/2014/main" id="{BB3AFAD3-5A13-4A52-B578-2996610FB666}"/>
+                <a16:creationId xmlns:a16="http://schemas.microsoft.com/office/drawing/2014/main" id="{A6392AC0-12F5-460C-80DE-D66B5D5ABBC0}"/>
               </a:ext>
             </a:extLst>
           </p:cNvPr>
@@ -14021,7 +14021,7 @@
           <p:cNvPr id="20" name="">
             <a:extLst xmlns:a="http://schemas.openxmlformats.org/drawingml/2006/main">
               <a:ext uri="{FF2B5EF4-FFF2-40B4-BE49-F238E27FC236}">
-                <a16:creationId xmlns:a16="http://schemas.microsoft.com/office/drawing/2014/main" id="{23172451-CBA2-4F8F-AED4-90D623E65106}"/>
+                <a16:creationId xmlns:a16="http://schemas.microsoft.com/office/drawing/2014/main" id="{051DECFB-A993-4912-8DAF-A3BD83D57336}"/>
               </a:ext>
             </a:extLst>
           </p:cNvPr>
@@ -14066,7 +14066,7 @@
           <p:cNvPr id="21" name="">
             <a:extLst xmlns:a="http://schemas.openxmlformats.org/drawingml/2006/main">
               <a:ext uri="{FF2B5EF4-FFF2-40B4-BE49-F238E27FC236}">
-                <a16:creationId xmlns:a16="http://schemas.microsoft.com/office/drawing/2014/main" id="{9C97222C-5226-4FC5-B028-0C6373378FBC}"/>
+                <a16:creationId xmlns:a16="http://schemas.microsoft.com/office/drawing/2014/main" id="{7C554DC4-1EB1-4A8F-9273-371601A7A449}"/>
               </a:ext>
             </a:extLst>
           </p:cNvPr>
@@ -14111,7 +14111,7 @@
           <p:cNvPr id="22" name="">
             <a:extLst xmlns:a="http://schemas.openxmlformats.org/drawingml/2006/main">
               <a:ext uri="{FF2B5EF4-FFF2-40B4-BE49-F238E27FC236}">
-                <a16:creationId xmlns:a16="http://schemas.microsoft.com/office/drawing/2014/main" id="{DFA33B44-E924-405A-9047-BC9AEDDA9A07}"/>
+                <a16:creationId xmlns:a16="http://schemas.microsoft.com/office/drawing/2014/main" id="{2B94E088-5FAA-460C-9115-589AC8C43EEF}"/>
               </a:ext>
             </a:extLst>
           </p:cNvPr>
@@ -14144,7 +14144,7 @@
           <p:cNvPr id="23" name="">
             <a:extLst xmlns:a="http://schemas.openxmlformats.org/drawingml/2006/main">
               <a:ext uri="{FF2B5EF4-FFF2-40B4-BE49-F238E27FC236}">
-                <a16:creationId xmlns:a16="http://schemas.microsoft.com/office/drawing/2014/main" id="{509D1F9A-A4C1-4F62-AAF5-ED159AAF814B}"/>
+                <a16:creationId xmlns:a16="http://schemas.microsoft.com/office/drawing/2014/main" id="{B684300A-D596-46B8-AC35-A2F77561DBE7}"/>
               </a:ext>
             </a:extLst>
           </p:cNvPr>
@@ -14189,7 +14189,7 @@
           <p:cNvPr id="24" name="">
             <a:extLst xmlns:a="http://schemas.openxmlformats.org/drawingml/2006/main">
               <a:ext uri="{FF2B5EF4-FFF2-40B4-BE49-F238E27FC236}">
-                <a16:creationId xmlns:a16="http://schemas.microsoft.com/office/drawing/2014/main" id="{5A27749A-B6AB-4571-A6F9-6EA7AA553B8B}"/>
+                <a16:creationId xmlns:a16="http://schemas.microsoft.com/office/drawing/2014/main" id="{B87155B1-D642-4EFC-903E-72DB852E9242}"/>
               </a:ext>
             </a:extLst>
           </p:cNvPr>
@@ -14234,7 +14234,7 @@
           <p:cNvPr id="25" name="">
             <a:extLst xmlns:a="http://schemas.openxmlformats.org/drawingml/2006/main">
               <a:ext uri="{FF2B5EF4-FFF2-40B4-BE49-F238E27FC236}">
-                <a16:creationId xmlns:a16="http://schemas.microsoft.com/office/drawing/2014/main" id="{284EE6EC-7CEC-4265-800D-807A36DAEC03}"/>
+                <a16:creationId xmlns:a16="http://schemas.microsoft.com/office/drawing/2014/main" id="{53576767-0FED-449F-868F-66866A8CB455}"/>
               </a:ext>
             </a:extLst>
           </p:cNvPr>
@@ -14279,7 +14279,7 @@
           <p:cNvPr id="26" name="">
             <a:extLst xmlns:a="http://schemas.openxmlformats.org/drawingml/2006/main">
               <a:ext uri="{FF2B5EF4-FFF2-40B4-BE49-F238E27FC236}">
-                <a16:creationId xmlns:a16="http://schemas.microsoft.com/office/drawing/2014/main" id="{B591F653-A767-4547-89CD-8A2857CBC36D}"/>
+                <a16:creationId xmlns:a16="http://schemas.microsoft.com/office/drawing/2014/main" id="{5842AC08-54AA-444C-AD2A-901DB8788F2B}"/>
               </a:ext>
             </a:extLst>
           </p:cNvPr>
@@ -14312,7 +14312,7 @@
           <p:cNvPr id="27" name="">
             <a:extLst xmlns:a="http://schemas.openxmlformats.org/drawingml/2006/main">
               <a:ext uri="{FF2B5EF4-FFF2-40B4-BE49-F238E27FC236}">
-                <a16:creationId xmlns:a16="http://schemas.microsoft.com/office/drawing/2014/main" id="{35BBE83B-6037-4424-998E-C4DC6909A952}"/>
+                <a16:creationId xmlns:a16="http://schemas.microsoft.com/office/drawing/2014/main" id="{A851B89F-44CA-4B51-AF6A-586A1FA9E29A}"/>
               </a:ext>
             </a:extLst>
           </p:cNvPr>
@@ -14357,7 +14357,7 @@
           <p:cNvPr id="28" name="">
             <a:extLst xmlns:a="http://schemas.openxmlformats.org/drawingml/2006/main">
               <a:ext uri="{FF2B5EF4-FFF2-40B4-BE49-F238E27FC236}">
-                <a16:creationId xmlns:a16="http://schemas.microsoft.com/office/drawing/2014/main" id="{1A5C8E7A-A156-492A-9643-A8D21E1C203D}"/>
+                <a16:creationId xmlns:a16="http://schemas.microsoft.com/office/drawing/2014/main" id="{D2AE3C77-8851-4D03-98F5-6287BCF6D352}"/>
               </a:ext>
             </a:extLst>
           </p:cNvPr>
@@ -14402,7 +14402,7 @@
           <p:cNvPr id="29" name="">
             <a:extLst xmlns:a="http://schemas.openxmlformats.org/drawingml/2006/main">
               <a:ext uri="{FF2B5EF4-FFF2-40B4-BE49-F238E27FC236}">
-                <a16:creationId xmlns:a16="http://schemas.microsoft.com/office/drawing/2014/main" id="{6F37FB76-1EAE-4D2A-B333-401CC67CBEA2}"/>
+                <a16:creationId xmlns:a16="http://schemas.microsoft.com/office/drawing/2014/main" id="{2070662A-D178-49F1-9364-51260E8CB186}"/>
               </a:ext>
             </a:extLst>
           </p:cNvPr>
@@ -14447,7 +14447,7 @@
           <p:cNvPr id="30" name="">
             <a:extLst xmlns:a="http://schemas.openxmlformats.org/drawingml/2006/main">
               <a:ext uri="{FF2B5EF4-FFF2-40B4-BE49-F238E27FC236}">
-                <a16:creationId xmlns:a16="http://schemas.microsoft.com/office/drawing/2014/main" id="{D029C70E-49A8-491B-AB23-5AD185784CED}"/>
+                <a16:creationId xmlns:a16="http://schemas.microsoft.com/office/drawing/2014/main" id="{7ABC3436-2A5F-4953-B08E-35099AFDBA9F}"/>
               </a:ext>
             </a:extLst>
           </p:cNvPr>
@@ -14480,7 +14480,7 @@
           <p:cNvPr id="31" name="">
             <a:extLst xmlns:a="http://schemas.openxmlformats.org/drawingml/2006/main">
               <a:ext uri="{FF2B5EF4-FFF2-40B4-BE49-F238E27FC236}">
-                <a16:creationId xmlns:a16="http://schemas.microsoft.com/office/drawing/2014/main" id="{6FCA4547-0934-4E9C-AD90-D73413FF3D1B}"/>
+                <a16:creationId xmlns:a16="http://schemas.microsoft.com/office/drawing/2014/main" id="{6A9D9AAC-4FC2-4E97-9E3C-7562448322BF}"/>
               </a:ext>
             </a:extLst>
           </p:cNvPr>
@@ -14525,7 +14525,7 @@
           <p:cNvPr id="32" name="">
             <a:extLst xmlns:a="http://schemas.openxmlformats.org/drawingml/2006/main">
               <a:ext uri="{FF2B5EF4-FFF2-40B4-BE49-F238E27FC236}">
-                <a16:creationId xmlns:a16="http://schemas.microsoft.com/office/drawing/2014/main" id="{93EDECB5-1544-4D6C-A8E2-D78C25730DCA}"/>
+                <a16:creationId xmlns:a16="http://schemas.microsoft.com/office/drawing/2014/main" id="{890CB780-68CE-43E5-B641-8809DD93ED0F}"/>
               </a:ext>
             </a:extLst>
           </p:cNvPr>
@@ -14570,7 +14570,7 @@
           <p:cNvPr id="33" name="">
             <a:extLst xmlns:a="http://schemas.openxmlformats.org/drawingml/2006/main">
               <a:ext uri="{FF2B5EF4-FFF2-40B4-BE49-F238E27FC236}">
-                <a16:creationId xmlns:a16="http://schemas.microsoft.com/office/drawing/2014/main" id="{01A1EFF7-89A1-4F55-A5C8-927F28B98434}"/>
+                <a16:creationId xmlns:a16="http://schemas.microsoft.com/office/drawing/2014/main" id="{7A1A6278-EC91-4094-B489-25D99DCFEFB4}"/>
               </a:ext>
             </a:extLst>
           </p:cNvPr>
@@ -14615,7 +14615,7 @@
           <p:cNvPr id="34" name="">
             <a:extLst xmlns:a="http://schemas.openxmlformats.org/drawingml/2006/main">
               <a:ext uri="{FF2B5EF4-FFF2-40B4-BE49-F238E27FC236}">
-                <a16:creationId xmlns:a16="http://schemas.microsoft.com/office/drawing/2014/main" id="{4424EFF0-6757-4A47-987B-1C94D0887DB6}"/>
+                <a16:creationId xmlns:a16="http://schemas.microsoft.com/office/drawing/2014/main" id="{DED22A9D-52C9-4ED2-805C-3748D3CF8AEF}"/>
               </a:ext>
             </a:extLst>
           </p:cNvPr>
@@ -14648,7 +14648,7 @@
           <p:cNvPr id="35" name="">
             <a:extLst xmlns:a="http://schemas.openxmlformats.org/drawingml/2006/main">
               <a:ext uri="{FF2B5EF4-FFF2-40B4-BE49-F238E27FC236}">
-                <a16:creationId xmlns:a16="http://schemas.microsoft.com/office/drawing/2014/main" id="{10B0B93D-10E5-41C4-A4E0-91115B4EBBA9}"/>
+                <a16:creationId xmlns:a16="http://schemas.microsoft.com/office/drawing/2014/main" id="{F8E00D71-D8B6-4AD1-B6EA-18D92A42BD58}"/>
               </a:ext>
             </a:extLst>
           </p:cNvPr>
@@ -14693,7 +14693,7 @@
           <p:cNvPr id="36" name="">
             <a:extLst xmlns:a="http://schemas.openxmlformats.org/drawingml/2006/main">
               <a:ext uri="{FF2B5EF4-FFF2-40B4-BE49-F238E27FC236}">
-                <a16:creationId xmlns:a16="http://schemas.microsoft.com/office/drawing/2014/main" id="{6704D7E8-E752-44A3-92CE-40A8641F367F}"/>
+                <a16:creationId xmlns:a16="http://schemas.microsoft.com/office/drawing/2014/main" id="{6620C07E-EEB6-4295-98FE-AEE2B9083D22}"/>
               </a:ext>
             </a:extLst>
           </p:cNvPr>
@@ -14738,7 +14738,7 @@
           <p:cNvPr id="37" name="">
             <a:extLst xmlns:a="http://schemas.openxmlformats.org/drawingml/2006/main">
               <a:ext uri="{FF2B5EF4-FFF2-40B4-BE49-F238E27FC236}">
-                <a16:creationId xmlns:a16="http://schemas.microsoft.com/office/drawing/2014/main" id="{8AC0891B-36CD-4826-83F5-338B47FDE5BE}"/>
+                <a16:creationId xmlns:a16="http://schemas.microsoft.com/office/drawing/2014/main" id="{2151D8A1-226A-4A47-80C4-0FF7BCC5E6FA}"/>
               </a:ext>
             </a:extLst>
           </p:cNvPr>
@@ -14783,7 +14783,7 @@
           <p:cNvPr id="38" name="">
             <a:extLst xmlns:a="http://schemas.openxmlformats.org/drawingml/2006/main">
               <a:ext uri="{FF2B5EF4-FFF2-40B4-BE49-F238E27FC236}">
-                <a16:creationId xmlns:a16="http://schemas.microsoft.com/office/drawing/2014/main" id="{0F6C80DC-0FE6-46D7-AAE4-AC13395939C7}"/>
+                <a16:creationId xmlns:a16="http://schemas.microsoft.com/office/drawing/2014/main" id="{5CD668CA-6067-4BF2-BC55-5E2A49C653F9}"/>
               </a:ext>
             </a:extLst>
           </p:cNvPr>
@@ -14816,7 +14816,7 @@
           <p:cNvPr id="39" name="">
             <a:extLst xmlns:a="http://schemas.openxmlformats.org/drawingml/2006/main">
               <a:ext uri="{FF2B5EF4-FFF2-40B4-BE49-F238E27FC236}">
-                <a16:creationId xmlns:a16="http://schemas.microsoft.com/office/drawing/2014/main" id="{6634F9E3-5D92-4FEF-B3CD-7D36E9EB647B}"/>
+                <a16:creationId xmlns:a16="http://schemas.microsoft.com/office/drawing/2014/main" id="{0BA32056-07FC-42B7-97E6-718C3D270B3D}"/>
               </a:ext>
             </a:extLst>
           </p:cNvPr>
@@ -14861,7 +14861,7 @@
           <p:cNvPr id="40" name="">
             <a:extLst xmlns:a="http://schemas.openxmlformats.org/drawingml/2006/main">
               <a:ext uri="{FF2B5EF4-FFF2-40B4-BE49-F238E27FC236}">
-                <a16:creationId xmlns:a16="http://schemas.microsoft.com/office/drawing/2014/main" id="{1486C906-BD9A-4810-B75D-4AE4AA4538FF}"/>
+                <a16:creationId xmlns:a16="http://schemas.microsoft.com/office/drawing/2014/main" id="{BCE25A52-2938-4374-BAE2-043274FC5C60}"/>
               </a:ext>
             </a:extLst>
           </p:cNvPr>
@@ -14906,7 +14906,7 @@
           <p:cNvPr id="41" name="">
             <a:extLst xmlns:a="http://schemas.openxmlformats.org/drawingml/2006/main">
               <a:ext uri="{FF2B5EF4-FFF2-40B4-BE49-F238E27FC236}">
-                <a16:creationId xmlns:a16="http://schemas.microsoft.com/office/drawing/2014/main" id="{94D9C2EC-3423-4ECD-95A7-7F3C47BAC07B}"/>
+                <a16:creationId xmlns:a16="http://schemas.microsoft.com/office/drawing/2014/main" id="{9016F1B6-0446-4273-98B6-512672B34020}"/>
               </a:ext>
             </a:extLst>
           </p:cNvPr>
@@ -14951,7 +14951,7 @@
           <p:cNvPr id="42" name="">
             <a:extLst xmlns:a="http://schemas.openxmlformats.org/drawingml/2006/main">
               <a:ext uri="{FF2B5EF4-FFF2-40B4-BE49-F238E27FC236}">
-                <a16:creationId xmlns:a16="http://schemas.microsoft.com/office/drawing/2014/main" id="{ED00D49F-4E68-407B-ABF7-7263F223367D}"/>
+                <a16:creationId xmlns:a16="http://schemas.microsoft.com/office/drawing/2014/main" id="{A7B10A53-0F5D-46F7-9C5B-48BDE9366CBB}"/>
               </a:ext>
             </a:extLst>
           </p:cNvPr>
@@ -14984,7 +14984,7 @@
           <p:cNvPr id="43" name="">
             <a:extLst xmlns:a="http://schemas.openxmlformats.org/drawingml/2006/main">
               <a:ext uri="{FF2B5EF4-FFF2-40B4-BE49-F238E27FC236}">
-                <a16:creationId xmlns:a16="http://schemas.microsoft.com/office/drawing/2014/main" id="{93BC48CD-8D58-4DCB-B430-EB4894A4BBF7}"/>
+                <a16:creationId xmlns:a16="http://schemas.microsoft.com/office/drawing/2014/main" id="{A6A73650-E4B1-4A72-A1A5-30B29D352616}"/>
               </a:ext>
             </a:extLst>
           </p:cNvPr>
@@ -15029,7 +15029,7 @@
           <p:cNvPr id="44" name="">
             <a:extLst xmlns:a="http://schemas.openxmlformats.org/drawingml/2006/main">
               <a:ext uri="{FF2B5EF4-FFF2-40B4-BE49-F238E27FC236}">
-                <a16:creationId xmlns:a16="http://schemas.microsoft.com/office/drawing/2014/main" id="{5325ED9E-06B1-4B57-8200-5F9A32424157}"/>
+                <a16:creationId xmlns:a16="http://schemas.microsoft.com/office/drawing/2014/main" id="{E91BD514-9AF0-44D5-B4C0-97445DF10BF4}"/>
               </a:ext>
             </a:extLst>
           </p:cNvPr>
@@ -15074,7 +15074,7 @@
           <p:cNvPr id="45" name="">
             <a:extLst xmlns:a="http://schemas.openxmlformats.org/drawingml/2006/main">
               <a:ext uri="{FF2B5EF4-FFF2-40B4-BE49-F238E27FC236}">
-                <a16:creationId xmlns:a16="http://schemas.microsoft.com/office/drawing/2014/main" id="{E1B67E05-01F3-4080-A0D7-1A73BB4ADCB9}"/>
+                <a16:creationId xmlns:a16="http://schemas.microsoft.com/office/drawing/2014/main" id="{F96CCD5B-8540-49F0-91B5-80156AAB74F6}"/>
               </a:ext>
             </a:extLst>
           </p:cNvPr>
@@ -15119,7 +15119,7 @@
           <p:cNvPr id="46" name="">
             <a:extLst xmlns:a="http://schemas.openxmlformats.org/drawingml/2006/main">
               <a:ext uri="{FF2B5EF4-FFF2-40B4-BE49-F238E27FC236}">
-                <a16:creationId xmlns:a16="http://schemas.microsoft.com/office/drawing/2014/main" id="{03CEFFAF-2591-4AE1-BABA-B33EE2183ABF}"/>
+                <a16:creationId xmlns:a16="http://schemas.microsoft.com/office/drawing/2014/main" id="{2063C384-FA85-48D0-A57F-3555AF9A52C5}"/>
               </a:ext>
             </a:extLst>
           </p:cNvPr>
@@ -15162,7 +15162,7 @@
     </p:spTree>
     <p:extLst>
       <p:ext uri="{BB962C8B-B14F-4D97-AF65-F5344CB8AC3E}">
-        <p14:creationId xmlns:p14="http://schemas.microsoft.com/office/powerpoint/2010/main" val="1411532848"/>
+        <p14:creationId xmlns:p14="http://schemas.microsoft.com/office/powerpoint/2010/main" val="1258402070"/>
       </p:ext>
     </p:extLst>
   </p:cSld>
@@ -15186,7 +15186,7 @@
           <p:cNvPr id="27" name="">
             <a:extLst xmlns:a="http://schemas.openxmlformats.org/drawingml/2006/main">
               <a:ext uri="{FF2B5EF4-FFF2-40B4-BE49-F238E27FC236}">
-                <a16:creationId xmlns:a16="http://schemas.microsoft.com/office/drawing/2014/main" id="{5DB8FAD2-76EF-4412-8F8E-59C711755177}"/>
+                <a16:creationId xmlns:a16="http://schemas.microsoft.com/office/drawing/2014/main" id="{AF47B074-2A97-4AAC-A71D-64F50416A080}"/>
               </a:ext>
             </a:extLst>
           </p:cNvPr>
@@ -15217,7 +15217,7 @@
           <p:cNvPr id="2" name="">
             <a:extLst xmlns:a="http://schemas.openxmlformats.org/drawingml/2006/main">
               <a:ext uri="{FF2B5EF4-FFF2-40B4-BE49-F238E27FC236}">
-                <a16:creationId xmlns:a16="http://schemas.microsoft.com/office/drawing/2014/main" id="{456EC6A5-1E8C-49EC-A9AF-EB1ED19412C9}"/>
+                <a16:creationId xmlns:a16="http://schemas.microsoft.com/office/drawing/2014/main" id="{873D8F77-8AE8-49E8-B8BD-88DDC586E154}"/>
               </a:ext>
             </a:extLst>
           </p:cNvPr>
@@ -15262,7 +15262,7 @@
           <p:cNvPr id="3" name="">
             <a:extLst xmlns:a="http://schemas.openxmlformats.org/drawingml/2006/main">
               <a:ext uri="{FF2B5EF4-FFF2-40B4-BE49-F238E27FC236}">
-                <a16:creationId xmlns:a16="http://schemas.microsoft.com/office/drawing/2014/main" id="{9E589194-6C8A-40EC-BBD8-04CEF75D1B64}"/>
+                <a16:creationId xmlns:a16="http://schemas.microsoft.com/office/drawing/2014/main" id="{8B5F2A44-4AC2-428F-B857-109A9C396A6B}"/>
               </a:ext>
             </a:extLst>
           </p:cNvPr>
@@ -15307,7 +15307,7 @@
           <p:cNvPr id="4" name="">
             <a:extLst xmlns:a="http://schemas.openxmlformats.org/drawingml/2006/main">
               <a:ext uri="{FF2B5EF4-FFF2-40B4-BE49-F238E27FC236}">
-                <a16:creationId xmlns:a16="http://schemas.microsoft.com/office/drawing/2014/main" id="{3E259B44-8250-4165-A0AB-1B9CF2996D52}"/>
+                <a16:creationId xmlns:a16="http://schemas.microsoft.com/office/drawing/2014/main" id="{76AC6B0F-3A1D-4938-BB4C-FDA3B28164F9}"/>
               </a:ext>
             </a:extLst>
           </p:cNvPr>
@@ -15352,7 +15352,7 @@
           <p:cNvPr id="5" name="">
             <a:extLst xmlns:a="http://schemas.openxmlformats.org/drawingml/2006/main">
               <a:ext uri="{FF2B5EF4-FFF2-40B4-BE49-F238E27FC236}">
-                <a16:creationId xmlns:a16="http://schemas.microsoft.com/office/drawing/2014/main" id="{FF528518-5790-4ECA-BC33-B115102B6070}"/>
+                <a16:creationId xmlns:a16="http://schemas.microsoft.com/office/drawing/2014/main" id="{924760A0-59E5-4DD9-8062-FC8F0F00506F}"/>
               </a:ext>
             </a:extLst>
           </p:cNvPr>
@@ -15383,7 +15383,7 @@
           <p:cNvPr id="6" name="">
             <a:extLst xmlns:a="http://schemas.openxmlformats.org/drawingml/2006/main">
               <a:ext uri="{FF2B5EF4-FFF2-40B4-BE49-F238E27FC236}">
-                <a16:creationId xmlns:a16="http://schemas.microsoft.com/office/drawing/2014/main" id="{6E6D83E2-D4DB-48BB-9C10-CEFE84DDAF65}"/>
+                <a16:creationId xmlns:a16="http://schemas.microsoft.com/office/drawing/2014/main" id="{356E2975-8F8D-48D0-84C7-F31074151D88}"/>
               </a:ext>
             </a:extLst>
           </p:cNvPr>
@@ -15414,7 +15414,7 @@
           <p:cNvPr id="7" name="">
             <a:extLst xmlns:a="http://schemas.openxmlformats.org/drawingml/2006/main">
               <a:ext uri="{FF2B5EF4-FFF2-40B4-BE49-F238E27FC236}">
-                <a16:creationId xmlns:a16="http://schemas.microsoft.com/office/drawing/2014/main" id="{0D262153-4E6E-4BA3-AE67-D8AF61574028}"/>
+                <a16:creationId xmlns:a16="http://schemas.microsoft.com/office/drawing/2014/main" id="{C03E5AB6-ED89-4520-9C26-58990F0A7F05}"/>
               </a:ext>
             </a:extLst>
           </p:cNvPr>
@@ -15459,7 +15459,7 @@
           <p:cNvPr id="8" name="">
             <a:extLst xmlns:a="http://schemas.openxmlformats.org/drawingml/2006/main">
               <a:ext uri="{FF2B5EF4-FFF2-40B4-BE49-F238E27FC236}">
-                <a16:creationId xmlns:a16="http://schemas.microsoft.com/office/drawing/2014/main" id="{5E714891-E21F-4058-BC17-E53C20D57A0F}"/>
+                <a16:creationId xmlns:a16="http://schemas.microsoft.com/office/drawing/2014/main" id="{0A890346-A8F6-41D3-A3E3-44FE35DFEEFE}"/>
               </a:ext>
             </a:extLst>
           </p:cNvPr>
@@ -15504,7 +15504,7 @@
           <p:cNvPr id="9" name="">
             <a:extLst xmlns:a="http://schemas.openxmlformats.org/drawingml/2006/main">
               <a:ext uri="{FF2B5EF4-FFF2-40B4-BE49-F238E27FC236}">
-                <a16:creationId xmlns:a16="http://schemas.microsoft.com/office/drawing/2014/main" id="{0805ECF3-66AB-4B2C-B7C3-90C77AD31355}"/>
+                <a16:creationId xmlns:a16="http://schemas.microsoft.com/office/drawing/2014/main" id="{166E2486-F98D-41AE-AF0E-4D14829DE84F}"/>
               </a:ext>
             </a:extLst>
           </p:cNvPr>
@@ -15539,7 +15539,7 @@
           <p:cNvPr id="10" name="">
             <a:extLst xmlns:a="http://schemas.openxmlformats.org/drawingml/2006/main">
               <a:ext uri="{FF2B5EF4-FFF2-40B4-BE49-F238E27FC236}">
-                <a16:creationId xmlns:a16="http://schemas.microsoft.com/office/drawing/2014/main" id="{0EE5ED9D-A697-4CF8-8D0A-E88AF406D2F2}"/>
+                <a16:creationId xmlns:a16="http://schemas.microsoft.com/office/drawing/2014/main" id="{3C7EFB59-005C-459B-884F-FD596F868B87}"/>
               </a:ext>
             </a:extLst>
           </p:cNvPr>
@@ -15584,7 +15584,7 @@
           <p:cNvPr id="11" name="">
             <a:extLst xmlns:a="http://schemas.openxmlformats.org/drawingml/2006/main">
               <a:ext uri="{FF2B5EF4-FFF2-40B4-BE49-F238E27FC236}">
-                <a16:creationId xmlns:a16="http://schemas.microsoft.com/office/drawing/2014/main" id="{72944102-9D15-4F78-9C8C-2FCF55293AC5}"/>
+                <a16:creationId xmlns:a16="http://schemas.microsoft.com/office/drawing/2014/main" id="{AFA078DB-B7A8-47A5-9CC1-8458B2B4206D}"/>
               </a:ext>
             </a:extLst>
           </p:cNvPr>
@@ -15629,7 +15629,7 @@
           <p:cNvPr id="12" name="">
             <a:extLst xmlns:a="http://schemas.openxmlformats.org/drawingml/2006/main">
               <a:ext uri="{FF2B5EF4-FFF2-40B4-BE49-F238E27FC236}">
-                <a16:creationId xmlns:a16="http://schemas.microsoft.com/office/drawing/2014/main" id="{193C590E-DBAF-432D-9464-5B2678DF63F9}"/>
+                <a16:creationId xmlns:a16="http://schemas.microsoft.com/office/drawing/2014/main" id="{6B963C71-D489-48DF-AB8D-5D01909300BB}"/>
               </a:ext>
             </a:extLst>
           </p:cNvPr>
@@ -15674,7 +15674,7 @@
           <p:cNvPr id="13" name="">
             <a:extLst xmlns:a="http://schemas.openxmlformats.org/drawingml/2006/main">
               <a:ext uri="{FF2B5EF4-FFF2-40B4-BE49-F238E27FC236}">
-                <a16:creationId xmlns:a16="http://schemas.microsoft.com/office/drawing/2014/main" id="{7417F6AE-BFF4-4BA4-B95A-FBE6C19E7FDD}"/>
+                <a16:creationId xmlns:a16="http://schemas.microsoft.com/office/drawing/2014/main" id="{32519392-D8F4-47E4-9838-4A3F3FD9717B}"/>
               </a:ext>
             </a:extLst>
           </p:cNvPr>
@@ -15709,7 +15709,7 @@
           <p:cNvPr id="14" name="">
             <a:extLst xmlns:a="http://schemas.openxmlformats.org/drawingml/2006/main">
               <a:ext uri="{FF2B5EF4-FFF2-40B4-BE49-F238E27FC236}">
-                <a16:creationId xmlns:a16="http://schemas.microsoft.com/office/drawing/2014/main" id="{61585539-0496-49C9-A117-E60DB2B5BE5F}"/>
+                <a16:creationId xmlns:a16="http://schemas.microsoft.com/office/drawing/2014/main" id="{52465FD4-FF99-46F7-8696-427BF65AAC54}"/>
               </a:ext>
             </a:extLst>
           </p:cNvPr>
@@ -15740,7 +15740,7 @@
           <p:cNvPr id="15" name="">
             <a:extLst xmlns:a="http://schemas.openxmlformats.org/drawingml/2006/main">
               <a:ext uri="{FF2B5EF4-FFF2-40B4-BE49-F238E27FC236}">
-                <a16:creationId xmlns:a16="http://schemas.microsoft.com/office/drawing/2014/main" id="{9BB42E6B-B6F0-46DB-9D21-405CC3681A93}"/>
+                <a16:creationId xmlns:a16="http://schemas.microsoft.com/office/drawing/2014/main" id="{3098E0EA-0029-49A5-A6CD-2724C9CBF33A}"/>
               </a:ext>
             </a:extLst>
           </p:cNvPr>
@@ -15785,7 +15785,7 @@
           <p:cNvPr id="16" name="">
             <a:extLst xmlns:a="http://schemas.openxmlformats.org/drawingml/2006/main">
               <a:ext uri="{FF2B5EF4-FFF2-40B4-BE49-F238E27FC236}">
-                <a16:creationId xmlns:a16="http://schemas.microsoft.com/office/drawing/2014/main" id="{DE46DAC9-B304-4E34-B6A4-25255E151AD5}"/>
+                <a16:creationId xmlns:a16="http://schemas.microsoft.com/office/drawing/2014/main" id="{BA731695-F1B6-4482-8D42-8AF600C580C9}"/>
               </a:ext>
             </a:extLst>
           </p:cNvPr>
@@ -15830,7 +15830,7 @@
           <p:cNvPr id="17" name="">
             <a:extLst xmlns:a="http://schemas.openxmlformats.org/drawingml/2006/main">
               <a:ext uri="{FF2B5EF4-FFF2-40B4-BE49-F238E27FC236}">
-                <a16:creationId xmlns:a16="http://schemas.microsoft.com/office/drawing/2014/main" id="{9C26C8BD-9D3D-405D-8FA5-E6016A317E66}"/>
+                <a16:creationId xmlns:a16="http://schemas.microsoft.com/office/drawing/2014/main" id="{B119B04F-97A3-400C-B380-B7114C97F703}"/>
               </a:ext>
             </a:extLst>
           </p:cNvPr>
@@ -15865,7 +15865,7 @@
           <p:cNvPr id="18" name="">
             <a:extLst xmlns:a="http://schemas.openxmlformats.org/drawingml/2006/main">
               <a:ext uri="{FF2B5EF4-FFF2-40B4-BE49-F238E27FC236}">
-                <a16:creationId xmlns:a16="http://schemas.microsoft.com/office/drawing/2014/main" id="{15D0B26D-F436-4E7D-A3F2-7A293B3F376B}"/>
+                <a16:creationId xmlns:a16="http://schemas.microsoft.com/office/drawing/2014/main" id="{6ED0C709-E0A8-40C2-868B-883F49B66840}"/>
               </a:ext>
             </a:extLst>
           </p:cNvPr>
@@ -15896,7 +15896,7 @@
           <p:cNvPr id="19" name="">
             <a:extLst xmlns:a="http://schemas.openxmlformats.org/drawingml/2006/main">
               <a:ext uri="{FF2B5EF4-FFF2-40B4-BE49-F238E27FC236}">
-                <a16:creationId xmlns:a16="http://schemas.microsoft.com/office/drawing/2014/main" id="{F6146A62-5040-45BB-8B28-A671C72C2ED9}"/>
+                <a16:creationId xmlns:a16="http://schemas.microsoft.com/office/drawing/2014/main" id="{8441712B-67C0-4A48-9AEC-7A72073270B8}"/>
               </a:ext>
             </a:extLst>
           </p:cNvPr>
@@ -15941,7 +15941,7 @@
           <p:cNvPr id="20" name="">
             <a:extLst xmlns:a="http://schemas.openxmlformats.org/drawingml/2006/main">
               <a:ext uri="{FF2B5EF4-FFF2-40B4-BE49-F238E27FC236}">
-                <a16:creationId xmlns:a16="http://schemas.microsoft.com/office/drawing/2014/main" id="{0C14F79D-7BB5-452D-8355-F30904F24AD0}"/>
+                <a16:creationId xmlns:a16="http://schemas.microsoft.com/office/drawing/2014/main" id="{2D9095F8-6989-4973-8501-C515F4ACD82A}"/>
               </a:ext>
             </a:extLst>
           </p:cNvPr>
@@ -15986,7 +15986,7 @@
           <p:cNvPr id="21" name="">
             <a:extLst xmlns:a="http://schemas.openxmlformats.org/drawingml/2006/main">
               <a:ext uri="{FF2B5EF4-FFF2-40B4-BE49-F238E27FC236}">
-                <a16:creationId xmlns:a16="http://schemas.microsoft.com/office/drawing/2014/main" id="{2D6698C2-F019-4438-B851-DE32168EBABF}"/>
+                <a16:creationId xmlns:a16="http://schemas.microsoft.com/office/drawing/2014/main" id="{7C9640C1-5593-482B-8C73-3609E68DB6C0}"/>
               </a:ext>
             </a:extLst>
           </p:cNvPr>
@@ -16021,7 +16021,7 @@
           <p:cNvPr id="22" name="">
             <a:extLst xmlns:a="http://schemas.openxmlformats.org/drawingml/2006/main">
               <a:ext uri="{FF2B5EF4-FFF2-40B4-BE49-F238E27FC236}">
-                <a16:creationId xmlns:a16="http://schemas.microsoft.com/office/drawing/2014/main" id="{8036AFE0-4042-4295-BB7B-A66A238A1967}"/>
+                <a16:creationId xmlns:a16="http://schemas.microsoft.com/office/drawing/2014/main" id="{EDC9E036-086F-46BC-964E-EDA79ED5698C}"/>
               </a:ext>
             </a:extLst>
           </p:cNvPr>
@@ -16052,7 +16052,7 @@
           <p:cNvPr id="23" name="">
             <a:extLst xmlns:a="http://schemas.openxmlformats.org/drawingml/2006/main">
               <a:ext uri="{FF2B5EF4-FFF2-40B4-BE49-F238E27FC236}">
-                <a16:creationId xmlns:a16="http://schemas.microsoft.com/office/drawing/2014/main" id="{A7DC9DF7-1DE3-483C-9890-A99F4CAC3E53}"/>
+                <a16:creationId xmlns:a16="http://schemas.microsoft.com/office/drawing/2014/main" id="{900716B7-1425-4292-BC2E-D7D5576AEA60}"/>
               </a:ext>
             </a:extLst>
           </p:cNvPr>
@@ -16097,7 +16097,7 @@
           <p:cNvPr id="24" name="">
             <a:extLst xmlns:a="http://schemas.openxmlformats.org/drawingml/2006/main">
               <a:ext uri="{FF2B5EF4-FFF2-40B4-BE49-F238E27FC236}">
-                <a16:creationId xmlns:a16="http://schemas.microsoft.com/office/drawing/2014/main" id="{ADFA8BBA-6242-49F8-87EF-4A072AC68CE8}"/>
+                <a16:creationId xmlns:a16="http://schemas.microsoft.com/office/drawing/2014/main" id="{617E2CAA-C4F0-4F34-B390-8D1D5A7C4188}"/>
               </a:ext>
             </a:extLst>
           </p:cNvPr>
@@ -16142,7 +16142,7 @@
           <p:cNvPr id="25" name="">
             <a:extLst xmlns:a="http://schemas.openxmlformats.org/drawingml/2006/main">
               <a:ext uri="{FF2B5EF4-FFF2-40B4-BE49-F238E27FC236}">
-                <a16:creationId xmlns:a16="http://schemas.microsoft.com/office/drawing/2014/main" id="{EBFF1CC0-AFC8-48A4-BE8F-2FE5EA9439B4}"/>
+                <a16:creationId xmlns:a16="http://schemas.microsoft.com/office/drawing/2014/main" id="{F8168A1E-5550-4931-BE1F-5A0834E79F16}"/>
               </a:ext>
             </a:extLst>
           </p:cNvPr>
@@ -16187,7 +16187,7 @@
           <p:cNvPr id="26" name="">
             <a:extLst xmlns:a="http://schemas.openxmlformats.org/drawingml/2006/main">
               <a:ext uri="{FF2B5EF4-FFF2-40B4-BE49-F238E27FC236}">
-                <a16:creationId xmlns:a16="http://schemas.microsoft.com/office/drawing/2014/main" id="{D42EB3B9-C9B9-4BB7-9A8D-6FC6A67C5507}"/>
+                <a16:creationId xmlns:a16="http://schemas.microsoft.com/office/drawing/2014/main" id="{48D36643-0D4F-4030-9497-460684D0D3EA}"/>
               </a:ext>
             </a:extLst>
           </p:cNvPr>
@@ -16230,7 +16230,7 @@
     </p:spTree>
     <p:extLst>
       <p:ext uri="{BB962C8B-B14F-4D97-AF65-F5344CB8AC3E}">
-        <p14:creationId xmlns:p14="http://schemas.microsoft.com/office/powerpoint/2010/main" val="737642828"/>
+        <p14:creationId xmlns:p14="http://schemas.microsoft.com/office/powerpoint/2010/main" val="1609350188"/>
       </p:ext>
     </p:extLst>
   </p:cSld>
@@ -16254,7 +16254,7 @@
           <p:cNvPr id="24" name="">
             <a:extLst xmlns:a="http://schemas.openxmlformats.org/drawingml/2006/main">
               <a:ext uri="{FF2B5EF4-FFF2-40B4-BE49-F238E27FC236}">
-                <a16:creationId xmlns:a16="http://schemas.microsoft.com/office/drawing/2014/main" id="{2F5C9FEA-E3FF-4ADF-A16A-2536C16FA935}"/>
+                <a16:creationId xmlns:a16="http://schemas.microsoft.com/office/drawing/2014/main" id="{C11087FC-9E2F-4FE9-A67A-D104ED223335}"/>
               </a:ext>
             </a:extLst>
           </p:cNvPr>
@@ -16285,7 +16285,7 @@
           <p:cNvPr id="2" name="">
             <a:extLst xmlns:a="http://schemas.openxmlformats.org/drawingml/2006/main">
               <a:ext uri="{FF2B5EF4-FFF2-40B4-BE49-F238E27FC236}">
-                <a16:creationId xmlns:a16="http://schemas.microsoft.com/office/drawing/2014/main" id="{47B17ECC-2C98-47E1-BA68-324BF0271EB5}"/>
+                <a16:creationId xmlns:a16="http://schemas.microsoft.com/office/drawing/2014/main" id="{66E34DEC-1480-4D13-960A-7479C209EFCE}"/>
               </a:ext>
             </a:extLst>
           </p:cNvPr>
@@ -16316,7 +16316,7 @@
           <p:cNvPr id="3" name="">
             <a:extLst xmlns:a="http://schemas.openxmlformats.org/drawingml/2006/main">
               <a:ext uri="{FF2B5EF4-FFF2-40B4-BE49-F238E27FC236}">
-                <a16:creationId xmlns:a16="http://schemas.microsoft.com/office/drawing/2014/main" id="{DEC84BE2-B04C-4126-AE3B-C91FFDF99D6D}"/>
+                <a16:creationId xmlns:a16="http://schemas.microsoft.com/office/drawing/2014/main" id="{2D44372A-1832-4829-865F-6B2C6F3A7319}"/>
               </a:ext>
             </a:extLst>
           </p:cNvPr>
@@ -16361,7 +16361,7 @@
           <p:cNvPr id="4" name="">
             <a:extLst xmlns:a="http://schemas.openxmlformats.org/drawingml/2006/main">
               <a:ext uri="{FF2B5EF4-FFF2-40B4-BE49-F238E27FC236}">
-                <a16:creationId xmlns:a16="http://schemas.microsoft.com/office/drawing/2014/main" id="{719D3EEB-E0A0-4687-A737-13FAEA7539DC}"/>
+                <a16:creationId xmlns:a16="http://schemas.microsoft.com/office/drawing/2014/main" id="{965BF1AA-8DD2-4673-A887-CD257CF5A347}"/>
               </a:ext>
             </a:extLst>
           </p:cNvPr>
@@ -16406,7 +16406,7 @@
           <p:cNvPr id="5" name="">
             <a:extLst xmlns:a="http://schemas.openxmlformats.org/drawingml/2006/main">
               <a:ext uri="{FF2B5EF4-FFF2-40B4-BE49-F238E27FC236}">
-                <a16:creationId xmlns:a16="http://schemas.microsoft.com/office/drawing/2014/main" id="{3FA7A21C-BE23-4117-99C1-82A6060DA0C4}"/>
+                <a16:creationId xmlns:a16="http://schemas.microsoft.com/office/drawing/2014/main" id="{4F6788B9-54DB-4069-9FAD-162DA329F188}"/>
               </a:ext>
             </a:extLst>
           </p:cNvPr>
@@ -16437,7 +16437,7 @@
           <p:cNvPr id="6" name="">
             <a:extLst xmlns:a="http://schemas.openxmlformats.org/drawingml/2006/main">
               <a:ext uri="{FF2B5EF4-FFF2-40B4-BE49-F238E27FC236}">
-                <a16:creationId xmlns:a16="http://schemas.microsoft.com/office/drawing/2014/main" id="{A6612F14-8DD1-4FD1-A3E3-52DF251E3E94}"/>
+                <a16:creationId xmlns:a16="http://schemas.microsoft.com/office/drawing/2014/main" id="{A4995601-4622-4A32-8C6E-BCF9612053A7}"/>
               </a:ext>
             </a:extLst>
           </p:cNvPr>
@@ -16482,7 +16482,7 @@
           <p:cNvPr id="7" name="">
             <a:extLst xmlns:a="http://schemas.openxmlformats.org/drawingml/2006/main">
               <a:ext uri="{FF2B5EF4-FFF2-40B4-BE49-F238E27FC236}">
-                <a16:creationId xmlns:a16="http://schemas.microsoft.com/office/drawing/2014/main" id="{DCD60F41-23D2-46CD-AD85-074749B609D6}"/>
+                <a16:creationId xmlns:a16="http://schemas.microsoft.com/office/drawing/2014/main" id="{6F6AD328-2D59-4EC0-8E63-D43C590C3606}"/>
               </a:ext>
             </a:extLst>
           </p:cNvPr>
@@ -16527,7 +16527,7 @@
           <p:cNvPr id="8" name="">
             <a:extLst xmlns:a="http://schemas.openxmlformats.org/drawingml/2006/main">
               <a:ext uri="{FF2B5EF4-FFF2-40B4-BE49-F238E27FC236}">
-                <a16:creationId xmlns:a16="http://schemas.microsoft.com/office/drawing/2014/main" id="{F2D1ABD5-4022-48BF-A94F-158AE77301CF}"/>
+                <a16:creationId xmlns:a16="http://schemas.microsoft.com/office/drawing/2014/main" id="{AC1A0E1D-9E24-49FB-B941-92F9DAB183A4}"/>
               </a:ext>
             </a:extLst>
           </p:cNvPr>
@@ -16562,7 +16562,7 @@
           <p:cNvPr id="9" name="">
             <a:extLst xmlns:a="http://schemas.openxmlformats.org/drawingml/2006/main">
               <a:ext uri="{FF2B5EF4-FFF2-40B4-BE49-F238E27FC236}">
-                <a16:creationId xmlns:a16="http://schemas.microsoft.com/office/drawing/2014/main" id="{DCF5F005-6380-4279-BEC6-C57E84784B46}"/>
+                <a16:creationId xmlns:a16="http://schemas.microsoft.com/office/drawing/2014/main" id="{88BB2112-99F8-412E-96B9-85619FBAFB0A}"/>
               </a:ext>
             </a:extLst>
           </p:cNvPr>
@@ -16593,7 +16593,7 @@
           <p:cNvPr id="10" name="">
             <a:extLst xmlns:a="http://schemas.openxmlformats.org/drawingml/2006/main">
               <a:ext uri="{FF2B5EF4-FFF2-40B4-BE49-F238E27FC236}">
-                <a16:creationId xmlns:a16="http://schemas.microsoft.com/office/drawing/2014/main" id="{52F26263-E7AC-4E82-9B94-6B9E0DB1DE90}"/>
+                <a16:creationId xmlns:a16="http://schemas.microsoft.com/office/drawing/2014/main" id="{F8C24E56-A334-4DCD-832D-3A6B7FFDC8ED}"/>
               </a:ext>
             </a:extLst>
           </p:cNvPr>
@@ -16638,7 +16638,7 @@
           <p:cNvPr id="11" name="">
             <a:extLst xmlns:a="http://schemas.openxmlformats.org/drawingml/2006/main">
               <a:ext uri="{FF2B5EF4-FFF2-40B4-BE49-F238E27FC236}">
-                <a16:creationId xmlns:a16="http://schemas.microsoft.com/office/drawing/2014/main" id="{254E9EAB-1030-48FF-891E-01D13192EF7B}"/>
+                <a16:creationId xmlns:a16="http://schemas.microsoft.com/office/drawing/2014/main" id="{3BD7D7D8-9787-4156-8E6D-3004E4C21837}"/>
               </a:ext>
             </a:extLst>
           </p:cNvPr>
@@ -16683,7 +16683,7 @@
           <p:cNvPr id="12" name="">
             <a:extLst xmlns:a="http://schemas.openxmlformats.org/drawingml/2006/main">
               <a:ext uri="{FF2B5EF4-FFF2-40B4-BE49-F238E27FC236}">
-                <a16:creationId xmlns:a16="http://schemas.microsoft.com/office/drawing/2014/main" id="{4A21BDB4-D390-45CC-B0E3-5FCA4D74AD27}"/>
+                <a16:creationId xmlns:a16="http://schemas.microsoft.com/office/drawing/2014/main" id="{FC7D3E17-529A-4795-8990-177907FF02F7}"/>
               </a:ext>
             </a:extLst>
           </p:cNvPr>
@@ -16718,7 +16718,7 @@
           <p:cNvPr id="13" name="">
             <a:extLst xmlns:a="http://schemas.openxmlformats.org/drawingml/2006/main">
               <a:ext uri="{FF2B5EF4-FFF2-40B4-BE49-F238E27FC236}">
-                <a16:creationId xmlns:a16="http://schemas.microsoft.com/office/drawing/2014/main" id="{9767ABE8-662E-4D68-9AB5-3EF17B7F2517}"/>
+                <a16:creationId xmlns:a16="http://schemas.microsoft.com/office/drawing/2014/main" id="{A6FDB476-14BF-43AD-AB5D-27C65971A351}"/>
               </a:ext>
             </a:extLst>
           </p:cNvPr>
@@ -16749,7 +16749,7 @@
           <p:cNvPr id="14" name="">
             <a:extLst xmlns:a="http://schemas.openxmlformats.org/drawingml/2006/main">
               <a:ext uri="{FF2B5EF4-FFF2-40B4-BE49-F238E27FC236}">
-                <a16:creationId xmlns:a16="http://schemas.microsoft.com/office/drawing/2014/main" id="{84C67CDC-B8F9-4B9B-917B-6B00849D3015}"/>
+                <a16:creationId xmlns:a16="http://schemas.microsoft.com/office/drawing/2014/main" id="{8235AB8E-0D30-4A4B-B6B8-B4C888DA9C61}"/>
               </a:ext>
             </a:extLst>
           </p:cNvPr>
@@ -16794,7 +16794,7 @@
           <p:cNvPr id="15" name="">
             <a:extLst xmlns:a="http://schemas.openxmlformats.org/drawingml/2006/main">
               <a:ext uri="{FF2B5EF4-FFF2-40B4-BE49-F238E27FC236}">
-                <a16:creationId xmlns:a16="http://schemas.microsoft.com/office/drawing/2014/main" id="{760794F6-1B6B-45E2-9408-E8A1A545F51B}"/>
+                <a16:creationId xmlns:a16="http://schemas.microsoft.com/office/drawing/2014/main" id="{2861B87A-3E2F-43DB-B8AB-A604FA7D4503}"/>
               </a:ext>
             </a:extLst>
           </p:cNvPr>
@@ -16839,7 +16839,7 @@
           <p:cNvPr id="16" name="">
             <a:extLst xmlns:a="http://schemas.openxmlformats.org/drawingml/2006/main">
               <a:ext uri="{FF2B5EF4-FFF2-40B4-BE49-F238E27FC236}">
-                <a16:creationId xmlns:a16="http://schemas.microsoft.com/office/drawing/2014/main" id="{A8DBF094-A84C-4760-8CD4-0D826ADCDC87}"/>
+                <a16:creationId xmlns:a16="http://schemas.microsoft.com/office/drawing/2014/main" id="{356CDDE7-6470-4BBD-805F-06F1C80BFA81}"/>
               </a:ext>
             </a:extLst>
           </p:cNvPr>
@@ -16874,7 +16874,7 @@
           <p:cNvPr id="17" name="">
             <a:extLst xmlns:a="http://schemas.openxmlformats.org/drawingml/2006/main">
               <a:ext uri="{FF2B5EF4-FFF2-40B4-BE49-F238E27FC236}">
-                <a16:creationId xmlns:a16="http://schemas.microsoft.com/office/drawing/2014/main" id="{FD271A94-E7CE-4992-A880-C1ED03782577}"/>
+                <a16:creationId xmlns:a16="http://schemas.microsoft.com/office/drawing/2014/main" id="{AEDECFA3-A7A0-430E-BD24-7086F07B3193}"/>
               </a:ext>
             </a:extLst>
           </p:cNvPr>
@@ -16905,7 +16905,7 @@
           <p:cNvPr id="18" name="">
             <a:extLst xmlns:a="http://schemas.openxmlformats.org/drawingml/2006/main">
               <a:ext uri="{FF2B5EF4-FFF2-40B4-BE49-F238E27FC236}">
-                <a16:creationId xmlns:a16="http://schemas.microsoft.com/office/drawing/2014/main" id="{8D722D44-8F8A-410D-A2F7-83075785808F}"/>
+                <a16:creationId xmlns:a16="http://schemas.microsoft.com/office/drawing/2014/main" id="{8F5BFF75-08C8-40AF-88E4-63C1E4300D84}"/>
               </a:ext>
             </a:extLst>
           </p:cNvPr>
@@ -16950,7 +16950,7 @@
           <p:cNvPr id="19" name="">
             <a:extLst xmlns:a="http://schemas.openxmlformats.org/drawingml/2006/main">
               <a:ext uri="{FF2B5EF4-FFF2-40B4-BE49-F238E27FC236}">
-                <a16:creationId xmlns:a16="http://schemas.microsoft.com/office/drawing/2014/main" id="{0047282B-FE51-4E52-859C-90036C6A7C5B}"/>
+                <a16:creationId xmlns:a16="http://schemas.microsoft.com/office/drawing/2014/main" id="{AA34BB88-B6C6-44B2-9893-42702652878A}"/>
               </a:ext>
             </a:extLst>
           </p:cNvPr>
@@ -16995,7 +16995,7 @@
           <p:cNvPr id="20" name="">
             <a:extLst xmlns:a="http://schemas.openxmlformats.org/drawingml/2006/main">
               <a:ext uri="{FF2B5EF4-FFF2-40B4-BE49-F238E27FC236}">
-                <a16:creationId xmlns:a16="http://schemas.microsoft.com/office/drawing/2014/main" id="{3B6589D3-D451-4128-A582-8B17F42545CB}"/>
+                <a16:creationId xmlns:a16="http://schemas.microsoft.com/office/drawing/2014/main" id="{9E1235BC-6E83-40DC-BE05-6EE7A3AE1C85}"/>
               </a:ext>
             </a:extLst>
           </p:cNvPr>
@@ -17026,7 +17026,7 @@
           <p:cNvPr id="21" name="">
             <a:extLst xmlns:a="http://schemas.openxmlformats.org/drawingml/2006/main">
               <a:ext uri="{FF2B5EF4-FFF2-40B4-BE49-F238E27FC236}">
-                <a16:creationId xmlns:a16="http://schemas.microsoft.com/office/drawing/2014/main" id="{7A00EB60-EF48-4E80-B994-716C90E70E54}"/>
+                <a16:creationId xmlns:a16="http://schemas.microsoft.com/office/drawing/2014/main" id="{310F4031-71BB-41C6-8B7D-FA525C7E8BB0}"/>
               </a:ext>
             </a:extLst>
           </p:cNvPr>
@@ -17057,7 +17057,7 @@
           <p:cNvPr id="22" name="">
             <a:extLst xmlns:a="http://schemas.openxmlformats.org/drawingml/2006/main">
               <a:ext uri="{FF2B5EF4-FFF2-40B4-BE49-F238E27FC236}">
-                <a16:creationId xmlns:a16="http://schemas.microsoft.com/office/drawing/2014/main" id="{F287A293-B08B-4CE2-AAC8-93C46C713C4A}"/>
+                <a16:creationId xmlns:a16="http://schemas.microsoft.com/office/drawing/2014/main" id="{A6D0558B-D838-4483-A868-4A0157E74F6A}"/>
               </a:ext>
             </a:extLst>
           </p:cNvPr>
@@ -17102,7 +17102,7 @@
           <p:cNvPr id="23" name="">
             <a:extLst xmlns:a="http://schemas.openxmlformats.org/drawingml/2006/main">
               <a:ext uri="{FF2B5EF4-FFF2-40B4-BE49-F238E27FC236}">
-                <a16:creationId xmlns:a16="http://schemas.microsoft.com/office/drawing/2014/main" id="{10007E85-7B62-40AE-AB2E-005A628B0CEE}"/>
+                <a16:creationId xmlns:a16="http://schemas.microsoft.com/office/drawing/2014/main" id="{0ED3AB22-1231-4DA3-9325-F672924EBDE0}"/>
               </a:ext>
             </a:extLst>
           </p:cNvPr>
@@ -17145,7 +17145,7 @@
     </p:spTree>
     <p:extLst>
       <p:ext uri="{BB962C8B-B14F-4D97-AF65-F5344CB8AC3E}">
-        <p14:creationId xmlns:p14="http://schemas.microsoft.com/office/powerpoint/2010/main" val="596461240"/>
+        <p14:creationId xmlns:p14="http://schemas.microsoft.com/office/powerpoint/2010/main" val="1955686336"/>
       </p:ext>
     </p:extLst>
   </p:cSld>

</xml_diff>